<commit_message>
added parts of no silver bullet to lecture1
</commit_message>
<xml_diff>
--- a/slides/Lecture1.pptx
+++ b/slides/Lecture1.pptx
@@ -5,7 +5,7 @@
     <p:sldMasterId id="2147483648" r:id="rId1"/>
   </p:sldMasterIdLst>
   <p:notesMasterIdLst>
-    <p:notesMasterId r:id="rId38"/>
+    <p:notesMasterId r:id="rId44"/>
   </p:notesMasterIdLst>
   <p:sldIdLst>
     <p:sldId id="256" r:id="rId2"/>
@@ -38,12 +38,18 @@
     <p:sldId id="293" r:id="rId29"/>
     <p:sldId id="294" r:id="rId30"/>
     <p:sldId id="295" r:id="rId31"/>
-    <p:sldId id="289" r:id="rId32"/>
-    <p:sldId id="284" r:id="rId33"/>
-    <p:sldId id="271" r:id="rId34"/>
-    <p:sldId id="272" r:id="rId35"/>
-    <p:sldId id="273" r:id="rId36"/>
-    <p:sldId id="274" r:id="rId37"/>
+    <p:sldId id="296" r:id="rId32"/>
+    <p:sldId id="297" r:id="rId33"/>
+    <p:sldId id="298" r:id="rId34"/>
+    <p:sldId id="300" r:id="rId35"/>
+    <p:sldId id="301" r:id="rId36"/>
+    <p:sldId id="303" r:id="rId37"/>
+    <p:sldId id="289" r:id="rId38"/>
+    <p:sldId id="284" r:id="rId39"/>
+    <p:sldId id="271" r:id="rId40"/>
+    <p:sldId id="272" r:id="rId41"/>
+    <p:sldId id="273" r:id="rId42"/>
+    <p:sldId id="274" r:id="rId43"/>
   </p:sldIdLst>
   <p:sldSz cx="12192000" cy="6858000"/>
   <p:notesSz cx="6858000" cy="9144000"/>
@@ -232,7 +238,7 @@
           <a:p>
             <a:fld id="{E87D854A-D757-5C4C-A465-3201C554EB8D}" type="datetimeFigureOut">
               <a:rPr lang="en-US" smtClean="0"/>
-              <a:t>8/8/25</a:t>
+              <a:t>8/10/25</a:t>
             </a:fld>
             <a:endParaRPr lang="en-US"/>
           </a:p>
@@ -1069,7 +1075,7 @@
           <a:p>
             <a:fld id="{F1276487-8B75-2F43-9355-4B467BD57A6C}" type="datetime1">
               <a:rPr lang="en-US" smtClean="0"/>
-              <a:t>8/8/25</a:t>
+              <a:t>8/10/25</a:t>
             </a:fld>
             <a:endParaRPr lang="en-US"/>
           </a:p>
@@ -1275,7 +1281,7 @@
           <a:p>
             <a:fld id="{30B10427-957C-524C-8454-F629CBA9C9BE}" type="datetime1">
               <a:rPr lang="en-US" smtClean="0"/>
-              <a:t>8/8/25</a:t>
+              <a:t>8/10/25</a:t>
             </a:fld>
             <a:endParaRPr lang="en-US"/>
           </a:p>
@@ -1491,7 +1497,7 @@
           <a:p>
             <a:fld id="{4B97C5AB-4FB5-3149-A6CF-D0F885A81EBA}" type="datetime1">
               <a:rPr lang="en-US" smtClean="0"/>
-              <a:t>8/8/25</a:t>
+              <a:t>8/10/25</a:t>
             </a:fld>
             <a:endParaRPr lang="en-US"/>
           </a:p>
@@ -1697,7 +1703,7 @@
           <a:p>
             <a:fld id="{8D8F5D7A-DAAE-D246-A661-ED1AD3964955}" type="datetime1">
               <a:rPr lang="en-US" smtClean="0"/>
-              <a:t>8/8/25</a:t>
+              <a:t>8/10/25</a:t>
             </a:fld>
             <a:endParaRPr lang="en-US"/>
           </a:p>
@@ -1980,7 +1986,7 @@
           <a:p>
             <a:fld id="{801806B9-6C4B-3B45-9110-CA58C108BE01}" type="datetime1">
               <a:rPr lang="en-US" smtClean="0"/>
-              <a:t>8/8/25</a:t>
+              <a:t>8/10/25</a:t>
             </a:fld>
             <a:endParaRPr lang="en-US"/>
           </a:p>
@@ -2253,7 +2259,7 @@
           <a:p>
             <a:fld id="{025C6FEA-FDE7-B240-BEAF-6A3F6212E36E}" type="datetime1">
               <a:rPr lang="en-US" smtClean="0"/>
-              <a:t>8/8/25</a:t>
+              <a:t>8/10/25</a:t>
             </a:fld>
             <a:endParaRPr lang="en-US"/>
           </a:p>
@@ -2673,7 +2679,7 @@
           <a:p>
             <a:fld id="{895F5DD0-F679-3747-91F3-9DC9C3F86CB6}" type="datetime1">
               <a:rPr lang="en-US" smtClean="0"/>
-              <a:t>8/8/25</a:t>
+              <a:t>8/10/25</a:t>
             </a:fld>
             <a:endParaRPr lang="en-US"/>
           </a:p>
@@ -2822,7 +2828,7 @@
           <a:p>
             <a:fld id="{9EDA3FF8-7A34-ED49-AA5D-BC76DF58E74E}" type="datetime1">
               <a:rPr lang="en-US" smtClean="0"/>
-              <a:t>8/8/25</a:t>
+              <a:t>8/10/25</a:t>
             </a:fld>
             <a:endParaRPr lang="en-US"/>
           </a:p>
@@ -2943,7 +2949,7 @@
           <a:p>
             <a:fld id="{182A1C80-5B2D-564F-B8C6-B0B5B92F5809}" type="datetime1">
               <a:rPr lang="en-US" smtClean="0"/>
-              <a:t>8/8/25</a:t>
+              <a:t>8/10/25</a:t>
             </a:fld>
             <a:endParaRPr lang="en-US"/>
           </a:p>
@@ -3262,7 +3268,7 @@
           <a:p>
             <a:fld id="{65F75D97-7D6D-EC47-8250-30DF936063AD}" type="datetime1">
               <a:rPr lang="en-US" smtClean="0"/>
-              <a:t>8/8/25</a:t>
+              <a:t>8/10/25</a:t>
             </a:fld>
             <a:endParaRPr lang="en-US"/>
           </a:p>
@@ -3558,7 +3564,7 @@
           <a:p>
             <a:fld id="{D2E89D4A-5528-5F41-9AF6-6B3105C8A7C3}" type="datetime1">
               <a:rPr lang="en-US" smtClean="0"/>
-              <a:t>8/8/25</a:t>
+              <a:t>8/10/25</a:t>
             </a:fld>
             <a:endParaRPr lang="en-US"/>
           </a:p>
@@ -3799,7 +3805,7 @@
           <a:p>
             <a:fld id="{86344417-86B7-E841-9AA9-C4BE48872EF5}" type="datetime1">
               <a:rPr lang="en-US" smtClean="0"/>
-              <a:t>8/8/25</a:t>
+              <a:t>8/10/25</a:t>
             </a:fld>
             <a:endParaRPr lang="en-US"/>
           </a:p>
@@ -8719,9 +8725,18 @@
             </a:r>
           </a:p>
           <a:p>
-            <a:r>
-              <a:rPr lang="en-US" dirty="0"/>
-              <a:t>Slides are adapted from CSCI 5828 by Prof. Kenneth Anderson.</a:t>
+            <a:endParaRPr lang="en-US" dirty="0"/>
+          </a:p>
+          <a:p>
+            <a:endParaRPr lang="en-US" dirty="0"/>
+          </a:p>
+          <a:p>
+            <a:pPr marL="0" indent="0">
+              <a:buNone/>
+            </a:pPr>
+            <a:r>
+              <a:rPr lang="en-US" dirty="0"/>
+              <a:t>Acknowledgement: slides are inspired by Prof. Kenneth Anderson.</a:t>
             </a:r>
           </a:p>
           <a:p>
@@ -8820,7 +8835,7 @@
           <p:cNvPr id="2" name="Title 1">
             <a:extLst>
               <a:ext uri="{FF2B5EF4-FFF2-40B4-BE49-F238E27FC236}">
-                <a16:creationId xmlns:a16="http://schemas.microsoft.com/office/drawing/2014/main" id="{1351CCE4-A17A-54C7-791C-5EC433B09661}"/>
+                <a16:creationId xmlns:a16="http://schemas.microsoft.com/office/drawing/2014/main" id="{E269875F-9BB7-898F-C153-42CD7A1DE9AA}"/>
               </a:ext>
             </a:extLst>
           </p:cNvPr>
@@ -8838,7 +8853,7 @@
           <a:p>
             <a:r>
               <a:rPr lang="en-US" dirty="0"/>
-              <a:t>Backup slides</a:t>
+              <a:t>No Silver Bullet</a:t>
             </a:r>
           </a:p>
         </p:txBody>
@@ -8848,7 +8863,7 @@
           <p:cNvPr id="3" name="Content Placeholder 2">
             <a:extLst>
               <a:ext uri="{FF2B5EF4-FFF2-40B4-BE49-F238E27FC236}">
-                <a16:creationId xmlns:a16="http://schemas.microsoft.com/office/drawing/2014/main" id="{DE136F43-A2D1-0ED3-CA49-35D8DE89FC44}"/>
+                <a16:creationId xmlns:a16="http://schemas.microsoft.com/office/drawing/2014/main" id="{D00384A3-C10F-EDC9-5050-1CAC1879C5A8}"/>
               </a:ext>
             </a:extLst>
           </p:cNvPr>
@@ -8859,12 +8874,54 @@
             <p:ph idx="1"/>
           </p:nvPr>
         </p:nvSpPr>
-        <p:spPr/>
-        <p:txBody>
-          <a:bodyPr/>
-          <a:lstStyle/>
-          <a:p>
-            <a:endParaRPr lang="en-US"/>
+        <p:spPr>
+          <a:xfrm>
+            <a:off x="838200" y="1825625"/>
+            <a:ext cx="10586884" cy="4351338"/>
+          </a:xfrm>
+        </p:spPr>
+        <p:txBody>
+          <a:bodyPr/>
+          <a:lstStyle/>
+          <a:p>
+            <a:pPr marL="0" indent="0">
+              <a:buNone/>
+            </a:pPr>
+            <a:r>
+              <a:rPr lang="en-US" dirty="0"/>
+              <a:t>“There is no single development, in either technology or management technique, which by itself promises even one order-of-magnitude improvement within a decade in productivity, in reliability, in simplicity.”</a:t>
+            </a:r>
+          </a:p>
+          <a:p>
+            <a:pPr marL="0" indent="0">
+              <a:buNone/>
+            </a:pPr>
+            <a:endParaRPr lang="en-US" dirty="0"/>
+          </a:p>
+          <a:p>
+            <a:pPr marL="0" indent="0">
+              <a:buNone/>
+            </a:pPr>
+            <a:r>
+              <a:rPr lang="en-US" dirty="0"/>
+              <a:t>---- Fred Brooks, 1986</a:t>
+            </a:r>
+          </a:p>
+          <a:p>
+            <a:pPr>
+              <a:buFont typeface="Wingdings" pitchFamily="2" charset="2"/>
+              <a:buChar char="n"/>
+            </a:pPr>
+            <a:endParaRPr lang="en-US" dirty="0"/>
+          </a:p>
+          <a:p>
+            <a:pPr marL="0" indent="0">
+              <a:buNone/>
+            </a:pPr>
+            <a:r>
+              <a:rPr lang="en-US" dirty="0"/>
+              <a:t>i.e. There is no magical cure for the “software crisis”</a:t>
+            </a:r>
           </a:p>
         </p:txBody>
       </p:sp>
@@ -8873,7 +8930,7 @@
           <p:cNvPr id="4" name="Slide Number Placeholder 3">
             <a:extLst>
               <a:ext uri="{FF2B5EF4-FFF2-40B4-BE49-F238E27FC236}">
-                <a16:creationId xmlns:a16="http://schemas.microsoft.com/office/drawing/2014/main" id="{EA9A51AD-DAB4-490B-61FD-4BAD314648C2}"/>
+                <a16:creationId xmlns:a16="http://schemas.microsoft.com/office/drawing/2014/main" id="{F97FAC74-EE87-48F1-E4E5-1B9D123B62A2}"/>
               </a:ext>
             </a:extLst>
           </p:cNvPr>
@@ -8900,7 +8957,7 @@
     </p:spTree>
     <p:extLst>
       <p:ext uri="{BB962C8B-B14F-4D97-AF65-F5344CB8AC3E}">
-        <p14:creationId xmlns:p14="http://schemas.microsoft.com/office/powerpoint/2010/main" val="4309861"/>
+        <p14:creationId xmlns:p14="http://schemas.microsoft.com/office/powerpoint/2010/main" val="3321343231"/>
       </p:ext>
     </p:extLst>
   </p:cSld>
@@ -8932,6 +8989,906 @@
           <p:cNvPr id="2" name="Title 1">
             <a:extLst>
               <a:ext uri="{FF2B5EF4-FFF2-40B4-BE49-F238E27FC236}">
+                <a16:creationId xmlns:a16="http://schemas.microsoft.com/office/drawing/2014/main" id="{591E2F4F-3E0C-6C26-CD1D-26690D7B382A}"/>
+              </a:ext>
+            </a:extLst>
+          </p:cNvPr>
+          <p:cNvSpPr>
+            <a:spLocks noGrp="1"/>
+          </p:cNvSpPr>
+          <p:nvPr>
+            <p:ph type="title"/>
+          </p:nvPr>
+        </p:nvSpPr>
+        <p:spPr/>
+        <p:txBody>
+          <a:bodyPr/>
+          <a:lstStyle/>
+          <a:p>
+            <a:r>
+              <a:rPr lang="en-US" dirty="0"/>
+              <a:t>Why? Essence and Accidents</a:t>
+            </a:r>
+          </a:p>
+        </p:txBody>
+      </p:sp>
+      <p:sp>
+        <p:nvSpPr>
+          <p:cNvPr id="3" name="Content Placeholder 2">
+            <a:extLst>
+              <a:ext uri="{FF2B5EF4-FFF2-40B4-BE49-F238E27FC236}">
+                <a16:creationId xmlns:a16="http://schemas.microsoft.com/office/drawing/2014/main" id="{D9364D6B-A862-B5D6-6509-E2320CECE7FE}"/>
+              </a:ext>
+            </a:extLst>
+          </p:cNvPr>
+          <p:cNvSpPr>
+            <a:spLocks noGrp="1"/>
+          </p:cNvSpPr>
+          <p:nvPr>
+            <p:ph idx="1"/>
+          </p:nvPr>
+        </p:nvSpPr>
+        <p:spPr/>
+        <p:txBody>
+          <a:bodyPr/>
+          <a:lstStyle/>
+          <a:p>
+            <a:r>
+              <a:rPr lang="en-US" dirty="0"/>
+              <a:t>Brooks divides the problems facing software engineering into two categories</a:t>
+            </a:r>
+          </a:p>
+          <a:p>
+            <a:pPr lvl="1"/>
+            <a:r>
+              <a:rPr lang="en-US" b="1" dirty="0"/>
+              <a:t>Essence</a:t>
+            </a:r>
+            <a:r>
+              <a:rPr lang="en-US" dirty="0"/>
+              <a:t>: difficulties inherent in the nature of software</a:t>
+            </a:r>
+          </a:p>
+          <a:p>
+            <a:pPr lvl="1"/>
+            <a:r>
+              <a:rPr lang="en-US" b="1" dirty="0"/>
+              <a:t>Accidents</a:t>
+            </a:r>
+            <a:r>
+              <a:rPr lang="en-US" dirty="0"/>
+              <a:t>: difficulties related to the production of software</a:t>
+            </a:r>
+          </a:p>
+          <a:p>
+            <a:r>
+              <a:rPr lang="en-US" dirty="0"/>
+              <a:t>Brooks argues that most techniques attack the accidents of software engineering</a:t>
+            </a:r>
+          </a:p>
+        </p:txBody>
+      </p:sp>
+      <p:sp>
+        <p:nvSpPr>
+          <p:cNvPr id="4" name="Slide Number Placeholder 3">
+            <a:extLst>
+              <a:ext uri="{FF2B5EF4-FFF2-40B4-BE49-F238E27FC236}">
+                <a16:creationId xmlns:a16="http://schemas.microsoft.com/office/drawing/2014/main" id="{45BFFC80-0C92-A779-0DDD-973AD920686A}"/>
+              </a:ext>
+            </a:extLst>
+          </p:cNvPr>
+          <p:cNvSpPr>
+            <a:spLocks noGrp="1"/>
+          </p:cNvSpPr>
+          <p:nvPr>
+            <p:ph type="sldNum" sz="quarter" idx="12"/>
+          </p:nvPr>
+        </p:nvSpPr>
+        <p:spPr/>
+        <p:txBody>
+          <a:bodyPr/>
+          <a:lstStyle/>
+          <a:p>
+            <a:fld id="{3AB30462-0FD5-604F-8C98-DCC91BE84583}" type="slidenum">
+              <a:rPr lang="en-US" smtClean="0"/>
+              <a:t>32</a:t>
+            </a:fld>
+            <a:endParaRPr lang="en-US"/>
+          </a:p>
+        </p:txBody>
+      </p:sp>
+    </p:spTree>
+    <p:extLst>
+      <p:ext uri="{BB962C8B-B14F-4D97-AF65-F5344CB8AC3E}">
+        <p14:creationId xmlns:p14="http://schemas.microsoft.com/office/powerpoint/2010/main" val="136927100"/>
+      </p:ext>
+    </p:extLst>
+  </p:cSld>
+  <p:clrMapOvr>
+    <a:masterClrMapping/>
+  </p:clrMapOvr>
+</p:sld>
+</file>
+
+<file path=ppt/slides/slide33.xml><?xml version="1.0" encoding="utf-8"?>
+<p:sld xmlns:a="http://schemas.openxmlformats.org/drawingml/2006/main" xmlns:r="http://schemas.openxmlformats.org/officeDocument/2006/relationships" xmlns:p="http://schemas.openxmlformats.org/presentationml/2006/main">
+  <p:cSld>
+    <p:spTree>
+      <p:nvGrpSpPr>
+        <p:cNvPr id="1" name=""/>
+        <p:cNvGrpSpPr/>
+        <p:nvPr/>
+      </p:nvGrpSpPr>
+      <p:grpSpPr>
+        <a:xfrm>
+          <a:off x="0" y="0"/>
+          <a:ext cx="0" cy="0"/>
+          <a:chOff x="0" y="0"/>
+          <a:chExt cx="0" cy="0"/>
+        </a:xfrm>
+      </p:grpSpPr>
+      <p:sp>
+        <p:nvSpPr>
+          <p:cNvPr id="2" name="Title 1">
+            <a:extLst>
+              <a:ext uri="{FF2B5EF4-FFF2-40B4-BE49-F238E27FC236}">
+                <a16:creationId xmlns:a16="http://schemas.microsoft.com/office/drawing/2014/main" id="{DF0D2778-54F1-7A29-5481-F6A1A67120A7}"/>
+              </a:ext>
+            </a:extLst>
+          </p:cNvPr>
+          <p:cNvSpPr>
+            <a:spLocks noGrp="1"/>
+          </p:cNvSpPr>
+          <p:nvPr>
+            <p:ph type="title"/>
+          </p:nvPr>
+        </p:nvSpPr>
+        <p:spPr/>
+        <p:txBody>
+          <a:bodyPr/>
+          <a:lstStyle/>
+          <a:p>
+            <a:r>
+              <a:rPr lang="en-US" dirty="0"/>
+              <a:t>The Four Essential Difficulties</a:t>
+            </a:r>
+          </a:p>
+        </p:txBody>
+      </p:sp>
+      <p:sp>
+        <p:nvSpPr>
+          <p:cNvPr id="3" name="Content Placeholder 2">
+            <a:extLst>
+              <a:ext uri="{FF2B5EF4-FFF2-40B4-BE49-F238E27FC236}">
+                <a16:creationId xmlns:a16="http://schemas.microsoft.com/office/drawing/2014/main" id="{9E62E67D-9522-3EBE-B45D-18639062B65F}"/>
+              </a:ext>
+            </a:extLst>
+          </p:cNvPr>
+          <p:cNvSpPr>
+            <a:spLocks noGrp="1"/>
+          </p:cNvSpPr>
+          <p:nvPr>
+            <p:ph idx="1"/>
+          </p:nvPr>
+        </p:nvSpPr>
+        <p:spPr/>
+        <p:txBody>
+          <a:bodyPr/>
+          <a:lstStyle/>
+          <a:p>
+            <a:pPr marL="0" indent="0">
+              <a:buNone/>
+            </a:pPr>
+            <a:r>
+              <a:rPr lang="en-US" dirty="0"/>
+              <a:t>Why Software is Inherently Hard?</a:t>
+            </a:r>
+          </a:p>
+          <a:p>
+            <a:pPr marL="0" indent="0">
+              <a:buNone/>
+            </a:pPr>
+            <a:endParaRPr lang="en-US" dirty="0"/>
+          </a:p>
+          <a:p>
+            <a:r>
+              <a:rPr lang="en-US" b="1" dirty="0"/>
+              <a:t>Complexity</a:t>
+            </a:r>
+            <a:r>
+              <a:rPr lang="en-US" dirty="0"/>
+              <a:t>: Software systems are more complex than other human constructs; no two parts are alike.</a:t>
+            </a:r>
+          </a:p>
+          <a:p>
+            <a:r>
+              <a:rPr lang="en-US" b="1" dirty="0"/>
+              <a:t>Conformity</a:t>
+            </a:r>
+            <a:r>
+              <a:rPr lang="en-US" dirty="0"/>
+              <a:t>: Software must conform to a variety of human institutions and systems.</a:t>
+            </a:r>
+          </a:p>
+          <a:p>
+            <a:r>
+              <a:rPr lang="en-US" b="1" dirty="0"/>
+              <a:t>Changeability</a:t>
+            </a:r>
+            <a:r>
+              <a:rPr lang="en-US" dirty="0"/>
+              <a:t>: Software is constantly under pressure to change to meet new demands.</a:t>
+            </a:r>
+          </a:p>
+          <a:p>
+            <a:r>
+              <a:rPr lang="en-US" b="1" dirty="0"/>
+              <a:t>Invisibility</a:t>
+            </a:r>
+            <a:r>
+              <a:rPr lang="en-US" dirty="0"/>
+              <a:t>: Software is an abstract construct; it's hard to visualize.</a:t>
+            </a:r>
+          </a:p>
+        </p:txBody>
+      </p:sp>
+      <p:sp>
+        <p:nvSpPr>
+          <p:cNvPr id="4" name="Slide Number Placeholder 3">
+            <a:extLst>
+              <a:ext uri="{FF2B5EF4-FFF2-40B4-BE49-F238E27FC236}">
+                <a16:creationId xmlns:a16="http://schemas.microsoft.com/office/drawing/2014/main" id="{728633FF-6B7D-76EB-B7F2-146E0F752330}"/>
+              </a:ext>
+            </a:extLst>
+          </p:cNvPr>
+          <p:cNvSpPr>
+            <a:spLocks noGrp="1"/>
+          </p:cNvSpPr>
+          <p:nvPr>
+            <p:ph type="sldNum" sz="quarter" idx="12"/>
+          </p:nvPr>
+        </p:nvSpPr>
+        <p:spPr/>
+        <p:txBody>
+          <a:bodyPr/>
+          <a:lstStyle/>
+          <a:p>
+            <a:fld id="{3AB30462-0FD5-604F-8C98-DCC91BE84583}" type="slidenum">
+              <a:rPr lang="en-US" smtClean="0"/>
+              <a:t>33</a:t>
+            </a:fld>
+            <a:endParaRPr lang="en-US"/>
+          </a:p>
+        </p:txBody>
+      </p:sp>
+    </p:spTree>
+    <p:extLst>
+      <p:ext uri="{BB962C8B-B14F-4D97-AF65-F5344CB8AC3E}">
+        <p14:creationId xmlns:p14="http://schemas.microsoft.com/office/powerpoint/2010/main" val="1885371618"/>
+      </p:ext>
+    </p:extLst>
+  </p:cSld>
+  <p:clrMapOvr>
+    <a:masterClrMapping/>
+  </p:clrMapOvr>
+</p:sld>
+</file>
+
+<file path=ppt/slides/slide34.xml><?xml version="1.0" encoding="utf-8"?>
+<p:sld xmlns:a="http://schemas.openxmlformats.org/drawingml/2006/main" xmlns:r="http://schemas.openxmlformats.org/officeDocument/2006/relationships" xmlns:p="http://schemas.openxmlformats.org/presentationml/2006/main">
+  <p:cSld>
+    <p:spTree>
+      <p:nvGrpSpPr>
+        <p:cNvPr id="1" name=""/>
+        <p:cNvGrpSpPr/>
+        <p:nvPr/>
+      </p:nvGrpSpPr>
+      <p:grpSpPr>
+        <a:xfrm>
+          <a:off x="0" y="0"/>
+          <a:ext cx="0" cy="0"/>
+          <a:chOff x="0" y="0"/>
+          <a:chExt cx="0" cy="0"/>
+        </a:xfrm>
+      </p:grpSpPr>
+      <p:sp>
+        <p:nvSpPr>
+          <p:cNvPr id="2" name="Title 1">
+            <a:extLst>
+              <a:ext uri="{FF2B5EF4-FFF2-40B4-BE49-F238E27FC236}">
+                <a16:creationId xmlns:a16="http://schemas.microsoft.com/office/drawing/2014/main" id="{9B261BE8-3893-B023-55F5-A424A12572B7}"/>
+              </a:ext>
+            </a:extLst>
+          </p:cNvPr>
+          <p:cNvSpPr>
+            <a:spLocks noGrp="1"/>
+          </p:cNvSpPr>
+          <p:nvPr>
+            <p:ph type="title"/>
+          </p:nvPr>
+        </p:nvSpPr>
+        <p:spPr/>
+        <p:txBody>
+          <a:bodyPr/>
+          <a:lstStyle/>
+          <a:p>
+            <a:r>
+              <a:rPr lang="en-US" dirty="0"/>
+              <a:t>Past Solutions (The "Accidental" Gains)</a:t>
+            </a:r>
+          </a:p>
+        </p:txBody>
+      </p:sp>
+      <p:sp>
+        <p:nvSpPr>
+          <p:cNvPr id="3" name="Content Placeholder 2">
+            <a:extLst>
+              <a:ext uri="{FF2B5EF4-FFF2-40B4-BE49-F238E27FC236}">
+                <a16:creationId xmlns:a16="http://schemas.microsoft.com/office/drawing/2014/main" id="{E101E67F-7F3D-9681-331A-C4991789295D}"/>
+              </a:ext>
+            </a:extLst>
+          </p:cNvPr>
+          <p:cNvSpPr>
+            <a:spLocks noGrp="1"/>
+          </p:cNvSpPr>
+          <p:nvPr>
+            <p:ph idx="1"/>
+          </p:nvPr>
+        </p:nvSpPr>
+        <p:spPr/>
+        <p:txBody>
+          <a:bodyPr/>
+          <a:lstStyle/>
+          <a:p>
+            <a:pPr marL="0" indent="0">
+              <a:buNone/>
+            </a:pPr>
+            <a:r>
+              <a:rPr lang="en-US" dirty="0"/>
+              <a:t>Most of the big productivity gains in the past solved accidental problems.</a:t>
+            </a:r>
+          </a:p>
+          <a:p>
+            <a:pPr marL="0" indent="0">
+              <a:buNone/>
+            </a:pPr>
+            <a:endParaRPr lang="en-US" dirty="0"/>
+          </a:p>
+          <a:p>
+            <a:pPr>
+              <a:buFont typeface="Arial" panose="020B0604020202020204" pitchFamily="34" charset="0"/>
+              <a:buChar char="•"/>
+            </a:pPr>
+            <a:r>
+              <a:rPr lang="en-US" b="1" dirty="0"/>
+              <a:t>High-level languages:</a:t>
+            </a:r>
+            <a:r>
+              <a:rPr lang="en-US" dirty="0"/>
+              <a:t> Eliminated the complexity of writing machine-level code.</a:t>
+            </a:r>
+          </a:p>
+          <a:p>
+            <a:pPr>
+              <a:buFont typeface="Arial" panose="020B0604020202020204" pitchFamily="34" charset="0"/>
+              <a:buChar char="•"/>
+            </a:pPr>
+            <a:r>
+              <a:rPr lang="en-US" b="1" dirty="0"/>
+              <a:t>Time-sharing:</a:t>
+            </a:r>
+            <a:r>
+              <a:rPr lang="en-US" dirty="0"/>
+              <a:t> Reduced slow turnaround times.</a:t>
+            </a:r>
+          </a:p>
+          <a:p>
+            <a:pPr>
+              <a:buFont typeface="Arial" panose="020B0604020202020204" pitchFamily="34" charset="0"/>
+              <a:buChar char="•"/>
+            </a:pPr>
+            <a:r>
+              <a:rPr lang="en-US" b="1" dirty="0"/>
+              <a:t>Unified programming environments:</a:t>
+            </a:r>
+            <a:r>
+              <a:rPr lang="en-US" dirty="0"/>
+              <a:t> Improved the way programs work together.</a:t>
+            </a:r>
+          </a:p>
+          <a:p>
+            <a:pPr marL="0" indent="0">
+              <a:buNone/>
+            </a:pPr>
+            <a:endParaRPr lang="en-US" dirty="0"/>
+          </a:p>
+        </p:txBody>
+      </p:sp>
+      <p:sp>
+        <p:nvSpPr>
+          <p:cNvPr id="4" name="Slide Number Placeholder 3">
+            <a:extLst>
+              <a:ext uri="{FF2B5EF4-FFF2-40B4-BE49-F238E27FC236}">
+                <a16:creationId xmlns:a16="http://schemas.microsoft.com/office/drawing/2014/main" id="{B41DAB98-3AAE-42E5-3150-DD60A12180B0}"/>
+              </a:ext>
+            </a:extLst>
+          </p:cNvPr>
+          <p:cNvSpPr>
+            <a:spLocks noGrp="1"/>
+          </p:cNvSpPr>
+          <p:nvPr>
+            <p:ph type="sldNum" sz="quarter" idx="12"/>
+          </p:nvPr>
+        </p:nvSpPr>
+        <p:spPr/>
+        <p:txBody>
+          <a:bodyPr/>
+          <a:lstStyle/>
+          <a:p>
+            <a:fld id="{3AB30462-0FD5-604F-8C98-DCC91BE84583}" type="slidenum">
+              <a:rPr lang="en-US" smtClean="0"/>
+              <a:t>34</a:t>
+            </a:fld>
+            <a:endParaRPr lang="en-US"/>
+          </a:p>
+        </p:txBody>
+      </p:sp>
+    </p:spTree>
+    <p:extLst>
+      <p:ext uri="{BB962C8B-B14F-4D97-AF65-F5344CB8AC3E}">
+        <p14:creationId xmlns:p14="http://schemas.microsoft.com/office/powerpoint/2010/main" val="579760326"/>
+      </p:ext>
+    </p:extLst>
+  </p:cSld>
+  <p:clrMapOvr>
+    <a:masterClrMapping/>
+  </p:clrMapOvr>
+</p:sld>
+</file>
+
+<file path=ppt/slides/slide35.xml><?xml version="1.0" encoding="utf-8"?>
+<p:sld xmlns:a="http://schemas.openxmlformats.org/drawingml/2006/main" xmlns:r="http://schemas.openxmlformats.org/officeDocument/2006/relationships" xmlns:p="http://schemas.openxmlformats.org/presentationml/2006/main">
+  <p:cSld>
+    <p:spTree>
+      <p:nvGrpSpPr>
+        <p:cNvPr id="1" name=""/>
+        <p:cNvGrpSpPr/>
+        <p:nvPr/>
+      </p:nvGrpSpPr>
+      <p:grpSpPr>
+        <a:xfrm>
+          <a:off x="0" y="0"/>
+          <a:ext cx="0" cy="0"/>
+          <a:chOff x="0" y="0"/>
+          <a:chExt cx="0" cy="0"/>
+        </a:xfrm>
+      </p:grpSpPr>
+      <p:sp>
+        <p:nvSpPr>
+          <p:cNvPr id="2" name="Title 1">
+            <a:extLst>
+              <a:ext uri="{FF2B5EF4-FFF2-40B4-BE49-F238E27FC236}">
+                <a16:creationId xmlns:a16="http://schemas.microsoft.com/office/drawing/2014/main" id="{1CBF31AE-A851-A9F1-84C9-7C598CD7DAAC}"/>
+              </a:ext>
+            </a:extLst>
+          </p:cNvPr>
+          <p:cNvSpPr>
+            <a:spLocks noGrp="1"/>
+          </p:cNvSpPr>
+          <p:nvPr>
+            <p:ph type="title"/>
+          </p:nvPr>
+        </p:nvSpPr>
+        <p:spPr/>
+        <p:txBody>
+          <a:bodyPr/>
+          <a:lstStyle/>
+          <a:p>
+            <a:r>
+              <a:rPr lang="en-US" dirty="0"/>
+              <a:t>New Hopes</a:t>
+            </a:r>
+          </a:p>
+        </p:txBody>
+      </p:sp>
+      <p:sp>
+        <p:nvSpPr>
+          <p:cNvPr id="3" name="Content Placeholder 2">
+            <a:extLst>
+              <a:ext uri="{FF2B5EF4-FFF2-40B4-BE49-F238E27FC236}">
+                <a16:creationId xmlns:a16="http://schemas.microsoft.com/office/drawing/2014/main" id="{52BC44A8-27EC-6F7D-AE00-B1D2AC1A423D}"/>
+              </a:ext>
+            </a:extLst>
+          </p:cNvPr>
+          <p:cNvSpPr>
+            <a:spLocks noGrp="1"/>
+          </p:cNvSpPr>
+          <p:nvPr>
+            <p:ph idx="1"/>
+          </p:nvPr>
+        </p:nvSpPr>
+        <p:spPr/>
+        <p:txBody>
+          <a:bodyPr/>
+          <a:lstStyle/>
+          <a:p>
+            <a:r>
+              <a:rPr lang="en-US" dirty="0"/>
+              <a:t>Ada</a:t>
+            </a:r>
+          </a:p>
+          <a:p>
+            <a:pPr lvl="1"/>
+            <a:r>
+              <a:rPr lang="en-US" dirty="0"/>
+              <a:t>Main contribution is its philosophy, instead of language features</a:t>
+            </a:r>
+          </a:p>
+          <a:p>
+            <a:r>
+              <a:rPr lang="en-US" dirty="0"/>
+              <a:t>Object-Oriented programming</a:t>
+            </a:r>
+          </a:p>
+          <a:p>
+            <a:pPr lvl="1"/>
+            <a:endParaRPr lang="en-US" dirty="0"/>
+          </a:p>
+          <a:p>
+            <a:r>
+              <a:rPr lang="en-US" dirty="0"/>
+              <a:t>AI</a:t>
+            </a:r>
+          </a:p>
+          <a:p>
+            <a:endParaRPr lang="en-US" dirty="0"/>
+          </a:p>
+          <a:p>
+            <a:r>
+              <a:rPr lang="en-US" dirty="0"/>
+              <a:t>Automated programming</a:t>
+            </a:r>
+          </a:p>
+          <a:p>
+            <a:endParaRPr lang="en-US" dirty="0"/>
+          </a:p>
+          <a:p>
+            <a:r>
+              <a:rPr lang="en-US" dirty="0"/>
+              <a:t>Program verification</a:t>
+            </a:r>
+          </a:p>
+        </p:txBody>
+      </p:sp>
+      <p:sp>
+        <p:nvSpPr>
+          <p:cNvPr id="4" name="Slide Number Placeholder 3">
+            <a:extLst>
+              <a:ext uri="{FF2B5EF4-FFF2-40B4-BE49-F238E27FC236}">
+                <a16:creationId xmlns:a16="http://schemas.microsoft.com/office/drawing/2014/main" id="{3F9E9420-96E9-A534-F63F-5FBAD2B88600}"/>
+              </a:ext>
+            </a:extLst>
+          </p:cNvPr>
+          <p:cNvSpPr>
+            <a:spLocks noGrp="1"/>
+          </p:cNvSpPr>
+          <p:nvPr>
+            <p:ph type="sldNum" sz="quarter" idx="12"/>
+          </p:nvPr>
+        </p:nvSpPr>
+        <p:spPr/>
+        <p:txBody>
+          <a:bodyPr/>
+          <a:lstStyle/>
+          <a:p>
+            <a:fld id="{3AB30462-0FD5-604F-8C98-DCC91BE84583}" type="slidenum">
+              <a:rPr lang="en-US" smtClean="0"/>
+              <a:t>35</a:t>
+            </a:fld>
+            <a:endParaRPr lang="en-US"/>
+          </a:p>
+        </p:txBody>
+      </p:sp>
+    </p:spTree>
+    <p:extLst>
+      <p:ext uri="{BB962C8B-B14F-4D97-AF65-F5344CB8AC3E}">
+        <p14:creationId xmlns:p14="http://schemas.microsoft.com/office/powerpoint/2010/main" val="2596271236"/>
+      </p:ext>
+    </p:extLst>
+  </p:cSld>
+  <p:clrMapOvr>
+    <a:masterClrMapping/>
+  </p:clrMapOvr>
+</p:sld>
+</file>
+
+<file path=ppt/slides/slide36.xml><?xml version="1.0" encoding="utf-8"?>
+<p:sld xmlns:a="http://schemas.openxmlformats.org/drawingml/2006/main" xmlns:r="http://schemas.openxmlformats.org/officeDocument/2006/relationships" xmlns:p="http://schemas.openxmlformats.org/presentationml/2006/main">
+  <p:cSld>
+    <p:spTree>
+      <p:nvGrpSpPr>
+        <p:cNvPr id="1" name=""/>
+        <p:cNvGrpSpPr/>
+        <p:nvPr/>
+      </p:nvGrpSpPr>
+      <p:grpSpPr>
+        <a:xfrm>
+          <a:off x="0" y="0"/>
+          <a:ext cx="0" cy="0"/>
+          <a:chOff x="0" y="0"/>
+          <a:chExt cx="0" cy="0"/>
+        </a:xfrm>
+      </p:grpSpPr>
+      <p:sp>
+        <p:nvSpPr>
+          <p:cNvPr id="2" name="Title 1">
+            <a:extLst>
+              <a:ext uri="{FF2B5EF4-FFF2-40B4-BE49-F238E27FC236}">
+                <a16:creationId xmlns:a16="http://schemas.microsoft.com/office/drawing/2014/main" id="{D57D02C6-FC30-283D-C19E-5B6D236792D3}"/>
+              </a:ext>
+            </a:extLst>
+          </p:cNvPr>
+          <p:cNvSpPr>
+            <a:spLocks noGrp="1"/>
+          </p:cNvSpPr>
+          <p:nvPr>
+            <p:ph type="title"/>
+          </p:nvPr>
+        </p:nvSpPr>
+        <p:spPr/>
+        <p:txBody>
+          <a:bodyPr/>
+          <a:lstStyle/>
+          <a:p>
+            <a:r>
+              <a:rPr lang="en-US" dirty="0" err="1"/>
+              <a:t>Brooks's</a:t>
+            </a:r>
+            <a:r>
+              <a:rPr lang="en-US" dirty="0"/>
+              <a:t> Core Recommendations</a:t>
+            </a:r>
+          </a:p>
+        </p:txBody>
+      </p:sp>
+      <p:sp>
+        <p:nvSpPr>
+          <p:cNvPr id="3" name="Content Placeholder 2">
+            <a:extLst>
+              <a:ext uri="{FF2B5EF4-FFF2-40B4-BE49-F238E27FC236}">
+                <a16:creationId xmlns:a16="http://schemas.microsoft.com/office/drawing/2014/main" id="{C0EFF6ED-1133-3903-235E-64214D771464}"/>
+              </a:ext>
+            </a:extLst>
+          </p:cNvPr>
+          <p:cNvSpPr>
+            <a:spLocks noGrp="1"/>
+          </p:cNvSpPr>
+          <p:nvPr>
+            <p:ph idx="1"/>
+          </p:nvPr>
+        </p:nvSpPr>
+        <p:spPr/>
+        <p:txBody>
+          <a:bodyPr/>
+          <a:lstStyle/>
+          <a:p>
+            <a:r>
+              <a:rPr lang="en-US" b="1" dirty="0"/>
+              <a:t>Buy vs. Build:</a:t>
+            </a:r>
+            <a:r>
+              <a:rPr lang="en-US" dirty="0"/>
+              <a:t> Exploit the mass market and avoid creating what you can buy.</a:t>
+            </a:r>
+          </a:p>
+          <a:p>
+            <a:r>
+              <a:rPr lang="en-US" b="1" dirty="0"/>
+              <a:t>Rapid Prototyping:</a:t>
+            </a:r>
+            <a:r>
+              <a:rPr lang="en-US" dirty="0"/>
+              <a:t> Use prototypes to refine requirements iteratively.</a:t>
+            </a:r>
+          </a:p>
+          <a:p>
+            <a:r>
+              <a:rPr lang="en-US" b="1" dirty="0"/>
+              <a:t>Incremental Development:</a:t>
+            </a:r>
+            <a:r>
+              <a:rPr lang="en-US" dirty="0"/>
+              <a:t> "Grow" software piece by piece, rather than trying to build it all at once.</a:t>
+            </a:r>
+          </a:p>
+          <a:p>
+            <a:r>
+              <a:rPr lang="en-US" b="1" dirty="0"/>
+              <a:t>Great Designers:</a:t>
+            </a:r>
+            <a:r>
+              <a:rPr lang="en-US" dirty="0"/>
+              <a:t> Acknowledge and nurture the exceptional people who produce great designs.</a:t>
+            </a:r>
+          </a:p>
+        </p:txBody>
+      </p:sp>
+      <p:sp>
+        <p:nvSpPr>
+          <p:cNvPr id="4" name="Slide Number Placeholder 3">
+            <a:extLst>
+              <a:ext uri="{FF2B5EF4-FFF2-40B4-BE49-F238E27FC236}">
+                <a16:creationId xmlns:a16="http://schemas.microsoft.com/office/drawing/2014/main" id="{CD163FCC-57BF-6DCB-3F71-2DC6A9C256AD}"/>
+              </a:ext>
+            </a:extLst>
+          </p:cNvPr>
+          <p:cNvSpPr>
+            <a:spLocks noGrp="1"/>
+          </p:cNvSpPr>
+          <p:nvPr>
+            <p:ph type="sldNum" sz="quarter" idx="12"/>
+          </p:nvPr>
+        </p:nvSpPr>
+        <p:spPr/>
+        <p:txBody>
+          <a:bodyPr/>
+          <a:lstStyle/>
+          <a:p>
+            <a:fld id="{3AB30462-0FD5-604F-8C98-DCC91BE84583}" type="slidenum">
+              <a:rPr lang="en-US" smtClean="0"/>
+              <a:t>36</a:t>
+            </a:fld>
+            <a:endParaRPr lang="en-US"/>
+          </a:p>
+        </p:txBody>
+      </p:sp>
+    </p:spTree>
+    <p:extLst>
+      <p:ext uri="{BB962C8B-B14F-4D97-AF65-F5344CB8AC3E}">
+        <p14:creationId xmlns:p14="http://schemas.microsoft.com/office/powerpoint/2010/main" val="1098065064"/>
+      </p:ext>
+    </p:extLst>
+  </p:cSld>
+  <p:clrMapOvr>
+    <a:masterClrMapping/>
+  </p:clrMapOvr>
+</p:sld>
+</file>
+
+<file path=ppt/slides/slide37.xml><?xml version="1.0" encoding="utf-8"?>
+<p:sld xmlns:a="http://schemas.openxmlformats.org/drawingml/2006/main" xmlns:r="http://schemas.openxmlformats.org/officeDocument/2006/relationships" xmlns:p="http://schemas.openxmlformats.org/presentationml/2006/main">
+  <p:cSld>
+    <p:spTree>
+      <p:nvGrpSpPr>
+        <p:cNvPr id="1" name=""/>
+        <p:cNvGrpSpPr/>
+        <p:nvPr/>
+      </p:nvGrpSpPr>
+      <p:grpSpPr>
+        <a:xfrm>
+          <a:off x="0" y="0"/>
+          <a:ext cx="0" cy="0"/>
+          <a:chOff x="0" y="0"/>
+          <a:chExt cx="0" cy="0"/>
+        </a:xfrm>
+      </p:grpSpPr>
+      <p:sp>
+        <p:nvSpPr>
+          <p:cNvPr id="2" name="Title 1">
+            <a:extLst>
+              <a:ext uri="{FF2B5EF4-FFF2-40B4-BE49-F238E27FC236}">
+                <a16:creationId xmlns:a16="http://schemas.microsoft.com/office/drawing/2014/main" id="{1351CCE4-A17A-54C7-791C-5EC433B09661}"/>
+              </a:ext>
+            </a:extLst>
+          </p:cNvPr>
+          <p:cNvSpPr>
+            <a:spLocks noGrp="1"/>
+          </p:cNvSpPr>
+          <p:nvPr>
+            <p:ph type="title"/>
+          </p:nvPr>
+        </p:nvSpPr>
+        <p:spPr/>
+        <p:txBody>
+          <a:bodyPr/>
+          <a:lstStyle/>
+          <a:p>
+            <a:r>
+              <a:rPr lang="en-US" dirty="0"/>
+              <a:t>Backup slides</a:t>
+            </a:r>
+          </a:p>
+        </p:txBody>
+      </p:sp>
+      <p:sp>
+        <p:nvSpPr>
+          <p:cNvPr id="3" name="Content Placeholder 2">
+            <a:extLst>
+              <a:ext uri="{FF2B5EF4-FFF2-40B4-BE49-F238E27FC236}">
+                <a16:creationId xmlns:a16="http://schemas.microsoft.com/office/drawing/2014/main" id="{DE136F43-A2D1-0ED3-CA49-35D8DE89FC44}"/>
+              </a:ext>
+            </a:extLst>
+          </p:cNvPr>
+          <p:cNvSpPr>
+            <a:spLocks noGrp="1"/>
+          </p:cNvSpPr>
+          <p:nvPr>
+            <p:ph idx="1"/>
+          </p:nvPr>
+        </p:nvSpPr>
+        <p:spPr/>
+        <p:txBody>
+          <a:bodyPr/>
+          <a:lstStyle/>
+          <a:p>
+            <a:endParaRPr lang="en-US"/>
+          </a:p>
+        </p:txBody>
+      </p:sp>
+      <p:sp>
+        <p:nvSpPr>
+          <p:cNvPr id="4" name="Slide Number Placeholder 3">
+            <a:extLst>
+              <a:ext uri="{FF2B5EF4-FFF2-40B4-BE49-F238E27FC236}">
+                <a16:creationId xmlns:a16="http://schemas.microsoft.com/office/drawing/2014/main" id="{EA9A51AD-DAB4-490B-61FD-4BAD314648C2}"/>
+              </a:ext>
+            </a:extLst>
+          </p:cNvPr>
+          <p:cNvSpPr>
+            <a:spLocks noGrp="1"/>
+          </p:cNvSpPr>
+          <p:nvPr>
+            <p:ph type="sldNum" sz="quarter" idx="12"/>
+          </p:nvPr>
+        </p:nvSpPr>
+        <p:spPr/>
+        <p:txBody>
+          <a:bodyPr/>
+          <a:lstStyle/>
+          <a:p>
+            <a:fld id="{3AB30462-0FD5-604F-8C98-DCC91BE84583}" type="slidenum">
+              <a:rPr lang="en-US" smtClean="0"/>
+              <a:t>37</a:t>
+            </a:fld>
+            <a:endParaRPr lang="en-US"/>
+          </a:p>
+        </p:txBody>
+      </p:sp>
+    </p:spTree>
+    <p:extLst>
+      <p:ext uri="{BB962C8B-B14F-4D97-AF65-F5344CB8AC3E}">
+        <p14:creationId xmlns:p14="http://schemas.microsoft.com/office/powerpoint/2010/main" val="4309861"/>
+      </p:ext>
+    </p:extLst>
+  </p:cSld>
+  <p:clrMapOvr>
+    <a:masterClrMapping/>
+  </p:clrMapOvr>
+</p:sld>
+</file>
+
+<file path=ppt/slides/slide38.xml><?xml version="1.0" encoding="utf-8"?>
+<p:sld xmlns:a="http://schemas.openxmlformats.org/drawingml/2006/main" xmlns:r="http://schemas.openxmlformats.org/officeDocument/2006/relationships" xmlns:p="http://schemas.openxmlformats.org/presentationml/2006/main">
+  <p:cSld>
+    <p:spTree>
+      <p:nvGrpSpPr>
+        <p:cNvPr id="1" name=""/>
+        <p:cNvGrpSpPr/>
+        <p:nvPr/>
+      </p:nvGrpSpPr>
+      <p:grpSpPr>
+        <a:xfrm>
+          <a:off x="0" y="0"/>
+          <a:ext cx="0" cy="0"/>
+          <a:chOff x="0" y="0"/>
+          <a:chExt cx="0" cy="0"/>
+        </a:xfrm>
+      </p:grpSpPr>
+      <p:sp>
+        <p:nvSpPr>
+          <p:cNvPr id="2" name="Title 1">
+            <a:extLst>
+              <a:ext uri="{FF2B5EF4-FFF2-40B4-BE49-F238E27FC236}">
                 <a16:creationId xmlns:a16="http://schemas.microsoft.com/office/drawing/2014/main" id="{923341A6-15AB-49BC-59E9-9FE750803B9B}"/>
               </a:ext>
             </a:extLst>
@@ -9182,7 +10139,7 @@
           <a:p>
             <a:fld id="{3AB30462-0FD5-604F-8C98-DCC91BE84583}" type="slidenum">
               <a:rPr lang="en-US" smtClean="0"/>
-              <a:t>32</a:t>
+              <a:t>38</a:t>
             </a:fld>
             <a:endParaRPr lang="en-US"/>
           </a:p>
@@ -9201,7 +10158,7 @@
 </p:sld>
 </file>
 
-<file path=ppt/slides/slide33.xml><?xml version="1.0" encoding="utf-8"?>
+<file path=ppt/slides/slide39.xml><?xml version="1.0" encoding="utf-8"?>
 <p:sld xmlns:a="http://schemas.openxmlformats.org/drawingml/2006/main" xmlns:r="http://schemas.openxmlformats.org/officeDocument/2006/relationships" xmlns:p="http://schemas.openxmlformats.org/presentationml/2006/main">
   <p:cSld>
     <p:spTree>
@@ -9311,7 +10268,7 @@
           <a:p>
             <a:fld id="{3AB30462-0FD5-604F-8C98-DCC91BE84583}" type="slidenum">
               <a:rPr lang="en-US" smtClean="0"/>
-              <a:t>33</a:t>
+              <a:t>39</a:t>
             </a:fld>
             <a:endParaRPr lang="en-US"/>
           </a:p>
@@ -9321,593 +10278,6 @@
     <p:extLst>
       <p:ext uri="{BB962C8B-B14F-4D97-AF65-F5344CB8AC3E}">
         <p14:creationId xmlns:p14="http://schemas.microsoft.com/office/powerpoint/2010/main" val="4114217993"/>
-      </p:ext>
-    </p:extLst>
-  </p:cSld>
-  <p:clrMapOvr>
-    <a:masterClrMapping/>
-  </p:clrMapOvr>
-</p:sld>
-</file>
-
-<file path=ppt/slides/slide34.xml><?xml version="1.0" encoding="utf-8"?>
-<p:sld xmlns:a="http://schemas.openxmlformats.org/drawingml/2006/main" xmlns:r="http://schemas.openxmlformats.org/officeDocument/2006/relationships" xmlns:p="http://schemas.openxmlformats.org/presentationml/2006/main">
-  <p:cSld>
-    <p:spTree>
-      <p:nvGrpSpPr>
-        <p:cNvPr id="1" name="">
-          <a:extLst>
-            <a:ext uri="{FF2B5EF4-FFF2-40B4-BE49-F238E27FC236}">
-              <a16:creationId xmlns:a16="http://schemas.microsoft.com/office/drawing/2014/main" id="{A52F73ED-EFBA-F3DF-4D3E-88108C3D1A52}"/>
-            </a:ext>
-          </a:extLst>
-        </p:cNvPr>
-        <p:cNvGrpSpPr/>
-        <p:nvPr/>
-      </p:nvGrpSpPr>
-      <p:grpSpPr>
-        <a:xfrm>
-          <a:off x="0" y="0"/>
-          <a:ext cx="0" cy="0"/>
-          <a:chOff x="0" y="0"/>
-          <a:chExt cx="0" cy="0"/>
-        </a:xfrm>
-      </p:grpSpPr>
-      <p:sp>
-        <p:nvSpPr>
-          <p:cNvPr id="2" name="Title 1">
-            <a:extLst>
-              <a:ext uri="{FF2B5EF4-FFF2-40B4-BE49-F238E27FC236}">
-                <a16:creationId xmlns:a16="http://schemas.microsoft.com/office/drawing/2014/main" id="{6FCD59A0-294B-0A15-110B-4F03E294377F}"/>
-              </a:ext>
-            </a:extLst>
-          </p:cNvPr>
-          <p:cNvSpPr>
-            <a:spLocks noGrp="1"/>
-          </p:cNvSpPr>
-          <p:nvPr>
-            <p:ph type="title"/>
-          </p:nvPr>
-        </p:nvSpPr>
-        <p:spPr/>
-        <p:txBody>
-          <a:bodyPr/>
-          <a:lstStyle/>
-          <a:p>
-            <a:r>
-              <a:rPr lang="en-US" dirty="0"/>
-              <a:t>Main course topics</a:t>
-            </a:r>
-          </a:p>
-        </p:txBody>
-      </p:sp>
-      <p:sp>
-        <p:nvSpPr>
-          <p:cNvPr id="3" name="Content Placeholder 2">
-            <a:extLst>
-              <a:ext uri="{FF2B5EF4-FFF2-40B4-BE49-F238E27FC236}">
-                <a16:creationId xmlns:a16="http://schemas.microsoft.com/office/drawing/2014/main" id="{44070496-D261-9FCC-8B1F-5DF810745D54}"/>
-              </a:ext>
-            </a:extLst>
-          </p:cNvPr>
-          <p:cNvSpPr>
-            <a:spLocks noGrp="1"/>
-          </p:cNvSpPr>
-          <p:nvPr>
-            <p:ph idx="1"/>
-          </p:nvPr>
-        </p:nvSpPr>
-        <p:spPr/>
-        <p:txBody>
-          <a:bodyPr/>
-          <a:lstStyle/>
-          <a:p>
-            <a:r>
-              <a:rPr lang="en-US" dirty="0"/>
-              <a:t>How to write </a:t>
-            </a:r>
-            <a:r>
-              <a:rPr lang="en-US" u="sng" dirty="0"/>
-              <a:t>quality</a:t>
-            </a:r>
-            <a:r>
-              <a:rPr lang="en-US" dirty="0"/>
-              <a:t> code?</a:t>
-            </a:r>
-          </a:p>
-          <a:p>
-            <a:pPr lvl="1"/>
-            <a:r>
-              <a:rPr lang="en-US" altLang="zh-CN" dirty="0"/>
-              <a:t>Usable</a:t>
-            </a:r>
-            <a:endParaRPr lang="en-US" dirty="0"/>
-          </a:p>
-          <a:p>
-            <a:pPr lvl="1"/>
-            <a:r>
-              <a:rPr lang="en-US" dirty="0"/>
-              <a:t>Less error-prone</a:t>
-            </a:r>
-          </a:p>
-          <a:p>
-            <a:pPr lvl="1"/>
-            <a:r>
-              <a:rPr lang="en-US" dirty="0"/>
-              <a:t>Easier to maintain</a:t>
-            </a:r>
-          </a:p>
-          <a:p>
-            <a:pPr lvl="1"/>
-            <a:r>
-              <a:rPr lang="en-US" dirty="0"/>
-              <a:t>Reusable</a:t>
-            </a:r>
-          </a:p>
-          <a:p>
-            <a:pPr lvl="1"/>
-            <a:r>
-              <a:rPr lang="en-US" dirty="0"/>
-              <a:t>…</a:t>
-            </a:r>
-          </a:p>
-          <a:p>
-            <a:endParaRPr lang="en-US" dirty="0"/>
-          </a:p>
-          <a:p>
-            <a:pPr lvl="1"/>
-            <a:endParaRPr lang="en-US" dirty="0"/>
-          </a:p>
-          <a:p>
-            <a:endParaRPr lang="en-US" dirty="0"/>
-          </a:p>
-          <a:p>
-            <a:endParaRPr lang="en-US" dirty="0"/>
-          </a:p>
-        </p:txBody>
-      </p:sp>
-      <p:sp>
-        <p:nvSpPr>
-          <p:cNvPr id="4" name="Slide Number Placeholder 3">
-            <a:extLst>
-              <a:ext uri="{FF2B5EF4-FFF2-40B4-BE49-F238E27FC236}">
-                <a16:creationId xmlns:a16="http://schemas.microsoft.com/office/drawing/2014/main" id="{A3F2E659-F8C4-5B1C-96ED-AA2E86EABE38}"/>
-              </a:ext>
-            </a:extLst>
-          </p:cNvPr>
-          <p:cNvSpPr>
-            <a:spLocks noGrp="1"/>
-          </p:cNvSpPr>
-          <p:nvPr>
-            <p:ph type="sldNum" sz="quarter" idx="12"/>
-          </p:nvPr>
-        </p:nvSpPr>
-        <p:spPr/>
-        <p:txBody>
-          <a:bodyPr/>
-          <a:lstStyle/>
-          <a:p>
-            <a:fld id="{3AB30462-0FD5-604F-8C98-DCC91BE84583}" type="slidenum">
-              <a:rPr lang="en-US" smtClean="0"/>
-              <a:t>34</a:t>
-            </a:fld>
-            <a:endParaRPr lang="en-US"/>
-          </a:p>
-        </p:txBody>
-      </p:sp>
-    </p:spTree>
-    <p:extLst>
-      <p:ext uri="{BB962C8B-B14F-4D97-AF65-F5344CB8AC3E}">
-        <p14:creationId xmlns:p14="http://schemas.microsoft.com/office/powerpoint/2010/main" val="3897885859"/>
-      </p:ext>
-    </p:extLst>
-  </p:cSld>
-  <p:clrMapOvr>
-    <a:masterClrMapping/>
-  </p:clrMapOvr>
-</p:sld>
-</file>
-
-<file path=ppt/slides/slide35.xml><?xml version="1.0" encoding="utf-8"?>
-<p:sld xmlns:a="http://schemas.openxmlformats.org/drawingml/2006/main" xmlns:r="http://schemas.openxmlformats.org/officeDocument/2006/relationships" xmlns:p="http://schemas.openxmlformats.org/presentationml/2006/main">
-  <p:cSld>
-    <p:spTree>
-      <p:nvGrpSpPr>
-        <p:cNvPr id="1" name="">
-          <a:extLst>
-            <a:ext uri="{FF2B5EF4-FFF2-40B4-BE49-F238E27FC236}">
-              <a16:creationId xmlns:a16="http://schemas.microsoft.com/office/drawing/2014/main" id="{BA7C86BA-5877-CC53-4DEA-AE7B11D695B3}"/>
-            </a:ext>
-          </a:extLst>
-        </p:cNvPr>
-        <p:cNvGrpSpPr/>
-        <p:nvPr/>
-      </p:nvGrpSpPr>
-      <p:grpSpPr>
-        <a:xfrm>
-          <a:off x="0" y="0"/>
-          <a:ext cx="0" cy="0"/>
-          <a:chOff x="0" y="0"/>
-          <a:chExt cx="0" cy="0"/>
-        </a:xfrm>
-      </p:grpSpPr>
-      <p:sp>
-        <p:nvSpPr>
-          <p:cNvPr id="2" name="Title 1">
-            <a:extLst>
-              <a:ext uri="{FF2B5EF4-FFF2-40B4-BE49-F238E27FC236}">
-                <a16:creationId xmlns:a16="http://schemas.microsoft.com/office/drawing/2014/main" id="{FA7855FC-A2E8-8DBE-CA4A-68FDAA8A4332}"/>
-              </a:ext>
-            </a:extLst>
-          </p:cNvPr>
-          <p:cNvSpPr>
-            <a:spLocks noGrp="1"/>
-          </p:cNvSpPr>
-          <p:nvPr>
-            <p:ph type="title"/>
-          </p:nvPr>
-        </p:nvSpPr>
-        <p:spPr/>
-        <p:txBody>
-          <a:bodyPr/>
-          <a:lstStyle/>
-          <a:p>
-            <a:r>
-              <a:rPr lang="en-US" dirty="0"/>
-              <a:t>Main course topics</a:t>
-            </a:r>
-          </a:p>
-        </p:txBody>
-      </p:sp>
-      <p:sp>
-        <p:nvSpPr>
-          <p:cNvPr id="3" name="Content Placeholder 2">
-            <a:extLst>
-              <a:ext uri="{FF2B5EF4-FFF2-40B4-BE49-F238E27FC236}">
-                <a16:creationId xmlns:a16="http://schemas.microsoft.com/office/drawing/2014/main" id="{E21D6EEC-074C-6F97-56D2-DCA3DB28292F}"/>
-              </a:ext>
-            </a:extLst>
-          </p:cNvPr>
-          <p:cNvSpPr>
-            <a:spLocks noGrp="1"/>
-          </p:cNvSpPr>
-          <p:nvPr>
-            <p:ph idx="1"/>
-          </p:nvPr>
-        </p:nvSpPr>
-        <p:spPr/>
-        <p:txBody>
-          <a:bodyPr/>
-          <a:lstStyle/>
-          <a:p>
-            <a:r>
-              <a:rPr lang="en-US" dirty="0"/>
-              <a:t>How to write </a:t>
-            </a:r>
-            <a:r>
-              <a:rPr lang="en-US" u="sng" dirty="0"/>
-              <a:t>quality</a:t>
-            </a:r>
-            <a:r>
-              <a:rPr lang="en-US" dirty="0"/>
-              <a:t> code?</a:t>
-            </a:r>
-          </a:p>
-          <a:p>
-            <a:pPr lvl="1"/>
-            <a:r>
-              <a:rPr lang="en-US" altLang="zh-CN" dirty="0"/>
-              <a:t>Usable</a:t>
-            </a:r>
-            <a:endParaRPr lang="en-US" dirty="0"/>
-          </a:p>
-          <a:p>
-            <a:pPr lvl="1"/>
-            <a:r>
-              <a:rPr lang="en-US" dirty="0"/>
-              <a:t>Less error-prone</a:t>
-            </a:r>
-          </a:p>
-          <a:p>
-            <a:pPr lvl="1"/>
-            <a:r>
-              <a:rPr lang="en-US" dirty="0"/>
-              <a:t>Easier to maintain</a:t>
-            </a:r>
-          </a:p>
-          <a:p>
-            <a:pPr lvl="1"/>
-            <a:r>
-              <a:rPr lang="en-US" dirty="0"/>
-              <a:t>Reusable</a:t>
-            </a:r>
-          </a:p>
-          <a:p>
-            <a:pPr lvl="1"/>
-            <a:r>
-              <a:rPr lang="en-US" dirty="0"/>
-              <a:t>…</a:t>
-            </a:r>
-          </a:p>
-          <a:p>
-            <a:r>
-              <a:rPr lang="en-US" dirty="0"/>
-              <a:t>How to </a:t>
-            </a:r>
-            <a:r>
-              <a:rPr lang="en-US" u="sng" dirty="0"/>
-              <a:t>manage</a:t>
-            </a:r>
-            <a:r>
-              <a:rPr lang="en-US" dirty="0"/>
-              <a:t> a software project effectively?</a:t>
-            </a:r>
-          </a:p>
-          <a:p>
-            <a:endParaRPr lang="en-US" dirty="0"/>
-          </a:p>
-          <a:p>
-            <a:pPr lvl="1"/>
-            <a:endParaRPr lang="en-US" dirty="0"/>
-          </a:p>
-          <a:p>
-            <a:endParaRPr lang="en-US" dirty="0"/>
-          </a:p>
-          <a:p>
-            <a:endParaRPr lang="en-US" dirty="0"/>
-          </a:p>
-        </p:txBody>
-      </p:sp>
-      <p:sp>
-        <p:nvSpPr>
-          <p:cNvPr id="4" name="Slide Number Placeholder 3">
-            <a:extLst>
-              <a:ext uri="{FF2B5EF4-FFF2-40B4-BE49-F238E27FC236}">
-                <a16:creationId xmlns:a16="http://schemas.microsoft.com/office/drawing/2014/main" id="{F857987F-894F-663F-291F-2E1A6AE37818}"/>
-              </a:ext>
-            </a:extLst>
-          </p:cNvPr>
-          <p:cNvSpPr>
-            <a:spLocks noGrp="1"/>
-          </p:cNvSpPr>
-          <p:nvPr>
-            <p:ph type="sldNum" sz="quarter" idx="12"/>
-          </p:nvPr>
-        </p:nvSpPr>
-        <p:spPr/>
-        <p:txBody>
-          <a:bodyPr/>
-          <a:lstStyle/>
-          <a:p>
-            <a:fld id="{3AB30462-0FD5-604F-8C98-DCC91BE84583}" type="slidenum">
-              <a:rPr lang="en-US" smtClean="0"/>
-              <a:t>35</a:t>
-            </a:fld>
-            <a:endParaRPr lang="en-US"/>
-          </a:p>
-        </p:txBody>
-      </p:sp>
-    </p:spTree>
-    <p:extLst>
-      <p:ext uri="{BB962C8B-B14F-4D97-AF65-F5344CB8AC3E}">
-        <p14:creationId xmlns:p14="http://schemas.microsoft.com/office/powerpoint/2010/main" val="2107989568"/>
-      </p:ext>
-    </p:extLst>
-  </p:cSld>
-  <p:clrMapOvr>
-    <a:masterClrMapping/>
-  </p:clrMapOvr>
-</p:sld>
-</file>
-
-<file path=ppt/slides/slide36.xml><?xml version="1.0" encoding="utf-8"?>
-<p:sld xmlns:a="http://schemas.openxmlformats.org/drawingml/2006/main" xmlns:r="http://schemas.openxmlformats.org/officeDocument/2006/relationships" xmlns:p="http://schemas.openxmlformats.org/presentationml/2006/main">
-  <p:cSld>
-    <p:spTree>
-      <p:nvGrpSpPr>
-        <p:cNvPr id="1" name="">
-          <a:extLst>
-            <a:ext uri="{FF2B5EF4-FFF2-40B4-BE49-F238E27FC236}">
-              <a16:creationId xmlns:a16="http://schemas.microsoft.com/office/drawing/2014/main" id="{EFC2373B-C16D-DA25-3264-93A826BFA945}"/>
-            </a:ext>
-          </a:extLst>
-        </p:cNvPr>
-        <p:cNvGrpSpPr/>
-        <p:nvPr/>
-      </p:nvGrpSpPr>
-      <p:grpSpPr>
-        <a:xfrm>
-          <a:off x="0" y="0"/>
-          <a:ext cx="0" cy="0"/>
-          <a:chOff x="0" y="0"/>
-          <a:chExt cx="0" cy="0"/>
-        </a:xfrm>
-      </p:grpSpPr>
-      <p:sp>
-        <p:nvSpPr>
-          <p:cNvPr id="2" name="Title 1">
-            <a:extLst>
-              <a:ext uri="{FF2B5EF4-FFF2-40B4-BE49-F238E27FC236}">
-                <a16:creationId xmlns:a16="http://schemas.microsoft.com/office/drawing/2014/main" id="{044E33EA-0C32-D87F-938C-0299354C5A7E}"/>
-              </a:ext>
-            </a:extLst>
-          </p:cNvPr>
-          <p:cNvSpPr>
-            <a:spLocks noGrp="1"/>
-          </p:cNvSpPr>
-          <p:nvPr>
-            <p:ph type="title"/>
-          </p:nvPr>
-        </p:nvSpPr>
-        <p:spPr/>
-        <p:txBody>
-          <a:bodyPr/>
-          <a:lstStyle/>
-          <a:p>
-            <a:r>
-              <a:rPr lang="en-US" dirty="0"/>
-              <a:t>Main course topics</a:t>
-            </a:r>
-          </a:p>
-        </p:txBody>
-      </p:sp>
-      <p:sp>
-        <p:nvSpPr>
-          <p:cNvPr id="3" name="Content Placeholder 2">
-            <a:extLst>
-              <a:ext uri="{FF2B5EF4-FFF2-40B4-BE49-F238E27FC236}">
-                <a16:creationId xmlns:a16="http://schemas.microsoft.com/office/drawing/2014/main" id="{1D5BB1B1-A45B-9016-E837-9E2473C61555}"/>
-              </a:ext>
-            </a:extLst>
-          </p:cNvPr>
-          <p:cNvSpPr>
-            <a:spLocks noGrp="1"/>
-          </p:cNvSpPr>
-          <p:nvPr>
-            <p:ph idx="1"/>
-          </p:nvPr>
-        </p:nvSpPr>
-        <p:spPr/>
-        <p:txBody>
-          <a:bodyPr/>
-          <a:lstStyle/>
-          <a:p>
-            <a:r>
-              <a:rPr lang="en-US" dirty="0"/>
-              <a:t>How to write </a:t>
-            </a:r>
-            <a:r>
-              <a:rPr lang="en-US" u="sng" dirty="0"/>
-              <a:t>quality</a:t>
-            </a:r>
-            <a:r>
-              <a:rPr lang="en-US" dirty="0"/>
-              <a:t> code?</a:t>
-            </a:r>
-          </a:p>
-          <a:p>
-            <a:pPr lvl="1"/>
-            <a:r>
-              <a:rPr lang="en-US" altLang="zh-CN" dirty="0"/>
-              <a:t>Usable</a:t>
-            </a:r>
-            <a:endParaRPr lang="en-US" dirty="0"/>
-          </a:p>
-          <a:p>
-            <a:pPr lvl="1"/>
-            <a:r>
-              <a:rPr lang="en-US" dirty="0"/>
-              <a:t>Less error-prone</a:t>
-            </a:r>
-          </a:p>
-          <a:p>
-            <a:pPr lvl="1"/>
-            <a:r>
-              <a:rPr lang="en-US" dirty="0"/>
-              <a:t>Easier to maintain</a:t>
-            </a:r>
-          </a:p>
-          <a:p>
-            <a:pPr lvl="1"/>
-            <a:r>
-              <a:rPr lang="en-US" dirty="0"/>
-              <a:t>Reusable</a:t>
-            </a:r>
-          </a:p>
-          <a:p>
-            <a:pPr lvl="1"/>
-            <a:r>
-              <a:rPr lang="en-US" dirty="0"/>
-              <a:t>…</a:t>
-            </a:r>
-          </a:p>
-          <a:p>
-            <a:r>
-              <a:rPr lang="en-US" dirty="0"/>
-              <a:t>How to </a:t>
-            </a:r>
-            <a:r>
-              <a:rPr lang="en-US" u="sng" dirty="0"/>
-              <a:t>manage</a:t>
-            </a:r>
-            <a:r>
-              <a:rPr lang="en-US" dirty="0"/>
-              <a:t> a software project effectively?</a:t>
-            </a:r>
-          </a:p>
-          <a:p>
-            <a:pPr lvl="1"/>
-            <a:r>
-              <a:rPr lang="en-US" dirty="0"/>
-              <a:t>Meet the user requirements</a:t>
-            </a:r>
-          </a:p>
-          <a:p>
-            <a:pPr lvl="1"/>
-            <a:r>
-              <a:rPr lang="en-US" dirty="0"/>
-              <a:t>Delivered in a timely manner</a:t>
-            </a:r>
-          </a:p>
-          <a:p>
-            <a:pPr lvl="1"/>
-            <a:r>
-              <a:rPr lang="en-US" dirty="0"/>
-              <a:t>…</a:t>
-            </a:r>
-          </a:p>
-          <a:p>
-            <a:pPr lvl="1"/>
-            <a:endParaRPr lang="en-US" dirty="0"/>
-          </a:p>
-          <a:p>
-            <a:endParaRPr lang="en-US" dirty="0"/>
-          </a:p>
-          <a:p>
-            <a:pPr lvl="1"/>
-            <a:endParaRPr lang="en-US" dirty="0"/>
-          </a:p>
-          <a:p>
-            <a:endParaRPr lang="en-US" dirty="0"/>
-          </a:p>
-          <a:p>
-            <a:endParaRPr lang="en-US" dirty="0"/>
-          </a:p>
-        </p:txBody>
-      </p:sp>
-      <p:sp>
-        <p:nvSpPr>
-          <p:cNvPr id="4" name="Slide Number Placeholder 3">
-            <a:extLst>
-              <a:ext uri="{FF2B5EF4-FFF2-40B4-BE49-F238E27FC236}">
-                <a16:creationId xmlns:a16="http://schemas.microsoft.com/office/drawing/2014/main" id="{3ADB5785-52A1-2D23-11E2-85983AA74D67}"/>
-              </a:ext>
-            </a:extLst>
-          </p:cNvPr>
-          <p:cNvSpPr>
-            <a:spLocks noGrp="1"/>
-          </p:cNvSpPr>
-          <p:nvPr>
-            <p:ph type="sldNum" sz="quarter" idx="12"/>
-          </p:nvPr>
-        </p:nvSpPr>
-        <p:spPr/>
-        <p:txBody>
-          <a:bodyPr/>
-          <a:lstStyle/>
-          <a:p>
-            <a:fld id="{3AB30462-0FD5-604F-8C98-DCC91BE84583}" type="slidenum">
-              <a:rPr lang="en-US" smtClean="0"/>
-              <a:t>36</a:t>
-            </a:fld>
-            <a:endParaRPr lang="en-US"/>
-          </a:p>
-        </p:txBody>
-      </p:sp>
-    </p:spTree>
-    <p:extLst>
-      <p:ext uri="{BB962C8B-B14F-4D97-AF65-F5344CB8AC3E}">
-        <p14:creationId xmlns:p14="http://schemas.microsoft.com/office/powerpoint/2010/main" val="1624227512"/>
       </p:ext>
     </p:extLst>
   </p:cSld>
@@ -10184,6 +10554,593 @@
     <p:extLst>
       <p:ext uri="{BB962C8B-B14F-4D97-AF65-F5344CB8AC3E}">
         <p14:creationId xmlns:p14="http://schemas.microsoft.com/office/powerpoint/2010/main" val="1336265694"/>
+      </p:ext>
+    </p:extLst>
+  </p:cSld>
+  <p:clrMapOvr>
+    <a:masterClrMapping/>
+  </p:clrMapOvr>
+</p:sld>
+</file>
+
+<file path=ppt/slides/slide40.xml><?xml version="1.0" encoding="utf-8"?>
+<p:sld xmlns:a="http://schemas.openxmlformats.org/drawingml/2006/main" xmlns:r="http://schemas.openxmlformats.org/officeDocument/2006/relationships" xmlns:p="http://schemas.openxmlformats.org/presentationml/2006/main">
+  <p:cSld>
+    <p:spTree>
+      <p:nvGrpSpPr>
+        <p:cNvPr id="1" name="">
+          <a:extLst>
+            <a:ext uri="{FF2B5EF4-FFF2-40B4-BE49-F238E27FC236}">
+              <a16:creationId xmlns:a16="http://schemas.microsoft.com/office/drawing/2014/main" id="{A52F73ED-EFBA-F3DF-4D3E-88108C3D1A52}"/>
+            </a:ext>
+          </a:extLst>
+        </p:cNvPr>
+        <p:cNvGrpSpPr/>
+        <p:nvPr/>
+      </p:nvGrpSpPr>
+      <p:grpSpPr>
+        <a:xfrm>
+          <a:off x="0" y="0"/>
+          <a:ext cx="0" cy="0"/>
+          <a:chOff x="0" y="0"/>
+          <a:chExt cx="0" cy="0"/>
+        </a:xfrm>
+      </p:grpSpPr>
+      <p:sp>
+        <p:nvSpPr>
+          <p:cNvPr id="2" name="Title 1">
+            <a:extLst>
+              <a:ext uri="{FF2B5EF4-FFF2-40B4-BE49-F238E27FC236}">
+                <a16:creationId xmlns:a16="http://schemas.microsoft.com/office/drawing/2014/main" id="{6FCD59A0-294B-0A15-110B-4F03E294377F}"/>
+              </a:ext>
+            </a:extLst>
+          </p:cNvPr>
+          <p:cNvSpPr>
+            <a:spLocks noGrp="1"/>
+          </p:cNvSpPr>
+          <p:nvPr>
+            <p:ph type="title"/>
+          </p:nvPr>
+        </p:nvSpPr>
+        <p:spPr/>
+        <p:txBody>
+          <a:bodyPr/>
+          <a:lstStyle/>
+          <a:p>
+            <a:r>
+              <a:rPr lang="en-US" dirty="0"/>
+              <a:t>Main course topics</a:t>
+            </a:r>
+          </a:p>
+        </p:txBody>
+      </p:sp>
+      <p:sp>
+        <p:nvSpPr>
+          <p:cNvPr id="3" name="Content Placeholder 2">
+            <a:extLst>
+              <a:ext uri="{FF2B5EF4-FFF2-40B4-BE49-F238E27FC236}">
+                <a16:creationId xmlns:a16="http://schemas.microsoft.com/office/drawing/2014/main" id="{44070496-D261-9FCC-8B1F-5DF810745D54}"/>
+              </a:ext>
+            </a:extLst>
+          </p:cNvPr>
+          <p:cNvSpPr>
+            <a:spLocks noGrp="1"/>
+          </p:cNvSpPr>
+          <p:nvPr>
+            <p:ph idx="1"/>
+          </p:nvPr>
+        </p:nvSpPr>
+        <p:spPr/>
+        <p:txBody>
+          <a:bodyPr/>
+          <a:lstStyle/>
+          <a:p>
+            <a:r>
+              <a:rPr lang="en-US" dirty="0"/>
+              <a:t>How to write </a:t>
+            </a:r>
+            <a:r>
+              <a:rPr lang="en-US" u="sng" dirty="0"/>
+              <a:t>quality</a:t>
+            </a:r>
+            <a:r>
+              <a:rPr lang="en-US" dirty="0"/>
+              <a:t> code?</a:t>
+            </a:r>
+          </a:p>
+          <a:p>
+            <a:pPr lvl="1"/>
+            <a:r>
+              <a:rPr lang="en-US" altLang="zh-CN" dirty="0"/>
+              <a:t>Usable</a:t>
+            </a:r>
+            <a:endParaRPr lang="en-US" dirty="0"/>
+          </a:p>
+          <a:p>
+            <a:pPr lvl="1"/>
+            <a:r>
+              <a:rPr lang="en-US" dirty="0"/>
+              <a:t>Less error-prone</a:t>
+            </a:r>
+          </a:p>
+          <a:p>
+            <a:pPr lvl="1"/>
+            <a:r>
+              <a:rPr lang="en-US" dirty="0"/>
+              <a:t>Easier to maintain</a:t>
+            </a:r>
+          </a:p>
+          <a:p>
+            <a:pPr lvl="1"/>
+            <a:r>
+              <a:rPr lang="en-US" dirty="0"/>
+              <a:t>Reusable</a:t>
+            </a:r>
+          </a:p>
+          <a:p>
+            <a:pPr lvl="1"/>
+            <a:r>
+              <a:rPr lang="en-US" dirty="0"/>
+              <a:t>…</a:t>
+            </a:r>
+          </a:p>
+          <a:p>
+            <a:endParaRPr lang="en-US" dirty="0"/>
+          </a:p>
+          <a:p>
+            <a:pPr lvl="1"/>
+            <a:endParaRPr lang="en-US" dirty="0"/>
+          </a:p>
+          <a:p>
+            <a:endParaRPr lang="en-US" dirty="0"/>
+          </a:p>
+          <a:p>
+            <a:endParaRPr lang="en-US" dirty="0"/>
+          </a:p>
+        </p:txBody>
+      </p:sp>
+      <p:sp>
+        <p:nvSpPr>
+          <p:cNvPr id="4" name="Slide Number Placeholder 3">
+            <a:extLst>
+              <a:ext uri="{FF2B5EF4-FFF2-40B4-BE49-F238E27FC236}">
+                <a16:creationId xmlns:a16="http://schemas.microsoft.com/office/drawing/2014/main" id="{A3F2E659-F8C4-5B1C-96ED-AA2E86EABE38}"/>
+              </a:ext>
+            </a:extLst>
+          </p:cNvPr>
+          <p:cNvSpPr>
+            <a:spLocks noGrp="1"/>
+          </p:cNvSpPr>
+          <p:nvPr>
+            <p:ph type="sldNum" sz="quarter" idx="12"/>
+          </p:nvPr>
+        </p:nvSpPr>
+        <p:spPr/>
+        <p:txBody>
+          <a:bodyPr/>
+          <a:lstStyle/>
+          <a:p>
+            <a:fld id="{3AB30462-0FD5-604F-8C98-DCC91BE84583}" type="slidenum">
+              <a:rPr lang="en-US" smtClean="0"/>
+              <a:t>40</a:t>
+            </a:fld>
+            <a:endParaRPr lang="en-US"/>
+          </a:p>
+        </p:txBody>
+      </p:sp>
+    </p:spTree>
+    <p:extLst>
+      <p:ext uri="{BB962C8B-B14F-4D97-AF65-F5344CB8AC3E}">
+        <p14:creationId xmlns:p14="http://schemas.microsoft.com/office/powerpoint/2010/main" val="3897885859"/>
+      </p:ext>
+    </p:extLst>
+  </p:cSld>
+  <p:clrMapOvr>
+    <a:masterClrMapping/>
+  </p:clrMapOvr>
+</p:sld>
+</file>
+
+<file path=ppt/slides/slide41.xml><?xml version="1.0" encoding="utf-8"?>
+<p:sld xmlns:a="http://schemas.openxmlformats.org/drawingml/2006/main" xmlns:r="http://schemas.openxmlformats.org/officeDocument/2006/relationships" xmlns:p="http://schemas.openxmlformats.org/presentationml/2006/main">
+  <p:cSld>
+    <p:spTree>
+      <p:nvGrpSpPr>
+        <p:cNvPr id="1" name="">
+          <a:extLst>
+            <a:ext uri="{FF2B5EF4-FFF2-40B4-BE49-F238E27FC236}">
+              <a16:creationId xmlns:a16="http://schemas.microsoft.com/office/drawing/2014/main" id="{BA7C86BA-5877-CC53-4DEA-AE7B11D695B3}"/>
+            </a:ext>
+          </a:extLst>
+        </p:cNvPr>
+        <p:cNvGrpSpPr/>
+        <p:nvPr/>
+      </p:nvGrpSpPr>
+      <p:grpSpPr>
+        <a:xfrm>
+          <a:off x="0" y="0"/>
+          <a:ext cx="0" cy="0"/>
+          <a:chOff x="0" y="0"/>
+          <a:chExt cx="0" cy="0"/>
+        </a:xfrm>
+      </p:grpSpPr>
+      <p:sp>
+        <p:nvSpPr>
+          <p:cNvPr id="2" name="Title 1">
+            <a:extLst>
+              <a:ext uri="{FF2B5EF4-FFF2-40B4-BE49-F238E27FC236}">
+                <a16:creationId xmlns:a16="http://schemas.microsoft.com/office/drawing/2014/main" id="{FA7855FC-A2E8-8DBE-CA4A-68FDAA8A4332}"/>
+              </a:ext>
+            </a:extLst>
+          </p:cNvPr>
+          <p:cNvSpPr>
+            <a:spLocks noGrp="1"/>
+          </p:cNvSpPr>
+          <p:nvPr>
+            <p:ph type="title"/>
+          </p:nvPr>
+        </p:nvSpPr>
+        <p:spPr/>
+        <p:txBody>
+          <a:bodyPr/>
+          <a:lstStyle/>
+          <a:p>
+            <a:r>
+              <a:rPr lang="en-US" dirty="0"/>
+              <a:t>Main course topics</a:t>
+            </a:r>
+          </a:p>
+        </p:txBody>
+      </p:sp>
+      <p:sp>
+        <p:nvSpPr>
+          <p:cNvPr id="3" name="Content Placeholder 2">
+            <a:extLst>
+              <a:ext uri="{FF2B5EF4-FFF2-40B4-BE49-F238E27FC236}">
+                <a16:creationId xmlns:a16="http://schemas.microsoft.com/office/drawing/2014/main" id="{E21D6EEC-074C-6F97-56D2-DCA3DB28292F}"/>
+              </a:ext>
+            </a:extLst>
+          </p:cNvPr>
+          <p:cNvSpPr>
+            <a:spLocks noGrp="1"/>
+          </p:cNvSpPr>
+          <p:nvPr>
+            <p:ph idx="1"/>
+          </p:nvPr>
+        </p:nvSpPr>
+        <p:spPr/>
+        <p:txBody>
+          <a:bodyPr/>
+          <a:lstStyle/>
+          <a:p>
+            <a:r>
+              <a:rPr lang="en-US" dirty="0"/>
+              <a:t>How to write </a:t>
+            </a:r>
+            <a:r>
+              <a:rPr lang="en-US" u="sng" dirty="0"/>
+              <a:t>quality</a:t>
+            </a:r>
+            <a:r>
+              <a:rPr lang="en-US" dirty="0"/>
+              <a:t> code?</a:t>
+            </a:r>
+          </a:p>
+          <a:p>
+            <a:pPr lvl="1"/>
+            <a:r>
+              <a:rPr lang="en-US" altLang="zh-CN" dirty="0"/>
+              <a:t>Usable</a:t>
+            </a:r>
+            <a:endParaRPr lang="en-US" dirty="0"/>
+          </a:p>
+          <a:p>
+            <a:pPr lvl="1"/>
+            <a:r>
+              <a:rPr lang="en-US" dirty="0"/>
+              <a:t>Less error-prone</a:t>
+            </a:r>
+          </a:p>
+          <a:p>
+            <a:pPr lvl="1"/>
+            <a:r>
+              <a:rPr lang="en-US" dirty="0"/>
+              <a:t>Easier to maintain</a:t>
+            </a:r>
+          </a:p>
+          <a:p>
+            <a:pPr lvl="1"/>
+            <a:r>
+              <a:rPr lang="en-US" dirty="0"/>
+              <a:t>Reusable</a:t>
+            </a:r>
+          </a:p>
+          <a:p>
+            <a:pPr lvl="1"/>
+            <a:r>
+              <a:rPr lang="en-US" dirty="0"/>
+              <a:t>…</a:t>
+            </a:r>
+          </a:p>
+          <a:p>
+            <a:r>
+              <a:rPr lang="en-US" dirty="0"/>
+              <a:t>How to </a:t>
+            </a:r>
+            <a:r>
+              <a:rPr lang="en-US" u="sng" dirty="0"/>
+              <a:t>manage</a:t>
+            </a:r>
+            <a:r>
+              <a:rPr lang="en-US" dirty="0"/>
+              <a:t> a software project effectively?</a:t>
+            </a:r>
+          </a:p>
+          <a:p>
+            <a:endParaRPr lang="en-US" dirty="0"/>
+          </a:p>
+          <a:p>
+            <a:pPr lvl="1"/>
+            <a:endParaRPr lang="en-US" dirty="0"/>
+          </a:p>
+          <a:p>
+            <a:endParaRPr lang="en-US" dirty="0"/>
+          </a:p>
+          <a:p>
+            <a:endParaRPr lang="en-US" dirty="0"/>
+          </a:p>
+        </p:txBody>
+      </p:sp>
+      <p:sp>
+        <p:nvSpPr>
+          <p:cNvPr id="4" name="Slide Number Placeholder 3">
+            <a:extLst>
+              <a:ext uri="{FF2B5EF4-FFF2-40B4-BE49-F238E27FC236}">
+                <a16:creationId xmlns:a16="http://schemas.microsoft.com/office/drawing/2014/main" id="{F857987F-894F-663F-291F-2E1A6AE37818}"/>
+              </a:ext>
+            </a:extLst>
+          </p:cNvPr>
+          <p:cNvSpPr>
+            <a:spLocks noGrp="1"/>
+          </p:cNvSpPr>
+          <p:nvPr>
+            <p:ph type="sldNum" sz="quarter" idx="12"/>
+          </p:nvPr>
+        </p:nvSpPr>
+        <p:spPr/>
+        <p:txBody>
+          <a:bodyPr/>
+          <a:lstStyle/>
+          <a:p>
+            <a:fld id="{3AB30462-0FD5-604F-8C98-DCC91BE84583}" type="slidenum">
+              <a:rPr lang="en-US" smtClean="0"/>
+              <a:t>41</a:t>
+            </a:fld>
+            <a:endParaRPr lang="en-US"/>
+          </a:p>
+        </p:txBody>
+      </p:sp>
+    </p:spTree>
+    <p:extLst>
+      <p:ext uri="{BB962C8B-B14F-4D97-AF65-F5344CB8AC3E}">
+        <p14:creationId xmlns:p14="http://schemas.microsoft.com/office/powerpoint/2010/main" val="2107989568"/>
+      </p:ext>
+    </p:extLst>
+  </p:cSld>
+  <p:clrMapOvr>
+    <a:masterClrMapping/>
+  </p:clrMapOvr>
+</p:sld>
+</file>
+
+<file path=ppt/slides/slide42.xml><?xml version="1.0" encoding="utf-8"?>
+<p:sld xmlns:a="http://schemas.openxmlformats.org/drawingml/2006/main" xmlns:r="http://schemas.openxmlformats.org/officeDocument/2006/relationships" xmlns:p="http://schemas.openxmlformats.org/presentationml/2006/main">
+  <p:cSld>
+    <p:spTree>
+      <p:nvGrpSpPr>
+        <p:cNvPr id="1" name="">
+          <a:extLst>
+            <a:ext uri="{FF2B5EF4-FFF2-40B4-BE49-F238E27FC236}">
+              <a16:creationId xmlns:a16="http://schemas.microsoft.com/office/drawing/2014/main" id="{EFC2373B-C16D-DA25-3264-93A826BFA945}"/>
+            </a:ext>
+          </a:extLst>
+        </p:cNvPr>
+        <p:cNvGrpSpPr/>
+        <p:nvPr/>
+      </p:nvGrpSpPr>
+      <p:grpSpPr>
+        <a:xfrm>
+          <a:off x="0" y="0"/>
+          <a:ext cx="0" cy="0"/>
+          <a:chOff x="0" y="0"/>
+          <a:chExt cx="0" cy="0"/>
+        </a:xfrm>
+      </p:grpSpPr>
+      <p:sp>
+        <p:nvSpPr>
+          <p:cNvPr id="2" name="Title 1">
+            <a:extLst>
+              <a:ext uri="{FF2B5EF4-FFF2-40B4-BE49-F238E27FC236}">
+                <a16:creationId xmlns:a16="http://schemas.microsoft.com/office/drawing/2014/main" id="{044E33EA-0C32-D87F-938C-0299354C5A7E}"/>
+              </a:ext>
+            </a:extLst>
+          </p:cNvPr>
+          <p:cNvSpPr>
+            <a:spLocks noGrp="1"/>
+          </p:cNvSpPr>
+          <p:nvPr>
+            <p:ph type="title"/>
+          </p:nvPr>
+        </p:nvSpPr>
+        <p:spPr/>
+        <p:txBody>
+          <a:bodyPr/>
+          <a:lstStyle/>
+          <a:p>
+            <a:r>
+              <a:rPr lang="en-US" dirty="0"/>
+              <a:t>Main course topics</a:t>
+            </a:r>
+          </a:p>
+        </p:txBody>
+      </p:sp>
+      <p:sp>
+        <p:nvSpPr>
+          <p:cNvPr id="3" name="Content Placeholder 2">
+            <a:extLst>
+              <a:ext uri="{FF2B5EF4-FFF2-40B4-BE49-F238E27FC236}">
+                <a16:creationId xmlns:a16="http://schemas.microsoft.com/office/drawing/2014/main" id="{1D5BB1B1-A45B-9016-E837-9E2473C61555}"/>
+              </a:ext>
+            </a:extLst>
+          </p:cNvPr>
+          <p:cNvSpPr>
+            <a:spLocks noGrp="1"/>
+          </p:cNvSpPr>
+          <p:nvPr>
+            <p:ph idx="1"/>
+          </p:nvPr>
+        </p:nvSpPr>
+        <p:spPr/>
+        <p:txBody>
+          <a:bodyPr/>
+          <a:lstStyle/>
+          <a:p>
+            <a:r>
+              <a:rPr lang="en-US" dirty="0"/>
+              <a:t>How to write </a:t>
+            </a:r>
+            <a:r>
+              <a:rPr lang="en-US" u="sng" dirty="0"/>
+              <a:t>quality</a:t>
+            </a:r>
+            <a:r>
+              <a:rPr lang="en-US" dirty="0"/>
+              <a:t> code?</a:t>
+            </a:r>
+          </a:p>
+          <a:p>
+            <a:pPr lvl="1"/>
+            <a:r>
+              <a:rPr lang="en-US" altLang="zh-CN" dirty="0"/>
+              <a:t>Usable</a:t>
+            </a:r>
+            <a:endParaRPr lang="en-US" dirty="0"/>
+          </a:p>
+          <a:p>
+            <a:pPr lvl="1"/>
+            <a:r>
+              <a:rPr lang="en-US" dirty="0"/>
+              <a:t>Less error-prone</a:t>
+            </a:r>
+          </a:p>
+          <a:p>
+            <a:pPr lvl="1"/>
+            <a:r>
+              <a:rPr lang="en-US" dirty="0"/>
+              <a:t>Easier to maintain</a:t>
+            </a:r>
+          </a:p>
+          <a:p>
+            <a:pPr lvl="1"/>
+            <a:r>
+              <a:rPr lang="en-US" dirty="0"/>
+              <a:t>Reusable</a:t>
+            </a:r>
+          </a:p>
+          <a:p>
+            <a:pPr lvl="1"/>
+            <a:r>
+              <a:rPr lang="en-US" dirty="0"/>
+              <a:t>…</a:t>
+            </a:r>
+          </a:p>
+          <a:p>
+            <a:r>
+              <a:rPr lang="en-US" dirty="0"/>
+              <a:t>How to </a:t>
+            </a:r>
+            <a:r>
+              <a:rPr lang="en-US" u="sng" dirty="0"/>
+              <a:t>manage</a:t>
+            </a:r>
+            <a:r>
+              <a:rPr lang="en-US" dirty="0"/>
+              <a:t> a software project effectively?</a:t>
+            </a:r>
+          </a:p>
+          <a:p>
+            <a:pPr lvl="1"/>
+            <a:r>
+              <a:rPr lang="en-US" dirty="0"/>
+              <a:t>Meet the user requirements</a:t>
+            </a:r>
+          </a:p>
+          <a:p>
+            <a:pPr lvl="1"/>
+            <a:r>
+              <a:rPr lang="en-US" dirty="0"/>
+              <a:t>Delivered in a timely manner</a:t>
+            </a:r>
+          </a:p>
+          <a:p>
+            <a:pPr lvl="1"/>
+            <a:r>
+              <a:rPr lang="en-US" dirty="0"/>
+              <a:t>…</a:t>
+            </a:r>
+          </a:p>
+          <a:p>
+            <a:pPr lvl="1"/>
+            <a:endParaRPr lang="en-US" dirty="0"/>
+          </a:p>
+          <a:p>
+            <a:endParaRPr lang="en-US" dirty="0"/>
+          </a:p>
+          <a:p>
+            <a:pPr lvl="1"/>
+            <a:endParaRPr lang="en-US" dirty="0"/>
+          </a:p>
+          <a:p>
+            <a:endParaRPr lang="en-US" dirty="0"/>
+          </a:p>
+          <a:p>
+            <a:endParaRPr lang="en-US" dirty="0"/>
+          </a:p>
+        </p:txBody>
+      </p:sp>
+      <p:sp>
+        <p:nvSpPr>
+          <p:cNvPr id="4" name="Slide Number Placeholder 3">
+            <a:extLst>
+              <a:ext uri="{FF2B5EF4-FFF2-40B4-BE49-F238E27FC236}">
+                <a16:creationId xmlns:a16="http://schemas.microsoft.com/office/drawing/2014/main" id="{3ADB5785-52A1-2D23-11E2-85983AA74D67}"/>
+              </a:ext>
+            </a:extLst>
+          </p:cNvPr>
+          <p:cNvSpPr>
+            <a:spLocks noGrp="1"/>
+          </p:cNvSpPr>
+          <p:nvPr>
+            <p:ph type="sldNum" sz="quarter" idx="12"/>
+          </p:nvPr>
+        </p:nvSpPr>
+        <p:spPr/>
+        <p:txBody>
+          <a:bodyPr/>
+          <a:lstStyle/>
+          <a:p>
+            <a:fld id="{3AB30462-0FD5-604F-8C98-DCC91BE84583}" type="slidenum">
+              <a:rPr lang="en-US" smtClean="0"/>
+              <a:t>42</a:t>
+            </a:fld>
+            <a:endParaRPr lang="en-US"/>
+          </a:p>
+        </p:txBody>
+      </p:sp>
+    </p:spTree>
+    <p:extLst>
+      <p:ext uri="{BB962C8B-B14F-4D97-AF65-F5344CB8AC3E}">
+        <p14:creationId xmlns:p14="http://schemas.microsoft.com/office/powerpoint/2010/main" val="1624227512"/>
       </p:ext>
     </p:extLst>
   </p:cSld>
@@ -10216,121 +11173,12 @@
           <a:chExt cx="0" cy="0"/>
         </a:xfrm>
       </p:grpSpPr>
-      <p:sp>
-        <p:nvSpPr>
-          <p:cNvPr id="2" name="Title 1">
-            <a:extLst>
-              <a:ext uri="{FF2B5EF4-FFF2-40B4-BE49-F238E27FC236}">
-                <a16:creationId xmlns:a16="http://schemas.microsoft.com/office/drawing/2014/main" id="{42E76335-E3D7-FD83-5AFA-B8EFB9A75336}"/>
-              </a:ext>
-            </a:extLst>
-          </p:cNvPr>
-          <p:cNvSpPr>
-            <a:spLocks noGrp="1"/>
-          </p:cNvSpPr>
-          <p:nvPr>
-            <p:ph type="title"/>
-          </p:nvPr>
-        </p:nvSpPr>
-        <p:spPr/>
-        <p:txBody>
-          <a:bodyPr/>
-          <a:lstStyle/>
-          <a:p>
-            <a:r>
-              <a:rPr lang="en-US" dirty="0"/>
-              <a:t>Why Software Engineering?</a:t>
-            </a:r>
-          </a:p>
-        </p:txBody>
-      </p:sp>
-      <p:sp>
-        <p:nvSpPr>
-          <p:cNvPr id="3" name="Content Placeholder 2">
-            <a:extLst>
-              <a:ext uri="{FF2B5EF4-FFF2-40B4-BE49-F238E27FC236}">
-                <a16:creationId xmlns:a16="http://schemas.microsoft.com/office/drawing/2014/main" id="{FE54DAE4-36AC-372D-1519-0ACED7268099}"/>
-              </a:ext>
-            </a:extLst>
-          </p:cNvPr>
-          <p:cNvSpPr>
-            <a:spLocks noGrp="1"/>
-          </p:cNvSpPr>
-          <p:nvPr>
-            <p:ph idx="1"/>
-          </p:nvPr>
-        </p:nvSpPr>
-        <p:spPr/>
-        <p:txBody>
-          <a:bodyPr/>
-          <a:lstStyle/>
-          <a:p>
-            <a:r>
-              <a:rPr lang="en-US" dirty="0"/>
-              <a:t>Software is Everywhere</a:t>
-            </a:r>
-          </a:p>
-          <a:p>
-            <a:pPr lvl="1"/>
-            <a:r>
-              <a:rPr lang="en-US" b="1" dirty="0"/>
-              <a:t>Example</a:t>
-            </a:r>
-            <a:r>
-              <a:rPr lang="en-US" dirty="0"/>
-              <a:t>: An MRI scanner, an airplane autopilot system, and your ride-share app — all run on complex software</a:t>
-            </a:r>
-          </a:p>
-          <a:p>
-            <a:pPr lvl="1"/>
-            <a:r>
-              <a:rPr lang="en-US" b="1" dirty="0"/>
-              <a:t>Point</a:t>
-            </a:r>
-            <a:r>
-              <a:rPr lang="en-US" dirty="0"/>
-              <a:t>: These systems must be </a:t>
-            </a:r>
-            <a:r>
-              <a:rPr lang="en-US" i="1" dirty="0"/>
-              <a:t>safe</a:t>
-            </a:r>
-            <a:r>
-              <a:rPr lang="en-US" dirty="0"/>
-              <a:t>, </a:t>
-            </a:r>
-            <a:r>
-              <a:rPr lang="en-US" i="1" dirty="0"/>
-              <a:t>reliable</a:t>
-            </a:r>
-            <a:r>
-              <a:rPr lang="en-US" dirty="0"/>
-              <a:t>, and </a:t>
-            </a:r>
-            <a:r>
-              <a:rPr lang="en-US" i="1" dirty="0"/>
-              <a:t>maintainable</a:t>
-            </a:r>
-            <a:endParaRPr lang="en-US" dirty="0"/>
-          </a:p>
-          <a:p>
-            <a:endParaRPr lang="en-US" i="1" dirty="0"/>
-          </a:p>
-          <a:p>
-            <a:endParaRPr lang="en-US" dirty="0"/>
-          </a:p>
-          <a:p>
-            <a:pPr lvl="1"/>
-            <a:endParaRPr lang="en-US" dirty="0"/>
-          </a:p>
-        </p:txBody>
-      </p:sp>
       <p:pic>
         <p:nvPicPr>
-          <p:cNvPr id="5" name="Picture 4">
-            <a:extLst>
-              <a:ext uri="{FF2B5EF4-FFF2-40B4-BE49-F238E27FC236}">
-                <a16:creationId xmlns:a16="http://schemas.microsoft.com/office/drawing/2014/main" id="{0AEFADB3-FD2E-DA0D-07E7-B93C0A90DBA0}"/>
+          <p:cNvPr id="14" name="Picture 13">
+            <a:extLst>
+              <a:ext uri="{FF2B5EF4-FFF2-40B4-BE49-F238E27FC236}">
+                <a16:creationId xmlns:a16="http://schemas.microsoft.com/office/drawing/2014/main" id="{6F37C7C3-0379-19D0-342F-52F379687AB1}"/>
               </a:ext>
             </a:extLst>
           </p:cNvPr>
@@ -10344,6 +11192,151 @@
             <a:extLst>
               <a:ext uri="{837473B0-CC2E-450A-ABE3-18F120FF3D39}">
                 <a1611:picAttrSrcUrl xmlns:a1611="http://schemas.microsoft.com/office/drawing/2016/11/main" r:id="rId3"/>
+              </a:ext>
+            </a:extLst>
+          </a:blip>
+          <a:stretch>
+            <a:fillRect/>
+          </a:stretch>
+        </p:blipFill>
+        <p:spPr>
+          <a:xfrm>
+            <a:off x="6924642" y="5642996"/>
+            <a:ext cx="1685958" cy="948351"/>
+          </a:xfrm>
+          <a:prstGeom prst="rect">
+            <a:avLst/>
+          </a:prstGeom>
+        </p:spPr>
+      </p:pic>
+      <p:sp>
+        <p:nvSpPr>
+          <p:cNvPr id="2" name="Title 1">
+            <a:extLst>
+              <a:ext uri="{FF2B5EF4-FFF2-40B4-BE49-F238E27FC236}">
+                <a16:creationId xmlns:a16="http://schemas.microsoft.com/office/drawing/2014/main" id="{42E76335-E3D7-FD83-5AFA-B8EFB9A75336}"/>
+              </a:ext>
+            </a:extLst>
+          </p:cNvPr>
+          <p:cNvSpPr>
+            <a:spLocks noGrp="1"/>
+          </p:cNvSpPr>
+          <p:nvPr>
+            <p:ph type="title"/>
+          </p:nvPr>
+        </p:nvSpPr>
+        <p:spPr/>
+        <p:txBody>
+          <a:bodyPr/>
+          <a:lstStyle/>
+          <a:p>
+            <a:r>
+              <a:rPr lang="en-US" dirty="0"/>
+              <a:t>Why Software Engineering?</a:t>
+            </a:r>
+          </a:p>
+        </p:txBody>
+      </p:sp>
+      <p:sp>
+        <p:nvSpPr>
+          <p:cNvPr id="3" name="Content Placeholder 2">
+            <a:extLst>
+              <a:ext uri="{FF2B5EF4-FFF2-40B4-BE49-F238E27FC236}">
+                <a16:creationId xmlns:a16="http://schemas.microsoft.com/office/drawing/2014/main" id="{FE54DAE4-36AC-372D-1519-0ACED7268099}"/>
+              </a:ext>
+            </a:extLst>
+          </p:cNvPr>
+          <p:cNvSpPr>
+            <a:spLocks noGrp="1"/>
+          </p:cNvSpPr>
+          <p:nvPr>
+            <p:ph idx="1"/>
+          </p:nvPr>
+        </p:nvSpPr>
+        <p:spPr/>
+        <p:txBody>
+          <a:bodyPr/>
+          <a:lstStyle/>
+          <a:p>
+            <a:r>
+              <a:rPr lang="en-US" dirty="0"/>
+              <a:t>Software is Everywhere</a:t>
+            </a:r>
+          </a:p>
+          <a:p>
+            <a:pPr lvl="1"/>
+            <a:r>
+              <a:rPr lang="en-US" b="1" dirty="0"/>
+              <a:t>Example</a:t>
+            </a:r>
+            <a:r>
+              <a:rPr lang="en-US" dirty="0"/>
+              <a:t>: An MRI scanner, an airplane autopilot system, and your ride-share app — all run on complex software</a:t>
+            </a:r>
+          </a:p>
+          <a:p>
+            <a:pPr lvl="1"/>
+            <a:r>
+              <a:rPr lang="en-US" b="1" dirty="0"/>
+              <a:t>Point</a:t>
+            </a:r>
+            <a:r>
+              <a:rPr lang="en-US" dirty="0"/>
+              <a:t>: These systems must be </a:t>
+            </a:r>
+            <a:r>
+              <a:rPr lang="en-US" i="1" dirty="0"/>
+              <a:t>safe</a:t>
+            </a:r>
+            <a:r>
+              <a:rPr lang="en-US" dirty="0"/>
+              <a:t>, </a:t>
+            </a:r>
+            <a:r>
+              <a:rPr lang="en-US" i="1" dirty="0"/>
+              <a:t>reliable</a:t>
+            </a:r>
+            <a:r>
+              <a:rPr lang="en-US" dirty="0"/>
+              <a:t>, and </a:t>
+            </a:r>
+            <a:r>
+              <a:rPr lang="en-US" i="1" dirty="0"/>
+              <a:t>maintainable</a:t>
+            </a:r>
+            <a:endParaRPr lang="en-US" dirty="0"/>
+          </a:p>
+          <a:p>
+            <a:endParaRPr lang="en-US" i="1" dirty="0"/>
+          </a:p>
+          <a:p>
+            <a:endParaRPr lang="en-US" dirty="0"/>
+          </a:p>
+          <a:p>
+            <a:pPr lvl="1"/>
+            <a:endParaRPr lang="en-US" dirty="0"/>
+          </a:p>
+        </p:txBody>
+      </p:sp>
+      <p:pic>
+        <p:nvPicPr>
+          <p:cNvPr id="5" name="Picture 4">
+            <a:extLst>
+              <a:ext uri="{FF2B5EF4-FFF2-40B4-BE49-F238E27FC236}">
+                <a16:creationId xmlns:a16="http://schemas.microsoft.com/office/drawing/2014/main" id="{0AEFADB3-FD2E-DA0D-07E7-B93C0A90DBA0}"/>
+              </a:ext>
+            </a:extLst>
+          </p:cNvPr>
+          <p:cNvPicPr>
+            <a:picLocks noChangeAspect="1"/>
+          </p:cNvPicPr>
+          <p:nvPr/>
+        </p:nvPicPr>
+        <p:blipFill>
+          <a:blip r:embed="rId4">
+            <a:extLst>
+              <a:ext uri="{837473B0-CC2E-450A-ABE3-18F120FF3D39}">
+                <a1611:picAttrSrcUrl xmlns:a1611="http://schemas.microsoft.com/office/drawing/2016/11/main" r:id="rId5"/>
               </a:ext>
             </a:extLst>
           </a:blip>
@@ -10376,10 +11369,10 @@
           <p:nvPr/>
         </p:nvPicPr>
         <p:blipFill>
-          <a:blip r:embed="rId4">
+          <a:blip r:embed="rId6">
             <a:extLst>
               <a:ext uri="{837473B0-CC2E-450A-ABE3-18F120FF3D39}">
-                <a1611:picAttrSrcUrl xmlns:a1611="http://schemas.microsoft.com/office/drawing/2016/11/main" r:id="rId5"/>
+                <a1611:picAttrSrcUrl xmlns:a1611="http://schemas.microsoft.com/office/drawing/2016/11/main" r:id="rId7"/>
               </a:ext>
             </a:extLst>
           </a:blip>
@@ -10412,10 +11405,10 @@
           <p:nvPr/>
         </p:nvPicPr>
         <p:blipFill>
-          <a:blip r:embed="rId6">
+          <a:blip r:embed="rId8">
             <a:extLst>
               <a:ext uri="{837473B0-CC2E-450A-ABE3-18F120FF3D39}">
-                <a1611:picAttrSrcUrl xmlns:a1611="http://schemas.microsoft.com/office/drawing/2016/11/main" r:id="rId7"/>
+                <a1611:picAttrSrcUrl xmlns:a1611="http://schemas.microsoft.com/office/drawing/2016/11/main" r:id="rId9"/>
               </a:ext>
             </a:extLst>
           </a:blip>
@@ -10448,10 +11441,10 @@
           <p:nvPr/>
         </p:nvPicPr>
         <p:blipFill>
-          <a:blip r:embed="rId8">
+          <a:blip r:embed="rId10">
             <a:extLst>
               <a:ext uri="{837473B0-CC2E-450A-ABE3-18F120FF3D39}">
-                <a1611:picAttrSrcUrl xmlns:a1611="http://schemas.microsoft.com/office/drawing/2016/11/main" r:id="rId9"/>
+                <a1611:picAttrSrcUrl xmlns:a1611="http://schemas.microsoft.com/office/drawing/2016/11/main" r:id="rId11"/>
               </a:ext>
             </a:extLst>
           </a:blip>
@@ -10484,10 +11477,10 @@
           <p:nvPr/>
         </p:nvPicPr>
         <p:blipFill>
-          <a:blip r:embed="rId10">
+          <a:blip r:embed="rId12">
             <a:extLst>
               <a:ext uri="{837473B0-CC2E-450A-ABE3-18F120FF3D39}">
-                <a1611:picAttrSrcUrl xmlns:a1611="http://schemas.microsoft.com/office/drawing/2016/11/main" r:id="rId11"/>
+                <a1611:picAttrSrcUrl xmlns:a1611="http://schemas.microsoft.com/office/drawing/2016/11/main" r:id="rId13"/>
               </a:ext>
             </a:extLst>
           </a:blip>
@@ -10497,7 +11490,7 @@
         </p:blipFill>
         <p:spPr>
           <a:xfrm>
-            <a:off x="6574364" y="5590568"/>
+            <a:off x="5362759" y="5634200"/>
             <a:ext cx="1675531" cy="942486"/>
           </a:xfrm>
           <a:prstGeom prst="rect">
@@ -10520,10 +11513,10 @@
           <p:nvPr/>
         </p:nvPicPr>
         <p:blipFill>
-          <a:blip r:embed="rId12">
+          <a:blip r:embed="rId14">
             <a:extLst>
               <a:ext uri="{837473B0-CC2E-450A-ABE3-18F120FF3D39}">
-                <a1611:picAttrSrcUrl xmlns:a1611="http://schemas.microsoft.com/office/drawing/2016/11/main" r:id="rId13"/>
+                <a1611:picAttrSrcUrl xmlns:a1611="http://schemas.microsoft.com/office/drawing/2016/11/main" r:id="rId15"/>
               </a:ext>
             </a:extLst>
           </a:blip>
@@ -10533,7 +11526,7 @@
         </p:blipFill>
         <p:spPr>
           <a:xfrm>
-            <a:off x="3380953" y="5504707"/>
+            <a:off x="3871561" y="5516048"/>
             <a:ext cx="1114208" cy="1114208"/>
           </a:xfrm>
           <a:prstGeom prst="rect">
@@ -10543,42 +11536,6 @@
       </p:pic>
       <p:pic>
         <p:nvPicPr>
-          <p:cNvPr id="14" name="Picture 13">
-            <a:extLst>
-              <a:ext uri="{FF2B5EF4-FFF2-40B4-BE49-F238E27FC236}">
-                <a16:creationId xmlns:a16="http://schemas.microsoft.com/office/drawing/2014/main" id="{6F37C7C3-0379-19D0-342F-52F379687AB1}"/>
-              </a:ext>
-            </a:extLst>
-          </p:cNvPr>
-          <p:cNvPicPr>
-            <a:picLocks noChangeAspect="1"/>
-          </p:cNvPicPr>
-          <p:nvPr/>
-        </p:nvPicPr>
-        <p:blipFill>
-          <a:blip r:embed="rId14">
-            <a:extLst>
-              <a:ext uri="{837473B0-CC2E-450A-ABE3-18F120FF3D39}">
-                <a1611:picAttrSrcUrl xmlns:a1611="http://schemas.microsoft.com/office/drawing/2016/11/main" r:id="rId15"/>
-              </a:ext>
-            </a:extLst>
-          </a:blip>
-          <a:stretch>
-            <a:fillRect/>
-          </a:stretch>
-        </p:blipFill>
-        <p:spPr>
-          <a:xfrm>
-            <a:off x="4888406" y="5544524"/>
-            <a:ext cx="1685958" cy="948351"/>
-          </a:xfrm>
-          <a:prstGeom prst="rect">
-            <a:avLst/>
-          </a:prstGeom>
-        </p:spPr>
-      </p:pic>
-      <p:pic>
-        <p:nvPicPr>
           <p:cNvPr id="1026" name="Picture 2" descr="Minsk, Belarus - 03-27-2023. OpenAI and ChatGPT logo. artifical chatbot  system. chat bot button for web, app and phone icon symbol. editorial  vector illustration 21972603 Vector Art at Vecteezy">
             <a:extLst>
               <a:ext uri="{FF2B5EF4-FFF2-40B4-BE49-F238E27FC236}">
@@ -10606,7 +11563,7 @@
         </p:blipFill>
         <p:spPr bwMode="auto">
           <a:xfrm>
-            <a:off x="8410792" y="5560069"/>
+            <a:off x="9490989" y="5560067"/>
             <a:ext cx="1114208" cy="1114208"/>
           </a:xfrm>
           <a:prstGeom prst="rect">

</xml_diff>

<commit_message>
added css grid examples
</commit_message>
<xml_diff>
--- a/slides/Lecture1.pptx
+++ b/slides/Lecture1.pptx
@@ -5,7 +5,7 @@
     <p:sldMasterId id="2147483648" r:id="rId1"/>
   </p:sldMasterIdLst>
   <p:notesMasterIdLst>
-    <p:notesMasterId r:id="rId44"/>
+    <p:notesMasterId r:id="rId40"/>
   </p:notesMasterIdLst>
   <p:sldIdLst>
     <p:sldId id="256" r:id="rId2"/>
@@ -44,12 +44,8 @@
     <p:sldId id="300" r:id="rId35"/>
     <p:sldId id="301" r:id="rId36"/>
     <p:sldId id="303" r:id="rId37"/>
-    <p:sldId id="289" r:id="rId38"/>
-    <p:sldId id="284" r:id="rId39"/>
-    <p:sldId id="271" r:id="rId40"/>
-    <p:sldId id="272" r:id="rId41"/>
-    <p:sldId id="273" r:id="rId42"/>
-    <p:sldId id="274" r:id="rId43"/>
+    <p:sldId id="304" r:id="rId38"/>
+    <p:sldId id="289" r:id="rId39"/>
   </p:sldIdLst>
   <p:sldSz cx="12192000" cy="6858000"/>
   <p:notesSz cx="6858000" cy="9144000"/>
@@ -9777,7 +9773,7 @@
           <p:cNvPr id="2" name="Title 1">
             <a:extLst>
               <a:ext uri="{FF2B5EF4-FFF2-40B4-BE49-F238E27FC236}">
-                <a16:creationId xmlns:a16="http://schemas.microsoft.com/office/drawing/2014/main" id="{1351CCE4-A17A-54C7-791C-5EC433B09661}"/>
+                <a16:creationId xmlns:a16="http://schemas.microsoft.com/office/drawing/2014/main" id="{606A405C-F76A-61F4-8E8C-58C843DDD736}"/>
               </a:ext>
             </a:extLst>
           </p:cNvPr>
@@ -9795,7 +9791,7 @@
           <a:p>
             <a:r>
               <a:rPr lang="en-US" dirty="0"/>
-              <a:t>Backup slides</a:t>
+              <a:t>Final Takeaway</a:t>
             </a:r>
           </a:p>
         </p:txBody>
@@ -9805,7 +9801,7 @@
           <p:cNvPr id="3" name="Content Placeholder 2">
             <a:extLst>
               <a:ext uri="{FF2B5EF4-FFF2-40B4-BE49-F238E27FC236}">
-                <a16:creationId xmlns:a16="http://schemas.microsoft.com/office/drawing/2014/main" id="{DE136F43-A2D1-0ED3-CA49-35D8DE89FC44}"/>
+                <a16:creationId xmlns:a16="http://schemas.microsoft.com/office/drawing/2014/main" id="{5F590423-0721-6397-9F35-EBA20CEC9704}"/>
               </a:ext>
             </a:extLst>
           </p:cNvPr>
@@ -9821,7 +9817,25 @@
           <a:bodyPr/>
           <a:lstStyle/>
           <a:p>
-            <a:endParaRPr lang="en-US"/>
+            <a:r>
+              <a:rPr lang="en-US" dirty="0"/>
+              <a:t>There's no magic solution to the software crisis.</a:t>
+            </a:r>
+          </a:p>
+          <a:p>
+            <a:r>
+              <a:rPr lang="en-US" dirty="0"/>
+              <a:t>Instead of seeking a single fix, we must address the fundamental nature of software.</a:t>
+            </a:r>
+          </a:p>
+          <a:p>
+            <a:r>
+              <a:rPr lang="en-US" dirty="0"/>
+              <a:t>The road to better software is paved with small, disciplined steps and the cultivation of great talent.</a:t>
+            </a:r>
+          </a:p>
+          <a:p>
+            <a:endParaRPr lang="en-US" dirty="0"/>
           </a:p>
         </p:txBody>
       </p:sp>
@@ -9830,7 +9844,7 @@
           <p:cNvPr id="4" name="Slide Number Placeholder 3">
             <a:extLst>
               <a:ext uri="{FF2B5EF4-FFF2-40B4-BE49-F238E27FC236}">
-                <a16:creationId xmlns:a16="http://schemas.microsoft.com/office/drawing/2014/main" id="{EA9A51AD-DAB4-490B-61FD-4BAD314648C2}"/>
+                <a16:creationId xmlns:a16="http://schemas.microsoft.com/office/drawing/2014/main" id="{5FDA1BA6-F94F-7A9B-42CD-9AE64BF0E3E1}"/>
               </a:ext>
             </a:extLst>
           </p:cNvPr>
@@ -9857,7 +9871,7 @@
     </p:spTree>
     <p:extLst>
       <p:ext uri="{BB962C8B-B14F-4D97-AF65-F5344CB8AC3E}">
-        <p14:creationId xmlns:p14="http://schemas.microsoft.com/office/powerpoint/2010/main" val="4309861"/>
+        <p14:creationId xmlns:p14="http://schemas.microsoft.com/office/powerpoint/2010/main" val="3132436037"/>
       </p:ext>
     </p:extLst>
   </p:cSld>
@@ -9889,7 +9903,7 @@
           <p:cNvPr id="2" name="Title 1">
             <a:extLst>
               <a:ext uri="{FF2B5EF4-FFF2-40B4-BE49-F238E27FC236}">
-                <a16:creationId xmlns:a16="http://schemas.microsoft.com/office/drawing/2014/main" id="{923341A6-15AB-49BC-59E9-9FE750803B9B}"/>
+                <a16:creationId xmlns:a16="http://schemas.microsoft.com/office/drawing/2014/main" id="{1351CCE4-A17A-54C7-791C-5EC433B09661}"/>
               </a:ext>
             </a:extLst>
           </p:cNvPr>
@@ -9907,7 +9921,7 @@
           <a:p>
             <a:r>
               <a:rPr lang="en-US" dirty="0"/>
-              <a:t>Final Thought</a:t>
+              <a:t>Backup slides</a:t>
             </a:r>
           </a:p>
         </p:txBody>
@@ -9917,7 +9931,7 @@
           <p:cNvPr id="3" name="Content Placeholder 2">
             <a:extLst>
               <a:ext uri="{FF2B5EF4-FFF2-40B4-BE49-F238E27FC236}">
-                <a16:creationId xmlns:a16="http://schemas.microsoft.com/office/drawing/2014/main" id="{AC782434-84C2-3901-BDA3-4E7446DBA3AE}"/>
+                <a16:creationId xmlns:a16="http://schemas.microsoft.com/office/drawing/2014/main" id="{DE136F43-A2D1-0ED3-CA49-35D8DE89FC44}"/>
               </a:ext>
             </a:extLst>
           </p:cNvPr>
@@ -9933,195 +9947,16 @@
           <a:bodyPr/>
           <a:lstStyle/>
           <a:p>
-            <a:pPr marL="0" indent="0">
-              <a:buNone/>
-            </a:pPr>
-            <a:r>
-              <a:rPr lang="en-US" i="1" dirty="0"/>
-              <a:t>The</a:t>
-            </a:r>
-            <a:r>
-              <a:rPr lang="en-US" dirty="0"/>
-              <a:t> </a:t>
-            </a:r>
-            <a:r>
-              <a:rPr lang="en-US" i="1" dirty="0"/>
-              <a:t>computing scientist‘s main challenge</a:t>
-            </a:r>
-            <a:r>
-              <a:rPr lang="en-US" dirty="0"/>
-              <a:t> is </a:t>
-            </a:r>
-            <a:r>
-              <a:rPr lang="en-US" i="1" dirty="0"/>
-              <a:t>not</a:t>
-            </a:r>
-            <a:r>
-              <a:rPr lang="en-US" dirty="0"/>
-              <a:t> to </a:t>
-            </a:r>
-            <a:r>
-              <a:rPr lang="en-US" i="1" dirty="0"/>
-              <a:t>get confused</a:t>
-            </a:r>
-            <a:r>
-              <a:rPr lang="en-US" dirty="0"/>
-              <a:t> by the </a:t>
-            </a:r>
-            <a:r>
-              <a:rPr lang="en-US" i="1" dirty="0"/>
-              <a:t>complexities</a:t>
-            </a:r>
-            <a:r>
-              <a:rPr lang="en-US" dirty="0"/>
-              <a:t> of </a:t>
-            </a:r>
-            <a:r>
-              <a:rPr lang="en-US" i="1" dirty="0"/>
-              <a:t>his own making</a:t>
-            </a:r>
-            <a:r>
-              <a:rPr lang="zh-CN" altLang="en-US" i="1" dirty="0"/>
-              <a:t>        </a:t>
-            </a:r>
-            <a:r>
-              <a:rPr lang="en-US" altLang="zh-CN" i="1" dirty="0"/>
-              <a:t>-----</a:t>
-            </a:r>
-            <a:r>
-              <a:rPr lang="en-US" dirty="0"/>
-              <a:t> </a:t>
-            </a:r>
-            <a:r>
-              <a:rPr lang="en-US" dirty="0" err="1"/>
-              <a:t>Edsger</a:t>
-            </a:r>
-            <a:r>
-              <a:rPr lang="en-US" dirty="0"/>
-              <a:t> Dijkstra</a:t>
-            </a:r>
-            <a:endParaRPr lang="en-US" altLang="zh-CN" i="1" dirty="0"/>
-          </a:p>
-          <a:p>
-            <a:pPr marL="0" indent="0">
-              <a:buNone/>
-            </a:pPr>
-            <a:endParaRPr lang="en-US" i="1" dirty="0"/>
-          </a:p>
-        </p:txBody>
-      </p:sp>
-      <p:pic>
-        <p:nvPicPr>
-          <p:cNvPr id="1026" name="Picture 2" descr="Edsger W. Dijkstra">
-            <a:extLst>
-              <a:ext uri="{FF2B5EF4-FFF2-40B4-BE49-F238E27FC236}">
-                <a16:creationId xmlns:a16="http://schemas.microsoft.com/office/drawing/2014/main" id="{5A8E9FF2-4C6E-634C-1DB0-5496B72A4469}"/>
-              </a:ext>
-            </a:extLst>
-          </p:cNvPr>
-          <p:cNvPicPr>
-            <a:picLocks noChangeAspect="1" noChangeArrowheads="1"/>
-          </p:cNvPicPr>
-          <p:nvPr/>
-        </p:nvPicPr>
-        <p:blipFill>
-          <a:blip r:embed="rId2">
-            <a:extLst>
-              <a:ext uri="{28A0092B-C50C-407E-A947-70E740481C1C}">
-                <a14:useLocalDpi xmlns:a14="http://schemas.microsoft.com/office/drawing/2010/main" val="0"/>
-              </a:ext>
-            </a:extLst>
-          </a:blip>
-          <a:srcRect/>
-          <a:stretch>
-            <a:fillRect/>
-          </a:stretch>
-        </p:blipFill>
-        <p:spPr bwMode="auto">
-          <a:xfrm>
-            <a:off x="4508500" y="3136900"/>
-            <a:ext cx="3175000" cy="3175000"/>
-          </a:xfrm>
-          <a:prstGeom prst="rect">
-            <a:avLst/>
-          </a:prstGeom>
-          <a:noFill/>
-          <a:extLst>
-            <a:ext uri="{909E8E84-426E-40DD-AFC4-6F175D3DCCD1}">
-              <a14:hiddenFill xmlns:a14="http://schemas.microsoft.com/office/drawing/2010/main">
-                <a:solidFill>
-                  <a:srgbClr val="FFFFFF"/>
-                </a:solidFill>
-              </a14:hiddenFill>
-            </a:ext>
-          </a:extLst>
-        </p:spPr>
-      </p:pic>
-      <p:sp>
-        <p:nvSpPr>
-          <p:cNvPr id="4" name="TextBox 3">
-            <a:extLst>
-              <a:ext uri="{FF2B5EF4-FFF2-40B4-BE49-F238E27FC236}">
-                <a16:creationId xmlns:a16="http://schemas.microsoft.com/office/drawing/2014/main" id="{FB3E9975-F465-1798-8ED0-60D7CD94AD43}"/>
-              </a:ext>
-            </a:extLst>
-          </p:cNvPr>
-          <p:cNvSpPr txBox="1"/>
-          <p:nvPr/>
-        </p:nvSpPr>
-        <p:spPr>
-          <a:xfrm>
-            <a:off x="4627489" y="6480019"/>
-            <a:ext cx="2937022" cy="215444"/>
-          </a:xfrm>
-          <a:prstGeom prst="rect">
-            <a:avLst/>
-          </a:prstGeom>
-          <a:noFill/>
-        </p:spPr>
-        <p:txBody>
-          <a:bodyPr wrap="none" rtlCol="0">
-            <a:spAutoFit/>
-          </a:bodyPr>
-          <a:lstStyle/>
-          <a:p>
-            <a:r>
-              <a:rPr lang="en-US" sz="800" dirty="0"/>
-              <a:t>https://</a:t>
-            </a:r>
-            <a:r>
-              <a:rPr lang="en-US" sz="800" dirty="0" err="1"/>
-              <a:t>cacm.acm.org</a:t>
-            </a:r>
-            <a:r>
-              <a:rPr lang="en-US" sz="800" dirty="0"/>
-              <a:t>/news/an-interview-with-</a:t>
-            </a:r>
-            <a:r>
-              <a:rPr lang="en-US" sz="800" dirty="0" err="1"/>
-              <a:t>edsger</a:t>
-            </a:r>
-            <a:r>
-              <a:rPr lang="en-US" sz="800" dirty="0"/>
-              <a:t>-w-</a:t>
-            </a:r>
-            <a:r>
-              <a:rPr lang="en-US" sz="800" dirty="0" err="1"/>
-              <a:t>dijkstra</a:t>
-            </a:r>
-            <a:r>
-              <a:rPr lang="en-US" sz="800" dirty="0"/>
-              <a:t>/</a:t>
-            </a:r>
-          </a:p>
-        </p:txBody>
-      </p:sp>
-      <p:sp>
-        <p:nvSpPr>
-          <p:cNvPr id="5" name="Slide Number Placeholder 4">
-            <a:extLst>
-              <a:ext uri="{FF2B5EF4-FFF2-40B4-BE49-F238E27FC236}">
-                <a16:creationId xmlns:a16="http://schemas.microsoft.com/office/drawing/2014/main" id="{3958F663-17E4-6B39-86B0-7D61EA69DD3F}"/>
+            <a:endParaRPr lang="en-US"/>
+          </a:p>
+        </p:txBody>
+      </p:sp>
+      <p:sp>
+        <p:nvSpPr>
+          <p:cNvPr id="4" name="Slide Number Placeholder 3">
+            <a:extLst>
+              <a:ext uri="{FF2B5EF4-FFF2-40B4-BE49-F238E27FC236}">
+                <a16:creationId xmlns:a16="http://schemas.microsoft.com/office/drawing/2014/main" id="{EA9A51AD-DAB4-490B-61FD-4BAD314648C2}"/>
               </a:ext>
             </a:extLst>
           </p:cNvPr>
@@ -10148,136 +9983,7 @@
     </p:spTree>
     <p:extLst>
       <p:ext uri="{BB962C8B-B14F-4D97-AF65-F5344CB8AC3E}">
-        <p14:creationId xmlns:p14="http://schemas.microsoft.com/office/powerpoint/2010/main" val="1880166139"/>
-      </p:ext>
-    </p:extLst>
-  </p:cSld>
-  <p:clrMapOvr>
-    <a:masterClrMapping/>
-  </p:clrMapOvr>
-</p:sld>
-</file>
-
-<file path=ppt/slides/slide39.xml><?xml version="1.0" encoding="utf-8"?>
-<p:sld xmlns:a="http://schemas.openxmlformats.org/drawingml/2006/main" xmlns:r="http://schemas.openxmlformats.org/officeDocument/2006/relationships" xmlns:p="http://schemas.openxmlformats.org/presentationml/2006/main">
-  <p:cSld>
-    <p:spTree>
-      <p:nvGrpSpPr>
-        <p:cNvPr id="1" name=""/>
-        <p:cNvGrpSpPr/>
-        <p:nvPr/>
-      </p:nvGrpSpPr>
-      <p:grpSpPr>
-        <a:xfrm>
-          <a:off x="0" y="0"/>
-          <a:ext cx="0" cy="0"/>
-          <a:chOff x="0" y="0"/>
-          <a:chExt cx="0" cy="0"/>
-        </a:xfrm>
-      </p:grpSpPr>
-      <p:sp>
-        <p:nvSpPr>
-          <p:cNvPr id="2" name="Title 1">
-            <a:extLst>
-              <a:ext uri="{FF2B5EF4-FFF2-40B4-BE49-F238E27FC236}">
-                <a16:creationId xmlns:a16="http://schemas.microsoft.com/office/drawing/2014/main" id="{12F2C704-08E8-7DE8-9EA6-4D8CA2E10937}"/>
-              </a:ext>
-            </a:extLst>
-          </p:cNvPr>
-          <p:cNvSpPr>
-            <a:spLocks noGrp="1"/>
-          </p:cNvSpPr>
-          <p:nvPr>
-            <p:ph type="title"/>
-          </p:nvPr>
-        </p:nvSpPr>
-        <p:spPr/>
-        <p:txBody>
-          <a:bodyPr/>
-          <a:lstStyle/>
-          <a:p>
-            <a:r>
-              <a:rPr lang="en-US" dirty="0"/>
-              <a:t>Main course topics</a:t>
-            </a:r>
-          </a:p>
-        </p:txBody>
-      </p:sp>
-      <p:sp>
-        <p:nvSpPr>
-          <p:cNvPr id="3" name="Content Placeholder 2">
-            <a:extLst>
-              <a:ext uri="{FF2B5EF4-FFF2-40B4-BE49-F238E27FC236}">
-                <a16:creationId xmlns:a16="http://schemas.microsoft.com/office/drawing/2014/main" id="{3B815FE5-78DD-ED18-7743-B67F38B9E81C}"/>
-              </a:ext>
-            </a:extLst>
-          </p:cNvPr>
-          <p:cNvSpPr>
-            <a:spLocks noGrp="1"/>
-          </p:cNvSpPr>
-          <p:nvPr>
-            <p:ph idx="1"/>
-          </p:nvPr>
-        </p:nvSpPr>
-        <p:spPr/>
-        <p:txBody>
-          <a:bodyPr/>
-          <a:lstStyle/>
-          <a:p>
-            <a:r>
-              <a:rPr lang="en-US" dirty="0"/>
-              <a:t>How to write </a:t>
-            </a:r>
-            <a:r>
-              <a:rPr lang="en-US" u="sng" dirty="0"/>
-              <a:t>quality</a:t>
-            </a:r>
-            <a:r>
-              <a:rPr lang="en-US" dirty="0"/>
-              <a:t> code?</a:t>
-            </a:r>
-          </a:p>
-          <a:p>
-            <a:endParaRPr lang="en-US" dirty="0"/>
-          </a:p>
-          <a:p>
-            <a:endParaRPr lang="en-US" dirty="0"/>
-          </a:p>
-        </p:txBody>
-      </p:sp>
-      <p:sp>
-        <p:nvSpPr>
-          <p:cNvPr id="4" name="Slide Number Placeholder 3">
-            <a:extLst>
-              <a:ext uri="{FF2B5EF4-FFF2-40B4-BE49-F238E27FC236}">
-                <a16:creationId xmlns:a16="http://schemas.microsoft.com/office/drawing/2014/main" id="{D26B2A2A-B152-A024-B999-DFB1BFBBFD40}"/>
-              </a:ext>
-            </a:extLst>
-          </p:cNvPr>
-          <p:cNvSpPr>
-            <a:spLocks noGrp="1"/>
-          </p:cNvSpPr>
-          <p:nvPr>
-            <p:ph type="sldNum" sz="quarter" idx="12"/>
-          </p:nvPr>
-        </p:nvSpPr>
-        <p:spPr/>
-        <p:txBody>
-          <a:bodyPr/>
-          <a:lstStyle/>
-          <a:p>
-            <a:fld id="{3AB30462-0FD5-604F-8C98-DCC91BE84583}" type="slidenum">
-              <a:rPr lang="en-US" smtClean="0"/>
-              <a:t>39</a:t>
-            </a:fld>
-            <a:endParaRPr lang="en-US"/>
-          </a:p>
-        </p:txBody>
-      </p:sp>
-    </p:spTree>
-    <p:extLst>
-      <p:ext uri="{BB962C8B-B14F-4D97-AF65-F5344CB8AC3E}">
-        <p14:creationId xmlns:p14="http://schemas.microsoft.com/office/powerpoint/2010/main" val="4114217993"/>
+        <p14:creationId xmlns:p14="http://schemas.microsoft.com/office/powerpoint/2010/main" val="4309861"/>
       </p:ext>
     </p:extLst>
   </p:cSld>
@@ -10554,593 +10260,6 @@
     <p:extLst>
       <p:ext uri="{BB962C8B-B14F-4D97-AF65-F5344CB8AC3E}">
         <p14:creationId xmlns:p14="http://schemas.microsoft.com/office/powerpoint/2010/main" val="1336265694"/>
-      </p:ext>
-    </p:extLst>
-  </p:cSld>
-  <p:clrMapOvr>
-    <a:masterClrMapping/>
-  </p:clrMapOvr>
-</p:sld>
-</file>
-
-<file path=ppt/slides/slide40.xml><?xml version="1.0" encoding="utf-8"?>
-<p:sld xmlns:a="http://schemas.openxmlformats.org/drawingml/2006/main" xmlns:r="http://schemas.openxmlformats.org/officeDocument/2006/relationships" xmlns:p="http://schemas.openxmlformats.org/presentationml/2006/main">
-  <p:cSld>
-    <p:spTree>
-      <p:nvGrpSpPr>
-        <p:cNvPr id="1" name="">
-          <a:extLst>
-            <a:ext uri="{FF2B5EF4-FFF2-40B4-BE49-F238E27FC236}">
-              <a16:creationId xmlns:a16="http://schemas.microsoft.com/office/drawing/2014/main" id="{A52F73ED-EFBA-F3DF-4D3E-88108C3D1A52}"/>
-            </a:ext>
-          </a:extLst>
-        </p:cNvPr>
-        <p:cNvGrpSpPr/>
-        <p:nvPr/>
-      </p:nvGrpSpPr>
-      <p:grpSpPr>
-        <a:xfrm>
-          <a:off x="0" y="0"/>
-          <a:ext cx="0" cy="0"/>
-          <a:chOff x="0" y="0"/>
-          <a:chExt cx="0" cy="0"/>
-        </a:xfrm>
-      </p:grpSpPr>
-      <p:sp>
-        <p:nvSpPr>
-          <p:cNvPr id="2" name="Title 1">
-            <a:extLst>
-              <a:ext uri="{FF2B5EF4-FFF2-40B4-BE49-F238E27FC236}">
-                <a16:creationId xmlns:a16="http://schemas.microsoft.com/office/drawing/2014/main" id="{6FCD59A0-294B-0A15-110B-4F03E294377F}"/>
-              </a:ext>
-            </a:extLst>
-          </p:cNvPr>
-          <p:cNvSpPr>
-            <a:spLocks noGrp="1"/>
-          </p:cNvSpPr>
-          <p:nvPr>
-            <p:ph type="title"/>
-          </p:nvPr>
-        </p:nvSpPr>
-        <p:spPr/>
-        <p:txBody>
-          <a:bodyPr/>
-          <a:lstStyle/>
-          <a:p>
-            <a:r>
-              <a:rPr lang="en-US" dirty="0"/>
-              <a:t>Main course topics</a:t>
-            </a:r>
-          </a:p>
-        </p:txBody>
-      </p:sp>
-      <p:sp>
-        <p:nvSpPr>
-          <p:cNvPr id="3" name="Content Placeholder 2">
-            <a:extLst>
-              <a:ext uri="{FF2B5EF4-FFF2-40B4-BE49-F238E27FC236}">
-                <a16:creationId xmlns:a16="http://schemas.microsoft.com/office/drawing/2014/main" id="{44070496-D261-9FCC-8B1F-5DF810745D54}"/>
-              </a:ext>
-            </a:extLst>
-          </p:cNvPr>
-          <p:cNvSpPr>
-            <a:spLocks noGrp="1"/>
-          </p:cNvSpPr>
-          <p:nvPr>
-            <p:ph idx="1"/>
-          </p:nvPr>
-        </p:nvSpPr>
-        <p:spPr/>
-        <p:txBody>
-          <a:bodyPr/>
-          <a:lstStyle/>
-          <a:p>
-            <a:r>
-              <a:rPr lang="en-US" dirty="0"/>
-              <a:t>How to write </a:t>
-            </a:r>
-            <a:r>
-              <a:rPr lang="en-US" u="sng" dirty="0"/>
-              <a:t>quality</a:t>
-            </a:r>
-            <a:r>
-              <a:rPr lang="en-US" dirty="0"/>
-              <a:t> code?</a:t>
-            </a:r>
-          </a:p>
-          <a:p>
-            <a:pPr lvl="1"/>
-            <a:r>
-              <a:rPr lang="en-US" altLang="zh-CN" dirty="0"/>
-              <a:t>Usable</a:t>
-            </a:r>
-            <a:endParaRPr lang="en-US" dirty="0"/>
-          </a:p>
-          <a:p>
-            <a:pPr lvl="1"/>
-            <a:r>
-              <a:rPr lang="en-US" dirty="0"/>
-              <a:t>Less error-prone</a:t>
-            </a:r>
-          </a:p>
-          <a:p>
-            <a:pPr lvl="1"/>
-            <a:r>
-              <a:rPr lang="en-US" dirty="0"/>
-              <a:t>Easier to maintain</a:t>
-            </a:r>
-          </a:p>
-          <a:p>
-            <a:pPr lvl="1"/>
-            <a:r>
-              <a:rPr lang="en-US" dirty="0"/>
-              <a:t>Reusable</a:t>
-            </a:r>
-          </a:p>
-          <a:p>
-            <a:pPr lvl="1"/>
-            <a:r>
-              <a:rPr lang="en-US" dirty="0"/>
-              <a:t>…</a:t>
-            </a:r>
-          </a:p>
-          <a:p>
-            <a:endParaRPr lang="en-US" dirty="0"/>
-          </a:p>
-          <a:p>
-            <a:pPr lvl="1"/>
-            <a:endParaRPr lang="en-US" dirty="0"/>
-          </a:p>
-          <a:p>
-            <a:endParaRPr lang="en-US" dirty="0"/>
-          </a:p>
-          <a:p>
-            <a:endParaRPr lang="en-US" dirty="0"/>
-          </a:p>
-        </p:txBody>
-      </p:sp>
-      <p:sp>
-        <p:nvSpPr>
-          <p:cNvPr id="4" name="Slide Number Placeholder 3">
-            <a:extLst>
-              <a:ext uri="{FF2B5EF4-FFF2-40B4-BE49-F238E27FC236}">
-                <a16:creationId xmlns:a16="http://schemas.microsoft.com/office/drawing/2014/main" id="{A3F2E659-F8C4-5B1C-96ED-AA2E86EABE38}"/>
-              </a:ext>
-            </a:extLst>
-          </p:cNvPr>
-          <p:cNvSpPr>
-            <a:spLocks noGrp="1"/>
-          </p:cNvSpPr>
-          <p:nvPr>
-            <p:ph type="sldNum" sz="quarter" idx="12"/>
-          </p:nvPr>
-        </p:nvSpPr>
-        <p:spPr/>
-        <p:txBody>
-          <a:bodyPr/>
-          <a:lstStyle/>
-          <a:p>
-            <a:fld id="{3AB30462-0FD5-604F-8C98-DCC91BE84583}" type="slidenum">
-              <a:rPr lang="en-US" smtClean="0"/>
-              <a:t>40</a:t>
-            </a:fld>
-            <a:endParaRPr lang="en-US"/>
-          </a:p>
-        </p:txBody>
-      </p:sp>
-    </p:spTree>
-    <p:extLst>
-      <p:ext uri="{BB962C8B-B14F-4D97-AF65-F5344CB8AC3E}">
-        <p14:creationId xmlns:p14="http://schemas.microsoft.com/office/powerpoint/2010/main" val="3897885859"/>
-      </p:ext>
-    </p:extLst>
-  </p:cSld>
-  <p:clrMapOvr>
-    <a:masterClrMapping/>
-  </p:clrMapOvr>
-</p:sld>
-</file>
-
-<file path=ppt/slides/slide41.xml><?xml version="1.0" encoding="utf-8"?>
-<p:sld xmlns:a="http://schemas.openxmlformats.org/drawingml/2006/main" xmlns:r="http://schemas.openxmlformats.org/officeDocument/2006/relationships" xmlns:p="http://schemas.openxmlformats.org/presentationml/2006/main">
-  <p:cSld>
-    <p:spTree>
-      <p:nvGrpSpPr>
-        <p:cNvPr id="1" name="">
-          <a:extLst>
-            <a:ext uri="{FF2B5EF4-FFF2-40B4-BE49-F238E27FC236}">
-              <a16:creationId xmlns:a16="http://schemas.microsoft.com/office/drawing/2014/main" id="{BA7C86BA-5877-CC53-4DEA-AE7B11D695B3}"/>
-            </a:ext>
-          </a:extLst>
-        </p:cNvPr>
-        <p:cNvGrpSpPr/>
-        <p:nvPr/>
-      </p:nvGrpSpPr>
-      <p:grpSpPr>
-        <a:xfrm>
-          <a:off x="0" y="0"/>
-          <a:ext cx="0" cy="0"/>
-          <a:chOff x="0" y="0"/>
-          <a:chExt cx="0" cy="0"/>
-        </a:xfrm>
-      </p:grpSpPr>
-      <p:sp>
-        <p:nvSpPr>
-          <p:cNvPr id="2" name="Title 1">
-            <a:extLst>
-              <a:ext uri="{FF2B5EF4-FFF2-40B4-BE49-F238E27FC236}">
-                <a16:creationId xmlns:a16="http://schemas.microsoft.com/office/drawing/2014/main" id="{FA7855FC-A2E8-8DBE-CA4A-68FDAA8A4332}"/>
-              </a:ext>
-            </a:extLst>
-          </p:cNvPr>
-          <p:cNvSpPr>
-            <a:spLocks noGrp="1"/>
-          </p:cNvSpPr>
-          <p:nvPr>
-            <p:ph type="title"/>
-          </p:nvPr>
-        </p:nvSpPr>
-        <p:spPr/>
-        <p:txBody>
-          <a:bodyPr/>
-          <a:lstStyle/>
-          <a:p>
-            <a:r>
-              <a:rPr lang="en-US" dirty="0"/>
-              <a:t>Main course topics</a:t>
-            </a:r>
-          </a:p>
-        </p:txBody>
-      </p:sp>
-      <p:sp>
-        <p:nvSpPr>
-          <p:cNvPr id="3" name="Content Placeholder 2">
-            <a:extLst>
-              <a:ext uri="{FF2B5EF4-FFF2-40B4-BE49-F238E27FC236}">
-                <a16:creationId xmlns:a16="http://schemas.microsoft.com/office/drawing/2014/main" id="{E21D6EEC-074C-6F97-56D2-DCA3DB28292F}"/>
-              </a:ext>
-            </a:extLst>
-          </p:cNvPr>
-          <p:cNvSpPr>
-            <a:spLocks noGrp="1"/>
-          </p:cNvSpPr>
-          <p:nvPr>
-            <p:ph idx="1"/>
-          </p:nvPr>
-        </p:nvSpPr>
-        <p:spPr/>
-        <p:txBody>
-          <a:bodyPr/>
-          <a:lstStyle/>
-          <a:p>
-            <a:r>
-              <a:rPr lang="en-US" dirty="0"/>
-              <a:t>How to write </a:t>
-            </a:r>
-            <a:r>
-              <a:rPr lang="en-US" u="sng" dirty="0"/>
-              <a:t>quality</a:t>
-            </a:r>
-            <a:r>
-              <a:rPr lang="en-US" dirty="0"/>
-              <a:t> code?</a:t>
-            </a:r>
-          </a:p>
-          <a:p>
-            <a:pPr lvl="1"/>
-            <a:r>
-              <a:rPr lang="en-US" altLang="zh-CN" dirty="0"/>
-              <a:t>Usable</a:t>
-            </a:r>
-            <a:endParaRPr lang="en-US" dirty="0"/>
-          </a:p>
-          <a:p>
-            <a:pPr lvl="1"/>
-            <a:r>
-              <a:rPr lang="en-US" dirty="0"/>
-              <a:t>Less error-prone</a:t>
-            </a:r>
-          </a:p>
-          <a:p>
-            <a:pPr lvl="1"/>
-            <a:r>
-              <a:rPr lang="en-US" dirty="0"/>
-              <a:t>Easier to maintain</a:t>
-            </a:r>
-          </a:p>
-          <a:p>
-            <a:pPr lvl="1"/>
-            <a:r>
-              <a:rPr lang="en-US" dirty="0"/>
-              <a:t>Reusable</a:t>
-            </a:r>
-          </a:p>
-          <a:p>
-            <a:pPr lvl="1"/>
-            <a:r>
-              <a:rPr lang="en-US" dirty="0"/>
-              <a:t>…</a:t>
-            </a:r>
-          </a:p>
-          <a:p>
-            <a:r>
-              <a:rPr lang="en-US" dirty="0"/>
-              <a:t>How to </a:t>
-            </a:r>
-            <a:r>
-              <a:rPr lang="en-US" u="sng" dirty="0"/>
-              <a:t>manage</a:t>
-            </a:r>
-            <a:r>
-              <a:rPr lang="en-US" dirty="0"/>
-              <a:t> a software project effectively?</a:t>
-            </a:r>
-          </a:p>
-          <a:p>
-            <a:endParaRPr lang="en-US" dirty="0"/>
-          </a:p>
-          <a:p>
-            <a:pPr lvl="1"/>
-            <a:endParaRPr lang="en-US" dirty="0"/>
-          </a:p>
-          <a:p>
-            <a:endParaRPr lang="en-US" dirty="0"/>
-          </a:p>
-          <a:p>
-            <a:endParaRPr lang="en-US" dirty="0"/>
-          </a:p>
-        </p:txBody>
-      </p:sp>
-      <p:sp>
-        <p:nvSpPr>
-          <p:cNvPr id="4" name="Slide Number Placeholder 3">
-            <a:extLst>
-              <a:ext uri="{FF2B5EF4-FFF2-40B4-BE49-F238E27FC236}">
-                <a16:creationId xmlns:a16="http://schemas.microsoft.com/office/drawing/2014/main" id="{F857987F-894F-663F-291F-2E1A6AE37818}"/>
-              </a:ext>
-            </a:extLst>
-          </p:cNvPr>
-          <p:cNvSpPr>
-            <a:spLocks noGrp="1"/>
-          </p:cNvSpPr>
-          <p:nvPr>
-            <p:ph type="sldNum" sz="quarter" idx="12"/>
-          </p:nvPr>
-        </p:nvSpPr>
-        <p:spPr/>
-        <p:txBody>
-          <a:bodyPr/>
-          <a:lstStyle/>
-          <a:p>
-            <a:fld id="{3AB30462-0FD5-604F-8C98-DCC91BE84583}" type="slidenum">
-              <a:rPr lang="en-US" smtClean="0"/>
-              <a:t>41</a:t>
-            </a:fld>
-            <a:endParaRPr lang="en-US"/>
-          </a:p>
-        </p:txBody>
-      </p:sp>
-    </p:spTree>
-    <p:extLst>
-      <p:ext uri="{BB962C8B-B14F-4D97-AF65-F5344CB8AC3E}">
-        <p14:creationId xmlns:p14="http://schemas.microsoft.com/office/powerpoint/2010/main" val="2107989568"/>
-      </p:ext>
-    </p:extLst>
-  </p:cSld>
-  <p:clrMapOvr>
-    <a:masterClrMapping/>
-  </p:clrMapOvr>
-</p:sld>
-</file>
-
-<file path=ppt/slides/slide42.xml><?xml version="1.0" encoding="utf-8"?>
-<p:sld xmlns:a="http://schemas.openxmlformats.org/drawingml/2006/main" xmlns:r="http://schemas.openxmlformats.org/officeDocument/2006/relationships" xmlns:p="http://schemas.openxmlformats.org/presentationml/2006/main">
-  <p:cSld>
-    <p:spTree>
-      <p:nvGrpSpPr>
-        <p:cNvPr id="1" name="">
-          <a:extLst>
-            <a:ext uri="{FF2B5EF4-FFF2-40B4-BE49-F238E27FC236}">
-              <a16:creationId xmlns:a16="http://schemas.microsoft.com/office/drawing/2014/main" id="{EFC2373B-C16D-DA25-3264-93A826BFA945}"/>
-            </a:ext>
-          </a:extLst>
-        </p:cNvPr>
-        <p:cNvGrpSpPr/>
-        <p:nvPr/>
-      </p:nvGrpSpPr>
-      <p:grpSpPr>
-        <a:xfrm>
-          <a:off x="0" y="0"/>
-          <a:ext cx="0" cy="0"/>
-          <a:chOff x="0" y="0"/>
-          <a:chExt cx="0" cy="0"/>
-        </a:xfrm>
-      </p:grpSpPr>
-      <p:sp>
-        <p:nvSpPr>
-          <p:cNvPr id="2" name="Title 1">
-            <a:extLst>
-              <a:ext uri="{FF2B5EF4-FFF2-40B4-BE49-F238E27FC236}">
-                <a16:creationId xmlns:a16="http://schemas.microsoft.com/office/drawing/2014/main" id="{044E33EA-0C32-D87F-938C-0299354C5A7E}"/>
-              </a:ext>
-            </a:extLst>
-          </p:cNvPr>
-          <p:cNvSpPr>
-            <a:spLocks noGrp="1"/>
-          </p:cNvSpPr>
-          <p:nvPr>
-            <p:ph type="title"/>
-          </p:nvPr>
-        </p:nvSpPr>
-        <p:spPr/>
-        <p:txBody>
-          <a:bodyPr/>
-          <a:lstStyle/>
-          <a:p>
-            <a:r>
-              <a:rPr lang="en-US" dirty="0"/>
-              <a:t>Main course topics</a:t>
-            </a:r>
-          </a:p>
-        </p:txBody>
-      </p:sp>
-      <p:sp>
-        <p:nvSpPr>
-          <p:cNvPr id="3" name="Content Placeholder 2">
-            <a:extLst>
-              <a:ext uri="{FF2B5EF4-FFF2-40B4-BE49-F238E27FC236}">
-                <a16:creationId xmlns:a16="http://schemas.microsoft.com/office/drawing/2014/main" id="{1D5BB1B1-A45B-9016-E837-9E2473C61555}"/>
-              </a:ext>
-            </a:extLst>
-          </p:cNvPr>
-          <p:cNvSpPr>
-            <a:spLocks noGrp="1"/>
-          </p:cNvSpPr>
-          <p:nvPr>
-            <p:ph idx="1"/>
-          </p:nvPr>
-        </p:nvSpPr>
-        <p:spPr/>
-        <p:txBody>
-          <a:bodyPr/>
-          <a:lstStyle/>
-          <a:p>
-            <a:r>
-              <a:rPr lang="en-US" dirty="0"/>
-              <a:t>How to write </a:t>
-            </a:r>
-            <a:r>
-              <a:rPr lang="en-US" u="sng" dirty="0"/>
-              <a:t>quality</a:t>
-            </a:r>
-            <a:r>
-              <a:rPr lang="en-US" dirty="0"/>
-              <a:t> code?</a:t>
-            </a:r>
-          </a:p>
-          <a:p>
-            <a:pPr lvl="1"/>
-            <a:r>
-              <a:rPr lang="en-US" altLang="zh-CN" dirty="0"/>
-              <a:t>Usable</a:t>
-            </a:r>
-            <a:endParaRPr lang="en-US" dirty="0"/>
-          </a:p>
-          <a:p>
-            <a:pPr lvl="1"/>
-            <a:r>
-              <a:rPr lang="en-US" dirty="0"/>
-              <a:t>Less error-prone</a:t>
-            </a:r>
-          </a:p>
-          <a:p>
-            <a:pPr lvl="1"/>
-            <a:r>
-              <a:rPr lang="en-US" dirty="0"/>
-              <a:t>Easier to maintain</a:t>
-            </a:r>
-          </a:p>
-          <a:p>
-            <a:pPr lvl="1"/>
-            <a:r>
-              <a:rPr lang="en-US" dirty="0"/>
-              <a:t>Reusable</a:t>
-            </a:r>
-          </a:p>
-          <a:p>
-            <a:pPr lvl="1"/>
-            <a:r>
-              <a:rPr lang="en-US" dirty="0"/>
-              <a:t>…</a:t>
-            </a:r>
-          </a:p>
-          <a:p>
-            <a:r>
-              <a:rPr lang="en-US" dirty="0"/>
-              <a:t>How to </a:t>
-            </a:r>
-            <a:r>
-              <a:rPr lang="en-US" u="sng" dirty="0"/>
-              <a:t>manage</a:t>
-            </a:r>
-            <a:r>
-              <a:rPr lang="en-US" dirty="0"/>
-              <a:t> a software project effectively?</a:t>
-            </a:r>
-          </a:p>
-          <a:p>
-            <a:pPr lvl="1"/>
-            <a:r>
-              <a:rPr lang="en-US" dirty="0"/>
-              <a:t>Meet the user requirements</a:t>
-            </a:r>
-          </a:p>
-          <a:p>
-            <a:pPr lvl="1"/>
-            <a:r>
-              <a:rPr lang="en-US" dirty="0"/>
-              <a:t>Delivered in a timely manner</a:t>
-            </a:r>
-          </a:p>
-          <a:p>
-            <a:pPr lvl="1"/>
-            <a:r>
-              <a:rPr lang="en-US" dirty="0"/>
-              <a:t>…</a:t>
-            </a:r>
-          </a:p>
-          <a:p>
-            <a:pPr lvl="1"/>
-            <a:endParaRPr lang="en-US" dirty="0"/>
-          </a:p>
-          <a:p>
-            <a:endParaRPr lang="en-US" dirty="0"/>
-          </a:p>
-          <a:p>
-            <a:pPr lvl="1"/>
-            <a:endParaRPr lang="en-US" dirty="0"/>
-          </a:p>
-          <a:p>
-            <a:endParaRPr lang="en-US" dirty="0"/>
-          </a:p>
-          <a:p>
-            <a:endParaRPr lang="en-US" dirty="0"/>
-          </a:p>
-        </p:txBody>
-      </p:sp>
-      <p:sp>
-        <p:nvSpPr>
-          <p:cNvPr id="4" name="Slide Number Placeholder 3">
-            <a:extLst>
-              <a:ext uri="{FF2B5EF4-FFF2-40B4-BE49-F238E27FC236}">
-                <a16:creationId xmlns:a16="http://schemas.microsoft.com/office/drawing/2014/main" id="{3ADB5785-52A1-2D23-11E2-85983AA74D67}"/>
-              </a:ext>
-            </a:extLst>
-          </p:cNvPr>
-          <p:cNvSpPr>
-            <a:spLocks noGrp="1"/>
-          </p:cNvSpPr>
-          <p:nvPr>
-            <p:ph type="sldNum" sz="quarter" idx="12"/>
-          </p:nvPr>
-        </p:nvSpPr>
-        <p:spPr/>
-        <p:txBody>
-          <a:bodyPr/>
-          <a:lstStyle/>
-          <a:p>
-            <a:fld id="{3AB30462-0FD5-604F-8C98-DCC91BE84583}" type="slidenum">
-              <a:rPr lang="en-US" smtClean="0"/>
-              <a:t>42</a:t>
-            </a:fld>
-            <a:endParaRPr lang="en-US"/>
-          </a:p>
-        </p:txBody>
-      </p:sp>
-    </p:spTree>
-    <p:extLst>
-      <p:ext uri="{BB962C8B-B14F-4D97-AF65-F5344CB8AC3E}">
-        <p14:creationId xmlns:p14="http://schemas.microsoft.com/office/powerpoint/2010/main" val="1624227512"/>
       </p:ext>
     </p:extLst>
   </p:cSld>

</xml_diff>

<commit_message>
added a new index.html based on discussion with chatGPT
</commit_message>
<xml_diff>
--- a/slides/Lecture1.pptx
+++ b/slides/Lecture1.pptx
@@ -5,7 +5,7 @@
     <p:sldMasterId id="2147483648" r:id="rId1"/>
   </p:sldMasterIdLst>
   <p:notesMasterIdLst>
-    <p:notesMasterId r:id="rId40"/>
+    <p:notesMasterId r:id="rId41"/>
   </p:notesMasterIdLst>
   <p:sldIdLst>
     <p:sldId id="256" r:id="rId2"/>
@@ -29,23 +29,24 @@
     <p:sldId id="288" r:id="rId20"/>
     <p:sldId id="290" r:id="rId21"/>
     <p:sldId id="276" r:id="rId22"/>
-    <p:sldId id="285" r:id="rId23"/>
-    <p:sldId id="269" r:id="rId24"/>
-    <p:sldId id="270" r:id="rId25"/>
-    <p:sldId id="283" r:id="rId26"/>
-    <p:sldId id="291" r:id="rId27"/>
-    <p:sldId id="292" r:id="rId28"/>
-    <p:sldId id="293" r:id="rId29"/>
-    <p:sldId id="294" r:id="rId30"/>
-    <p:sldId id="295" r:id="rId31"/>
-    <p:sldId id="296" r:id="rId32"/>
-    <p:sldId id="297" r:id="rId33"/>
-    <p:sldId id="298" r:id="rId34"/>
-    <p:sldId id="300" r:id="rId35"/>
-    <p:sldId id="301" r:id="rId36"/>
-    <p:sldId id="303" r:id="rId37"/>
-    <p:sldId id="304" r:id="rId38"/>
-    <p:sldId id="289" r:id="rId39"/>
+    <p:sldId id="305" r:id="rId23"/>
+    <p:sldId id="285" r:id="rId24"/>
+    <p:sldId id="269" r:id="rId25"/>
+    <p:sldId id="270" r:id="rId26"/>
+    <p:sldId id="283" r:id="rId27"/>
+    <p:sldId id="291" r:id="rId28"/>
+    <p:sldId id="292" r:id="rId29"/>
+    <p:sldId id="293" r:id="rId30"/>
+    <p:sldId id="294" r:id="rId31"/>
+    <p:sldId id="295" r:id="rId32"/>
+    <p:sldId id="296" r:id="rId33"/>
+    <p:sldId id="297" r:id="rId34"/>
+    <p:sldId id="298" r:id="rId35"/>
+    <p:sldId id="300" r:id="rId36"/>
+    <p:sldId id="301" r:id="rId37"/>
+    <p:sldId id="303" r:id="rId38"/>
+    <p:sldId id="304" r:id="rId39"/>
+    <p:sldId id="289" r:id="rId40"/>
   </p:sldIdLst>
   <p:sldSz cx="12192000" cy="6858000"/>
   <p:notesSz cx="6858000" cy="9144000"/>
@@ -234,7 +235,7 @@
           <a:p>
             <a:fld id="{E87D854A-D757-5C4C-A465-3201C554EB8D}" type="datetimeFigureOut">
               <a:rPr lang="en-US" smtClean="0"/>
-              <a:t>8/10/25</a:t>
+              <a:t>8/21/25</a:t>
             </a:fld>
             <a:endParaRPr lang="en-US"/>
           </a:p>
@@ -794,7 +795,7 @@
           <a:p>
             <a:fld id="{F0CDB674-9C07-4F43-9CB5-21BC013244CA}" type="slidenum">
               <a:rPr lang="en-US" smtClean="0"/>
-              <a:t>29</a:t>
+              <a:t>30</a:t>
             </a:fld>
             <a:endParaRPr lang="en-US"/>
           </a:p>
@@ -906,7 +907,7 @@
           <a:p>
             <a:fld id="{F0CDB674-9C07-4F43-9CB5-21BC013244CA}" type="slidenum">
               <a:rPr lang="en-US" smtClean="0"/>
-              <a:t>30</a:t>
+              <a:t>31</a:t>
             </a:fld>
             <a:endParaRPr lang="en-US"/>
           </a:p>
@@ -1071,7 +1072,7 @@
           <a:p>
             <a:fld id="{F1276487-8B75-2F43-9355-4B467BD57A6C}" type="datetime1">
               <a:rPr lang="en-US" smtClean="0"/>
-              <a:t>8/10/25</a:t>
+              <a:t>8/21/25</a:t>
             </a:fld>
             <a:endParaRPr lang="en-US"/>
           </a:p>
@@ -1277,7 +1278,7 @@
           <a:p>
             <a:fld id="{30B10427-957C-524C-8454-F629CBA9C9BE}" type="datetime1">
               <a:rPr lang="en-US" smtClean="0"/>
-              <a:t>8/10/25</a:t>
+              <a:t>8/21/25</a:t>
             </a:fld>
             <a:endParaRPr lang="en-US"/>
           </a:p>
@@ -1493,7 +1494,7 @@
           <a:p>
             <a:fld id="{4B97C5AB-4FB5-3149-A6CF-D0F885A81EBA}" type="datetime1">
               <a:rPr lang="en-US" smtClean="0"/>
-              <a:t>8/10/25</a:t>
+              <a:t>8/21/25</a:t>
             </a:fld>
             <a:endParaRPr lang="en-US"/>
           </a:p>
@@ -1699,7 +1700,7 @@
           <a:p>
             <a:fld id="{8D8F5D7A-DAAE-D246-A661-ED1AD3964955}" type="datetime1">
               <a:rPr lang="en-US" smtClean="0"/>
-              <a:t>8/10/25</a:t>
+              <a:t>8/21/25</a:t>
             </a:fld>
             <a:endParaRPr lang="en-US"/>
           </a:p>
@@ -1982,7 +1983,7 @@
           <a:p>
             <a:fld id="{801806B9-6C4B-3B45-9110-CA58C108BE01}" type="datetime1">
               <a:rPr lang="en-US" smtClean="0"/>
-              <a:t>8/10/25</a:t>
+              <a:t>8/21/25</a:t>
             </a:fld>
             <a:endParaRPr lang="en-US"/>
           </a:p>
@@ -2255,7 +2256,7 @@
           <a:p>
             <a:fld id="{025C6FEA-FDE7-B240-BEAF-6A3F6212E36E}" type="datetime1">
               <a:rPr lang="en-US" smtClean="0"/>
-              <a:t>8/10/25</a:t>
+              <a:t>8/21/25</a:t>
             </a:fld>
             <a:endParaRPr lang="en-US"/>
           </a:p>
@@ -2675,7 +2676,7 @@
           <a:p>
             <a:fld id="{895F5DD0-F679-3747-91F3-9DC9C3F86CB6}" type="datetime1">
               <a:rPr lang="en-US" smtClean="0"/>
-              <a:t>8/10/25</a:t>
+              <a:t>8/21/25</a:t>
             </a:fld>
             <a:endParaRPr lang="en-US"/>
           </a:p>
@@ -2824,7 +2825,7 @@
           <a:p>
             <a:fld id="{9EDA3FF8-7A34-ED49-AA5D-BC76DF58E74E}" type="datetime1">
               <a:rPr lang="en-US" smtClean="0"/>
-              <a:t>8/10/25</a:t>
+              <a:t>8/21/25</a:t>
             </a:fld>
             <a:endParaRPr lang="en-US"/>
           </a:p>
@@ -2945,7 +2946,7 @@
           <a:p>
             <a:fld id="{182A1C80-5B2D-564F-B8C6-B0B5B92F5809}" type="datetime1">
               <a:rPr lang="en-US" smtClean="0"/>
-              <a:t>8/10/25</a:t>
+              <a:t>8/21/25</a:t>
             </a:fld>
             <a:endParaRPr lang="en-US"/>
           </a:p>
@@ -3264,7 +3265,7 @@
           <a:p>
             <a:fld id="{65F75D97-7D6D-EC47-8250-30DF936063AD}" type="datetime1">
               <a:rPr lang="en-US" smtClean="0"/>
-              <a:t>8/10/25</a:t>
+              <a:t>8/21/25</a:t>
             </a:fld>
             <a:endParaRPr lang="en-US"/>
           </a:p>
@@ -3560,7 +3561,7 @@
           <a:p>
             <a:fld id="{D2E89D4A-5528-5F41-9AF6-6B3105C8A7C3}" type="datetime1">
               <a:rPr lang="en-US" smtClean="0"/>
-              <a:t>8/10/25</a:t>
+              <a:t>8/21/25</a:t>
             </a:fld>
             <a:endParaRPr lang="en-US"/>
           </a:p>
@@ -3801,7 +3802,7 @@
           <a:p>
             <a:fld id="{86344417-86B7-E841-9AA9-C4BE48872EF5}" type="datetime1">
               <a:rPr lang="en-US" smtClean="0"/>
-              <a:t>8/10/25</a:t>
+              <a:t>8/21/25</a:t>
             </a:fld>
             <a:endParaRPr lang="en-US"/>
           </a:p>
@@ -7084,7 +7085,7 @@
           <p:cNvPr id="2" name="Title 1">
             <a:extLst>
               <a:ext uri="{FF2B5EF4-FFF2-40B4-BE49-F238E27FC236}">
-                <a16:creationId xmlns:a16="http://schemas.microsoft.com/office/drawing/2014/main" id="{4A2729CB-0960-6997-CBE8-37D8858DA014}"/>
+                <a16:creationId xmlns:a16="http://schemas.microsoft.com/office/drawing/2014/main" id="{710E33E7-D7BF-4EF3-45AE-C24AD8914D43}"/>
               </a:ext>
             </a:extLst>
           </p:cNvPr>
@@ -7102,7 +7103,7 @@
           <a:p>
             <a:r>
               <a:rPr lang="en-US" dirty="0"/>
-              <a:t>Acknowledgements</a:t>
+              <a:t>Course topics</a:t>
             </a:r>
           </a:p>
         </p:txBody>
@@ -7112,7 +7113,7 @@
           <p:cNvPr id="3" name="Content Placeholder 2">
             <a:extLst>
               <a:ext uri="{FF2B5EF4-FFF2-40B4-BE49-F238E27FC236}">
-                <a16:creationId xmlns:a16="http://schemas.microsoft.com/office/drawing/2014/main" id="{CD390941-739F-1D0B-49B3-899054F005BF}"/>
+                <a16:creationId xmlns:a16="http://schemas.microsoft.com/office/drawing/2014/main" id="{69BE38D1-50DD-0177-C01E-291E054808D7}"/>
               </a:ext>
             </a:extLst>
           </p:cNvPr>
@@ -7125,20 +7126,112 @@
         </p:nvSpPr>
         <p:spPr/>
         <p:txBody>
-          <a:bodyPr/>
-          <a:lstStyle/>
-          <a:p>
-            <a:r>
-              <a:rPr lang="en-US" dirty="0"/>
-              <a:t>Course materials are inspired by or adapted from previous offerings of CISC 6100 by Prof. Bill Lord, and open source teaching materials by Prof. Florian </a:t>
-            </a:r>
-            <a:r>
-              <a:rPr lang="en-US" dirty="0" err="1"/>
-              <a:t>Echtler</a:t>
-            </a:r>
-            <a:r>
-              <a:rPr lang="en-US" dirty="0"/>
-              <a:t>.</a:t>
+          <a:bodyPr>
+            <a:normAutofit fontScale="70000" lnSpcReduction="20000"/>
+          </a:bodyPr>
+          <a:lstStyle/>
+          <a:p>
+            <a:r>
+              <a:rPr lang="en-US" dirty="0"/>
+              <a:t>Software development processes </a:t>
+            </a:r>
+          </a:p>
+          <a:p>
+            <a:pPr lvl="1"/>
+            <a:r>
+              <a:rPr lang="en-US" dirty="0"/>
+              <a:t>Waterfall and Agile</a:t>
+            </a:r>
+          </a:p>
+          <a:p>
+            <a:r>
+              <a:rPr lang="en-US" dirty="0"/>
+              <a:t>Requirements analysis</a:t>
+            </a:r>
+          </a:p>
+          <a:p>
+            <a:pPr lvl="1"/>
+            <a:r>
+              <a:rPr lang="en-US" dirty="0"/>
+              <a:t>Use cases and diagrams</a:t>
+            </a:r>
+          </a:p>
+          <a:p>
+            <a:r>
+              <a:rPr lang="en-US" dirty="0"/>
+              <a:t>Software modeling</a:t>
+            </a:r>
+          </a:p>
+          <a:p>
+            <a:pPr lvl="1"/>
+            <a:r>
+              <a:rPr lang="en-US" dirty="0"/>
+              <a:t>Top-down hierarchical design, stepwise refined</a:t>
+            </a:r>
+          </a:p>
+          <a:p>
+            <a:pPr lvl="1"/>
+            <a:r>
+              <a:rPr lang="en-US" dirty="0"/>
+              <a:t>Object oriented programming</a:t>
+            </a:r>
+          </a:p>
+          <a:p>
+            <a:pPr lvl="1"/>
+            <a:r>
+              <a:rPr lang="en-US" dirty="0"/>
+              <a:t>Design </a:t>
+            </a:r>
+            <a:r>
+              <a:rPr lang="en-US"/>
+              <a:t>patterns such as MVC</a:t>
+            </a:r>
+            <a:endParaRPr lang="en-US" dirty="0"/>
+          </a:p>
+          <a:p>
+            <a:r>
+              <a:rPr lang="en-US" dirty="0"/>
+              <a:t>Testing</a:t>
+            </a:r>
+          </a:p>
+          <a:p>
+            <a:pPr lvl="1"/>
+            <a:r>
+              <a:rPr lang="en-US" dirty="0"/>
+              <a:t>Unit and integration testing</a:t>
+            </a:r>
+          </a:p>
+          <a:p>
+            <a:pPr lvl="1"/>
+            <a:r>
+              <a:rPr lang="en-US" dirty="0"/>
+              <a:t>Maybe talk about fuzz testing as well</a:t>
+            </a:r>
+          </a:p>
+          <a:p>
+            <a:r>
+              <a:rPr lang="en-US" dirty="0"/>
+              <a:t>Web programming basics</a:t>
+            </a:r>
+          </a:p>
+          <a:p>
+            <a:pPr lvl="1"/>
+            <a:r>
+              <a:rPr lang="en-US" dirty="0"/>
+              <a:t>HTML, CSS, frontend JS, and Node JS</a:t>
+            </a:r>
+          </a:p>
+          <a:p>
+            <a:r>
+              <a:rPr lang="en-US" dirty="0"/>
+              <a:t>Tooling</a:t>
+            </a:r>
+          </a:p>
+          <a:p>
+            <a:pPr lvl="1"/>
+            <a:r>
+              <a:rPr lang="en-US" dirty="0"/>
+              <a:t>Git, CI/CD</a:t>
             </a:r>
           </a:p>
         </p:txBody>
@@ -7148,7 +7241,7 @@
           <p:cNvPr id="4" name="Slide Number Placeholder 3">
             <a:extLst>
               <a:ext uri="{FF2B5EF4-FFF2-40B4-BE49-F238E27FC236}">
-                <a16:creationId xmlns:a16="http://schemas.microsoft.com/office/drawing/2014/main" id="{EB6076FC-7E5B-714F-2A24-E45AA3B5F59F}"/>
+                <a16:creationId xmlns:a16="http://schemas.microsoft.com/office/drawing/2014/main" id="{566C8ECD-7946-286B-1677-F3F7B93CE9A9}"/>
               </a:ext>
             </a:extLst>
           </p:cNvPr>
@@ -7167,6 +7260,129 @@
             <a:fld id="{3AB30462-0FD5-604F-8C98-DCC91BE84583}" type="slidenum">
               <a:rPr lang="en-US" smtClean="0"/>
               <a:t>22</a:t>
+            </a:fld>
+            <a:endParaRPr lang="en-US"/>
+          </a:p>
+        </p:txBody>
+      </p:sp>
+    </p:spTree>
+    <p:extLst>
+      <p:ext uri="{BB962C8B-B14F-4D97-AF65-F5344CB8AC3E}">
+        <p14:creationId xmlns:p14="http://schemas.microsoft.com/office/powerpoint/2010/main" val="3276921302"/>
+      </p:ext>
+    </p:extLst>
+  </p:cSld>
+  <p:clrMapOvr>
+    <a:masterClrMapping/>
+  </p:clrMapOvr>
+</p:sld>
+</file>
+
+<file path=ppt/slides/slide23.xml><?xml version="1.0" encoding="utf-8"?>
+<p:sld xmlns:a="http://schemas.openxmlformats.org/drawingml/2006/main" xmlns:r="http://schemas.openxmlformats.org/officeDocument/2006/relationships" xmlns:p="http://schemas.openxmlformats.org/presentationml/2006/main">
+  <p:cSld>
+    <p:spTree>
+      <p:nvGrpSpPr>
+        <p:cNvPr id="1" name=""/>
+        <p:cNvGrpSpPr/>
+        <p:nvPr/>
+      </p:nvGrpSpPr>
+      <p:grpSpPr>
+        <a:xfrm>
+          <a:off x="0" y="0"/>
+          <a:ext cx="0" cy="0"/>
+          <a:chOff x="0" y="0"/>
+          <a:chExt cx="0" cy="0"/>
+        </a:xfrm>
+      </p:grpSpPr>
+      <p:sp>
+        <p:nvSpPr>
+          <p:cNvPr id="2" name="Title 1">
+            <a:extLst>
+              <a:ext uri="{FF2B5EF4-FFF2-40B4-BE49-F238E27FC236}">
+                <a16:creationId xmlns:a16="http://schemas.microsoft.com/office/drawing/2014/main" id="{4A2729CB-0960-6997-CBE8-37D8858DA014}"/>
+              </a:ext>
+            </a:extLst>
+          </p:cNvPr>
+          <p:cNvSpPr>
+            <a:spLocks noGrp="1"/>
+          </p:cNvSpPr>
+          <p:nvPr>
+            <p:ph type="title"/>
+          </p:nvPr>
+        </p:nvSpPr>
+        <p:spPr/>
+        <p:txBody>
+          <a:bodyPr/>
+          <a:lstStyle/>
+          <a:p>
+            <a:r>
+              <a:rPr lang="en-US" dirty="0"/>
+              <a:t>Acknowledgements</a:t>
+            </a:r>
+          </a:p>
+        </p:txBody>
+      </p:sp>
+      <p:sp>
+        <p:nvSpPr>
+          <p:cNvPr id="3" name="Content Placeholder 2">
+            <a:extLst>
+              <a:ext uri="{FF2B5EF4-FFF2-40B4-BE49-F238E27FC236}">
+                <a16:creationId xmlns:a16="http://schemas.microsoft.com/office/drawing/2014/main" id="{CD390941-739F-1D0B-49B3-899054F005BF}"/>
+              </a:ext>
+            </a:extLst>
+          </p:cNvPr>
+          <p:cNvSpPr>
+            <a:spLocks noGrp="1"/>
+          </p:cNvSpPr>
+          <p:nvPr>
+            <p:ph idx="1"/>
+          </p:nvPr>
+        </p:nvSpPr>
+        <p:spPr/>
+        <p:txBody>
+          <a:bodyPr/>
+          <a:lstStyle/>
+          <a:p>
+            <a:r>
+              <a:rPr lang="en-US" dirty="0"/>
+              <a:t>Course materials are inspired by or adapted from previous offerings of CISC 6100 by Prof. Bill Lord, and open source teaching materials by Prof. Florian </a:t>
+            </a:r>
+            <a:r>
+              <a:rPr lang="en-US" dirty="0" err="1"/>
+              <a:t>Echtler</a:t>
+            </a:r>
+            <a:r>
+              <a:rPr lang="en-US" dirty="0"/>
+              <a:t>.</a:t>
+            </a:r>
+          </a:p>
+        </p:txBody>
+      </p:sp>
+      <p:sp>
+        <p:nvSpPr>
+          <p:cNvPr id="4" name="Slide Number Placeholder 3">
+            <a:extLst>
+              <a:ext uri="{FF2B5EF4-FFF2-40B4-BE49-F238E27FC236}">
+                <a16:creationId xmlns:a16="http://schemas.microsoft.com/office/drawing/2014/main" id="{EB6076FC-7E5B-714F-2A24-E45AA3B5F59F}"/>
+              </a:ext>
+            </a:extLst>
+          </p:cNvPr>
+          <p:cNvSpPr>
+            <a:spLocks noGrp="1"/>
+          </p:cNvSpPr>
+          <p:nvPr>
+            <p:ph type="sldNum" sz="quarter" idx="12"/>
+          </p:nvPr>
+        </p:nvSpPr>
+        <p:spPr/>
+        <p:txBody>
+          <a:bodyPr/>
+          <a:lstStyle/>
+          <a:p>
+            <a:fld id="{3AB30462-0FD5-604F-8C98-DCC91BE84583}" type="slidenum">
+              <a:rPr lang="en-US" smtClean="0"/>
+              <a:t>23</a:t>
             </a:fld>
             <a:endParaRPr lang="en-US"/>
           </a:p>
@@ -7185,7 +7401,7 @@
 </p:sld>
 </file>
 
-<file path=ppt/slides/slide23.xml><?xml version="1.0" encoding="utf-8"?>
+<file path=ppt/slides/slide24.xml><?xml version="1.0" encoding="utf-8"?>
 <p:sld xmlns:a="http://schemas.openxmlformats.org/drawingml/2006/main" xmlns:r="http://schemas.openxmlformats.org/officeDocument/2006/relationships" xmlns:p="http://schemas.openxmlformats.org/presentationml/2006/main">
   <p:cSld>
     <p:spTree>
@@ -7371,7 +7587,7 @@
           <a:p>
             <a:fld id="{3AB30462-0FD5-604F-8C98-DCC91BE84583}" type="slidenum">
               <a:rPr lang="en-US" smtClean="0"/>
-              <a:t>23</a:t>
+              <a:t>24</a:t>
             </a:fld>
             <a:endParaRPr lang="en-US"/>
           </a:p>
@@ -7381,272 +7597,6 @@
     <p:extLst>
       <p:ext uri="{BB962C8B-B14F-4D97-AF65-F5344CB8AC3E}">
         <p14:creationId xmlns:p14="http://schemas.microsoft.com/office/powerpoint/2010/main" val="1525870370"/>
-      </p:ext>
-    </p:extLst>
-  </p:cSld>
-  <p:clrMapOvr>
-    <a:masterClrMapping/>
-  </p:clrMapOvr>
-</p:sld>
-</file>
-
-<file path=ppt/slides/slide24.xml><?xml version="1.0" encoding="utf-8"?>
-<p:sld xmlns:a="http://schemas.openxmlformats.org/drawingml/2006/main" xmlns:r="http://schemas.openxmlformats.org/officeDocument/2006/relationships" xmlns:p="http://schemas.openxmlformats.org/presentationml/2006/main">
-  <p:cSld>
-    <p:spTree>
-      <p:nvGrpSpPr>
-        <p:cNvPr id="1" name=""/>
-        <p:cNvGrpSpPr/>
-        <p:nvPr/>
-      </p:nvGrpSpPr>
-      <p:grpSpPr>
-        <a:xfrm>
-          <a:off x="0" y="0"/>
-          <a:ext cx="0" cy="0"/>
-          <a:chOff x="0" y="0"/>
-          <a:chExt cx="0" cy="0"/>
-        </a:xfrm>
-      </p:grpSpPr>
-      <p:sp>
-        <p:nvSpPr>
-          <p:cNvPr id="2" name="Title 1">
-            <a:extLst>
-              <a:ext uri="{FF2B5EF4-FFF2-40B4-BE49-F238E27FC236}">
-                <a16:creationId xmlns:a16="http://schemas.microsoft.com/office/drawing/2014/main" id="{9C7CF2B7-80AC-CA7B-C097-F09CCBE35A9D}"/>
-              </a:ext>
-            </a:extLst>
-          </p:cNvPr>
-          <p:cNvSpPr>
-            <a:spLocks noGrp="1"/>
-          </p:cNvSpPr>
-          <p:nvPr>
-            <p:ph type="title"/>
-          </p:nvPr>
-        </p:nvSpPr>
-        <p:spPr/>
-        <p:txBody>
-          <a:bodyPr/>
-          <a:lstStyle/>
-          <a:p>
-            <a:r>
-              <a:rPr lang="en-US" dirty="0"/>
-              <a:t>Semester</a:t>
-            </a:r>
-            <a:r>
-              <a:rPr lang="en-US" altLang="zh-CN" dirty="0"/>
-              <a:t>-Long</a:t>
-            </a:r>
-            <a:r>
-              <a:rPr lang="en-US" dirty="0"/>
-              <a:t> </a:t>
-            </a:r>
-            <a:r>
-              <a:rPr lang="en-US" altLang="zh-CN" dirty="0"/>
-              <a:t>P</a:t>
-            </a:r>
-            <a:r>
-              <a:rPr lang="en-US" dirty="0"/>
-              <a:t>roject – Gomoku </a:t>
-            </a:r>
-            <a:r>
-              <a:rPr lang="en-US" altLang="zh-CN" dirty="0"/>
-              <a:t>G</a:t>
-            </a:r>
-            <a:r>
-              <a:rPr lang="en-US" dirty="0"/>
-              <a:t>ame</a:t>
-            </a:r>
-          </a:p>
-        </p:txBody>
-      </p:sp>
-      <p:sp>
-        <p:nvSpPr>
-          <p:cNvPr id="3" name="Content Placeholder 2">
-            <a:extLst>
-              <a:ext uri="{FF2B5EF4-FFF2-40B4-BE49-F238E27FC236}">
-                <a16:creationId xmlns:a16="http://schemas.microsoft.com/office/drawing/2014/main" id="{F2C2992F-979A-8B66-CB05-BCA520B1A094}"/>
-              </a:ext>
-            </a:extLst>
-          </p:cNvPr>
-          <p:cNvSpPr>
-            <a:spLocks noGrp="1"/>
-          </p:cNvSpPr>
-          <p:nvPr>
-            <p:ph idx="1"/>
-          </p:nvPr>
-        </p:nvSpPr>
-        <p:spPr/>
-        <p:txBody>
-          <a:bodyPr/>
-          <a:lstStyle/>
-          <a:p>
-            <a:r>
-              <a:rPr lang="en-US" altLang="zh-CN" dirty="0"/>
-              <a:t>A</a:t>
-            </a:r>
-            <a:r>
-              <a:rPr lang="zh-CN" altLang="en-US" dirty="0"/>
-              <a:t> </a:t>
-            </a:r>
-            <a:r>
-              <a:rPr lang="en-US" altLang="zh-CN" dirty="0"/>
-              <a:t>simple</a:t>
-            </a:r>
-            <a:r>
-              <a:rPr lang="zh-CN" altLang="en-US" dirty="0"/>
-              <a:t> </a:t>
-            </a:r>
-            <a:r>
-              <a:rPr lang="en-US" altLang="zh-CN" dirty="0"/>
-              <a:t>game</a:t>
-            </a:r>
-            <a:r>
-              <a:rPr lang="zh-CN" altLang="en-US" dirty="0"/>
-              <a:t> </a:t>
-            </a:r>
-            <a:r>
-              <a:rPr lang="en-US" altLang="zh-CN" dirty="0"/>
-              <a:t>with</a:t>
-            </a:r>
-            <a:r>
-              <a:rPr lang="zh-CN" altLang="en-US" dirty="0"/>
-              <a:t> </a:t>
-            </a:r>
-            <a:r>
-              <a:rPr lang="en-US" altLang="zh-CN" dirty="0"/>
-              <a:t>minimal</a:t>
-            </a:r>
-            <a:r>
-              <a:rPr lang="zh-CN" altLang="en-US" dirty="0"/>
-              <a:t> </a:t>
-            </a:r>
-            <a:r>
-              <a:rPr lang="en-US" altLang="zh-CN" dirty="0"/>
-              <a:t>domain</a:t>
-            </a:r>
-            <a:r>
-              <a:rPr lang="zh-CN" altLang="en-US" dirty="0"/>
-              <a:t> </a:t>
-            </a:r>
-            <a:r>
-              <a:rPr lang="en-US" altLang="zh-CN" dirty="0"/>
-              <a:t>knowledge</a:t>
-            </a:r>
-          </a:p>
-          <a:p>
-            <a:r>
-              <a:rPr lang="en-US" altLang="zh-CN" dirty="0"/>
-              <a:t>Some</a:t>
-            </a:r>
-            <a:r>
-              <a:rPr lang="zh-CN" altLang="en-US" dirty="0"/>
-              <a:t> </a:t>
-            </a:r>
-            <a:r>
-              <a:rPr lang="en-US" altLang="zh-CN" dirty="0"/>
-              <a:t>level</a:t>
-            </a:r>
-            <a:r>
-              <a:rPr lang="zh-CN" altLang="en-US" dirty="0"/>
-              <a:t> </a:t>
-            </a:r>
-            <a:r>
-              <a:rPr lang="en-US" altLang="zh-CN" dirty="0"/>
-              <a:t>of</a:t>
-            </a:r>
-            <a:r>
-              <a:rPr lang="zh-CN" altLang="en-US" dirty="0"/>
-              <a:t> </a:t>
-            </a:r>
-            <a:r>
-              <a:rPr lang="en-US" altLang="zh-CN" dirty="0"/>
-              <a:t>complexity</a:t>
-            </a:r>
-            <a:r>
-              <a:rPr lang="zh-CN" altLang="en-US" dirty="0"/>
-              <a:t> </a:t>
-            </a:r>
-            <a:r>
-              <a:rPr lang="en-US" altLang="zh-CN" dirty="0"/>
-              <a:t>will</a:t>
-            </a:r>
-            <a:r>
-              <a:rPr lang="zh-CN" altLang="en-US" dirty="0"/>
-              <a:t> </a:t>
-            </a:r>
-            <a:r>
-              <a:rPr lang="en-US" altLang="zh-CN" dirty="0"/>
-              <a:t>be</a:t>
-            </a:r>
-            <a:r>
-              <a:rPr lang="zh-CN" altLang="en-US" dirty="0"/>
-              <a:t> </a:t>
-            </a:r>
-            <a:r>
-              <a:rPr lang="en-US" altLang="zh-CN" dirty="0"/>
-              <a:t>incorporated</a:t>
-            </a:r>
-            <a:r>
-              <a:rPr lang="zh-CN" altLang="en-US" dirty="0"/>
-              <a:t> </a:t>
-            </a:r>
-            <a:r>
-              <a:rPr lang="en-US" altLang="zh-CN" dirty="0"/>
-              <a:t>into</a:t>
-            </a:r>
-            <a:r>
-              <a:rPr lang="zh-CN" altLang="en-US" dirty="0"/>
-              <a:t> </a:t>
-            </a:r>
-            <a:r>
-              <a:rPr lang="en-US" altLang="zh-CN" dirty="0"/>
-              <a:t>the</a:t>
-            </a:r>
-            <a:r>
-              <a:rPr lang="zh-CN" altLang="en-US" dirty="0"/>
-              <a:t> </a:t>
-            </a:r>
-            <a:r>
-              <a:rPr lang="en-US" altLang="zh-CN" dirty="0"/>
-              <a:t>software</a:t>
-            </a:r>
-            <a:endParaRPr lang="en-US" dirty="0"/>
-          </a:p>
-        </p:txBody>
-      </p:sp>
-      <p:sp>
-        <p:nvSpPr>
-          <p:cNvPr id="4" name="Slide Number Placeholder 3">
-            <a:extLst>
-              <a:ext uri="{FF2B5EF4-FFF2-40B4-BE49-F238E27FC236}">
-                <a16:creationId xmlns:a16="http://schemas.microsoft.com/office/drawing/2014/main" id="{A339C8A2-0963-9331-E242-22F86A371810}"/>
-              </a:ext>
-            </a:extLst>
-          </p:cNvPr>
-          <p:cNvSpPr>
-            <a:spLocks noGrp="1"/>
-          </p:cNvSpPr>
-          <p:nvPr>
-            <p:ph type="sldNum" sz="quarter" idx="12"/>
-          </p:nvPr>
-        </p:nvSpPr>
-        <p:spPr/>
-        <p:txBody>
-          <a:bodyPr/>
-          <a:lstStyle/>
-          <a:p>
-            <a:fld id="{3AB30462-0FD5-604F-8C98-DCC91BE84583}" type="slidenum">
-              <a:rPr lang="en-US" smtClean="0"/>
-              <a:t>24</a:t>
-            </a:fld>
-            <a:endParaRPr lang="en-US"/>
-          </a:p>
-        </p:txBody>
-      </p:sp>
-    </p:spTree>
-    <p:extLst>
-      <p:ext uri="{BB962C8B-B14F-4D97-AF65-F5344CB8AC3E}">
-        <p14:creationId xmlns:p14="http://schemas.microsoft.com/office/powerpoint/2010/main" val="2516142745"/>
       </p:ext>
     </p:extLst>
   </p:cSld>
@@ -7678,7 +7628,7 @@
           <p:cNvPr id="2" name="Title 1">
             <a:extLst>
               <a:ext uri="{FF2B5EF4-FFF2-40B4-BE49-F238E27FC236}">
-                <a16:creationId xmlns:a16="http://schemas.microsoft.com/office/drawing/2014/main" id="{9F727561-83A4-2119-D7B4-E7CFB862333E}"/>
+                <a16:creationId xmlns:a16="http://schemas.microsoft.com/office/drawing/2014/main" id="{9C7CF2B7-80AC-CA7B-C097-F09CCBE35A9D}"/>
               </a:ext>
             </a:extLst>
           </p:cNvPr>
@@ -7696,7 +7646,23 @@
           <a:p>
             <a:r>
               <a:rPr lang="en-US" dirty="0"/>
-              <a:t>Gomoku </a:t>
+              <a:t>Semester</a:t>
+            </a:r>
+            <a:r>
+              <a:rPr lang="en-US" altLang="zh-CN" dirty="0"/>
+              <a:t>-Long</a:t>
+            </a:r>
+            <a:r>
+              <a:rPr lang="en-US" dirty="0"/>
+              <a:t> </a:t>
+            </a:r>
+            <a:r>
+              <a:rPr lang="en-US" altLang="zh-CN" dirty="0"/>
+              <a:t>P</a:t>
+            </a:r>
+            <a:r>
+              <a:rPr lang="en-US" dirty="0"/>
+              <a:t>roject – Gomoku </a:t>
             </a:r>
             <a:r>
               <a:rPr lang="en-US" altLang="zh-CN" dirty="0"/>
@@ -7706,13 +7672,159 @@
               <a:rPr lang="en-US" dirty="0"/>
               <a:t>ame</a:t>
             </a:r>
+          </a:p>
+        </p:txBody>
+      </p:sp>
+      <p:sp>
+        <p:nvSpPr>
+          <p:cNvPr id="3" name="Content Placeholder 2">
+            <a:extLst>
+              <a:ext uri="{FF2B5EF4-FFF2-40B4-BE49-F238E27FC236}">
+                <a16:creationId xmlns:a16="http://schemas.microsoft.com/office/drawing/2014/main" id="{F2C2992F-979A-8B66-CB05-BCA520B1A094}"/>
+              </a:ext>
+            </a:extLst>
+          </p:cNvPr>
+          <p:cNvSpPr>
+            <a:spLocks noGrp="1"/>
+          </p:cNvSpPr>
+          <p:nvPr>
+            <p:ph idx="1"/>
+          </p:nvPr>
+        </p:nvSpPr>
+        <p:spPr/>
+        <p:txBody>
+          <a:bodyPr/>
+          <a:lstStyle/>
+          <a:p>
+            <a:r>
+              <a:rPr lang="en-US" altLang="zh-CN" dirty="0"/>
+              <a:t>A</a:t>
+            </a:r>
             <a:r>
               <a:rPr lang="zh-CN" altLang="en-US" dirty="0"/>
               <a:t> </a:t>
             </a:r>
             <a:r>
               <a:rPr lang="en-US" altLang="zh-CN" dirty="0"/>
-              <a:t>Demo</a:t>
+              <a:t>simple</a:t>
+            </a:r>
+            <a:r>
+              <a:rPr lang="zh-CN" altLang="en-US" dirty="0"/>
+              <a:t> </a:t>
+            </a:r>
+            <a:r>
+              <a:rPr lang="en-US" altLang="zh-CN" dirty="0"/>
+              <a:t>game</a:t>
+            </a:r>
+            <a:r>
+              <a:rPr lang="zh-CN" altLang="en-US" dirty="0"/>
+              <a:t> </a:t>
+            </a:r>
+            <a:r>
+              <a:rPr lang="en-US" altLang="zh-CN" dirty="0"/>
+              <a:t>with</a:t>
+            </a:r>
+            <a:r>
+              <a:rPr lang="zh-CN" altLang="en-US" dirty="0"/>
+              <a:t> </a:t>
+            </a:r>
+            <a:r>
+              <a:rPr lang="en-US" altLang="zh-CN" dirty="0"/>
+              <a:t>minimal</a:t>
+            </a:r>
+            <a:r>
+              <a:rPr lang="zh-CN" altLang="en-US" dirty="0"/>
+              <a:t> </a:t>
+            </a:r>
+            <a:r>
+              <a:rPr lang="en-US" altLang="zh-CN" dirty="0"/>
+              <a:t>domain</a:t>
+            </a:r>
+            <a:r>
+              <a:rPr lang="zh-CN" altLang="en-US" dirty="0"/>
+              <a:t> </a:t>
+            </a:r>
+            <a:r>
+              <a:rPr lang="en-US" altLang="zh-CN" dirty="0"/>
+              <a:t>knowledge</a:t>
+            </a:r>
+          </a:p>
+          <a:p>
+            <a:r>
+              <a:rPr lang="en-US" altLang="zh-CN" dirty="0"/>
+              <a:t>Some</a:t>
+            </a:r>
+            <a:r>
+              <a:rPr lang="zh-CN" altLang="en-US" dirty="0"/>
+              <a:t> </a:t>
+            </a:r>
+            <a:r>
+              <a:rPr lang="en-US" altLang="zh-CN" dirty="0"/>
+              <a:t>level</a:t>
+            </a:r>
+            <a:r>
+              <a:rPr lang="zh-CN" altLang="en-US" dirty="0"/>
+              <a:t> </a:t>
+            </a:r>
+            <a:r>
+              <a:rPr lang="en-US" altLang="zh-CN" dirty="0"/>
+              <a:t>of</a:t>
+            </a:r>
+            <a:r>
+              <a:rPr lang="zh-CN" altLang="en-US" dirty="0"/>
+              <a:t> </a:t>
+            </a:r>
+            <a:r>
+              <a:rPr lang="en-US" altLang="zh-CN" dirty="0"/>
+              <a:t>complexity</a:t>
+            </a:r>
+            <a:r>
+              <a:rPr lang="zh-CN" altLang="en-US" dirty="0"/>
+              <a:t> </a:t>
+            </a:r>
+            <a:r>
+              <a:rPr lang="en-US" altLang="zh-CN" dirty="0"/>
+              <a:t>will</a:t>
+            </a:r>
+            <a:r>
+              <a:rPr lang="zh-CN" altLang="en-US" dirty="0"/>
+              <a:t> </a:t>
+            </a:r>
+            <a:r>
+              <a:rPr lang="en-US" altLang="zh-CN" dirty="0"/>
+              <a:t>be</a:t>
+            </a:r>
+            <a:r>
+              <a:rPr lang="zh-CN" altLang="en-US" dirty="0"/>
+              <a:t> </a:t>
+            </a:r>
+            <a:r>
+              <a:rPr lang="en-US" altLang="zh-CN" dirty="0"/>
+              <a:t>incorporated</a:t>
+            </a:r>
+            <a:r>
+              <a:rPr lang="zh-CN" altLang="en-US" dirty="0"/>
+              <a:t> </a:t>
+            </a:r>
+            <a:r>
+              <a:rPr lang="en-US" altLang="zh-CN" dirty="0"/>
+              <a:t>into</a:t>
+            </a:r>
+            <a:r>
+              <a:rPr lang="zh-CN" altLang="en-US" dirty="0"/>
+              <a:t> </a:t>
+            </a:r>
+            <a:r>
+              <a:rPr lang="en-US" altLang="zh-CN" dirty="0"/>
+              <a:t>the</a:t>
+            </a:r>
+            <a:r>
+              <a:rPr lang="zh-CN" altLang="en-US" dirty="0"/>
+              <a:t> </a:t>
+            </a:r>
+            <a:r>
+              <a:rPr lang="en-US" altLang="zh-CN" dirty="0"/>
+              <a:t>software</a:t>
             </a:r>
             <a:endParaRPr lang="en-US" dirty="0"/>
           </a:p>
@@ -7720,122 +7832,10 @@
       </p:sp>
       <p:sp>
         <p:nvSpPr>
-          <p:cNvPr id="3" name="Content Placeholder 2">
-            <a:extLst>
-              <a:ext uri="{FF2B5EF4-FFF2-40B4-BE49-F238E27FC236}">
-                <a16:creationId xmlns:a16="http://schemas.microsoft.com/office/drawing/2014/main" id="{863617F4-5CFD-866D-AC78-DCF88BC77A72}"/>
-              </a:ext>
-            </a:extLst>
-          </p:cNvPr>
-          <p:cNvSpPr>
-            <a:spLocks noGrp="1"/>
-          </p:cNvSpPr>
-          <p:nvPr>
-            <p:ph idx="1"/>
-          </p:nvPr>
-        </p:nvSpPr>
-        <p:spPr/>
-        <p:txBody>
-          <a:bodyPr/>
-          <a:lstStyle/>
-          <a:p>
-            <a:r>
-              <a:rPr lang="en-US" dirty="0"/>
-              <a:t>Two players alternate turns.</a:t>
-            </a:r>
-          </a:p>
-          <a:p>
-            <a:r>
-              <a:rPr lang="en-US" dirty="0"/>
-              <a:t>Win: unbroken line of 5 of your stones, horizontally, vertically, or diagonally.</a:t>
-            </a:r>
-          </a:p>
-        </p:txBody>
-      </p:sp>
-      <p:pic>
-        <p:nvPicPr>
-          <p:cNvPr id="4" name="Picture 3">
-            <a:extLst>
-              <a:ext uri="{FF2B5EF4-FFF2-40B4-BE49-F238E27FC236}">
-                <a16:creationId xmlns:a16="http://schemas.microsoft.com/office/drawing/2014/main" id="{F291428C-2BB8-B902-0305-1394DF762802}"/>
-              </a:ext>
-            </a:extLst>
-          </p:cNvPr>
-          <p:cNvPicPr>
-            <a:picLocks noChangeAspect="1"/>
-          </p:cNvPicPr>
-          <p:nvPr/>
-        </p:nvPicPr>
-        <p:blipFill>
-          <a:blip r:embed="rId2"/>
-          <a:stretch>
-            <a:fillRect/>
-          </a:stretch>
-        </p:blipFill>
-        <p:spPr>
-          <a:xfrm>
-            <a:off x="4652323" y="3301844"/>
-            <a:ext cx="2887353" cy="2948397"/>
-          </a:xfrm>
-          <a:prstGeom prst="rect">
-            <a:avLst/>
-          </a:prstGeom>
-        </p:spPr>
-      </p:pic>
-      <p:sp>
-        <p:nvSpPr>
-          <p:cNvPr id="5" name="TextBox 4">
-            <a:extLst>
-              <a:ext uri="{FF2B5EF4-FFF2-40B4-BE49-F238E27FC236}">
-                <a16:creationId xmlns:a16="http://schemas.microsoft.com/office/drawing/2014/main" id="{7710B0EC-36A3-BB2B-40E7-AFCAF75A75FB}"/>
-              </a:ext>
-            </a:extLst>
-          </p:cNvPr>
-          <p:cNvSpPr txBox="1"/>
-          <p:nvPr/>
-        </p:nvSpPr>
-        <p:spPr>
-          <a:xfrm>
-            <a:off x="4835878" y="6492875"/>
-            <a:ext cx="2520242" cy="215444"/>
-          </a:xfrm>
-          <a:prstGeom prst="rect">
-            <a:avLst/>
-          </a:prstGeom>
-          <a:noFill/>
-        </p:spPr>
-        <p:txBody>
-          <a:bodyPr wrap="none" rtlCol="0">
-            <a:spAutoFit/>
-          </a:bodyPr>
-          <a:lstStyle/>
-          <a:p>
-            <a:r>
-              <a:rPr lang="en-US" sz="800" dirty="0"/>
-              <a:t>Image source: https://</a:t>
-            </a:r>
-            <a:r>
-              <a:rPr lang="en-US" sz="800" dirty="0" err="1"/>
-              <a:t>www.wikihow.com</a:t>
-            </a:r>
-            <a:r>
-              <a:rPr lang="en-US" sz="800" dirty="0"/>
-              <a:t>/Play-</a:t>
-            </a:r>
-            <a:r>
-              <a:rPr lang="en-US" sz="800" dirty="0" err="1"/>
-              <a:t>Gomoku</a:t>
-            </a:r>
-            <a:endParaRPr lang="en-US" sz="800" dirty="0"/>
-          </a:p>
-        </p:txBody>
-      </p:sp>
-      <p:sp>
-        <p:nvSpPr>
-          <p:cNvPr id="6" name="Slide Number Placeholder 5">
-            <a:extLst>
-              <a:ext uri="{FF2B5EF4-FFF2-40B4-BE49-F238E27FC236}">
-                <a16:creationId xmlns:a16="http://schemas.microsoft.com/office/drawing/2014/main" id="{1AA73B74-0F50-4E6F-6816-EAB185A781CC}"/>
+          <p:cNvPr id="4" name="Slide Number Placeholder 3">
+            <a:extLst>
+              <a:ext uri="{FF2B5EF4-FFF2-40B4-BE49-F238E27FC236}">
+                <a16:creationId xmlns:a16="http://schemas.microsoft.com/office/drawing/2014/main" id="{A339C8A2-0963-9331-E242-22F86A371810}"/>
               </a:ext>
             </a:extLst>
           </p:cNvPr>
@@ -7862,7 +7862,7 @@
     </p:spTree>
     <p:extLst>
       <p:ext uri="{BB962C8B-B14F-4D97-AF65-F5344CB8AC3E}">
-        <p14:creationId xmlns:p14="http://schemas.microsoft.com/office/powerpoint/2010/main" val="1014093297"/>
+        <p14:creationId xmlns:p14="http://schemas.microsoft.com/office/powerpoint/2010/main" val="2516142745"/>
       </p:ext>
     </p:extLst>
   </p:cSld>
@@ -7894,7 +7894,7 @@
           <p:cNvPr id="2" name="Title 1">
             <a:extLst>
               <a:ext uri="{FF2B5EF4-FFF2-40B4-BE49-F238E27FC236}">
-                <a16:creationId xmlns:a16="http://schemas.microsoft.com/office/drawing/2014/main" id="{1874013F-EA8F-5440-7DDB-2D3E2F74CBF2}"/>
+                <a16:creationId xmlns:a16="http://schemas.microsoft.com/office/drawing/2014/main" id="{9F727561-83A4-2119-D7B4-E7CFB862333E}"/>
               </a:ext>
             </a:extLst>
           </p:cNvPr>
@@ -7912,8 +7912,25 @@
           <a:p>
             <a:r>
               <a:rPr lang="en-US" dirty="0"/>
-              <a:t>Project Goal</a:t>
-            </a:r>
+              <a:t>Gomoku </a:t>
+            </a:r>
+            <a:r>
+              <a:rPr lang="en-US" altLang="zh-CN" dirty="0"/>
+              <a:t>G</a:t>
+            </a:r>
+            <a:r>
+              <a:rPr lang="en-US" dirty="0"/>
+              <a:t>ame</a:t>
+            </a:r>
+            <a:r>
+              <a:rPr lang="zh-CN" altLang="en-US" dirty="0"/>
+              <a:t> </a:t>
+            </a:r>
+            <a:r>
+              <a:rPr lang="en-US" altLang="zh-CN" dirty="0"/>
+              <a:t>Demo</a:t>
+            </a:r>
+            <a:endParaRPr lang="en-US" dirty="0"/>
           </a:p>
         </p:txBody>
       </p:sp>
@@ -7922,7 +7939,7 @@
           <p:cNvPr id="3" name="Content Placeholder 2">
             <a:extLst>
               <a:ext uri="{FF2B5EF4-FFF2-40B4-BE49-F238E27FC236}">
-                <a16:creationId xmlns:a16="http://schemas.microsoft.com/office/drawing/2014/main" id="{B2DE82CF-2802-2662-6774-E0E0AF77332D}"/>
+                <a16:creationId xmlns:a16="http://schemas.microsoft.com/office/drawing/2014/main" id="{863617F4-5CFD-866D-AC78-DCF88BC77A72}"/>
               </a:ext>
             </a:extLst>
           </p:cNvPr>
@@ -7940,29 +7957,101 @@
           <a:p>
             <a:r>
               <a:rPr lang="en-US" dirty="0"/>
-              <a:t>Build a web application where users can play Gomoku locally or online with a friend by sharing a link</a:t>
-            </a:r>
-          </a:p>
-          <a:p>
-            <a:r>
-              <a:rPr lang="en-US" dirty="0"/>
-              <a:t>Project specification specifies a list of mandatory features, while you can implement additional features you find fun</a:t>
-            </a:r>
-          </a:p>
-          <a:p>
-            <a:r>
-              <a:rPr lang="en-US" dirty="0"/>
-              <a:t>Work in teams of 3 people (form your team by Sep. xxx)</a:t>
-            </a:r>
-          </a:p>
-        </p:txBody>
-      </p:sp>
-      <p:sp>
-        <p:nvSpPr>
-          <p:cNvPr id="4" name="Slide Number Placeholder 3">
-            <a:extLst>
-              <a:ext uri="{FF2B5EF4-FFF2-40B4-BE49-F238E27FC236}">
-                <a16:creationId xmlns:a16="http://schemas.microsoft.com/office/drawing/2014/main" id="{E82F27D3-7686-0834-390A-420E102B40C4}"/>
+              <a:t>Two players alternate turns.</a:t>
+            </a:r>
+          </a:p>
+          <a:p>
+            <a:r>
+              <a:rPr lang="en-US" dirty="0"/>
+              <a:t>Win: unbroken line of 5 of your stones, horizontally, vertically, or diagonally.</a:t>
+            </a:r>
+          </a:p>
+        </p:txBody>
+      </p:sp>
+      <p:pic>
+        <p:nvPicPr>
+          <p:cNvPr id="4" name="Picture 3">
+            <a:extLst>
+              <a:ext uri="{FF2B5EF4-FFF2-40B4-BE49-F238E27FC236}">
+                <a16:creationId xmlns:a16="http://schemas.microsoft.com/office/drawing/2014/main" id="{F291428C-2BB8-B902-0305-1394DF762802}"/>
+              </a:ext>
+            </a:extLst>
+          </p:cNvPr>
+          <p:cNvPicPr>
+            <a:picLocks noChangeAspect="1"/>
+          </p:cNvPicPr>
+          <p:nvPr/>
+        </p:nvPicPr>
+        <p:blipFill>
+          <a:blip r:embed="rId2"/>
+          <a:stretch>
+            <a:fillRect/>
+          </a:stretch>
+        </p:blipFill>
+        <p:spPr>
+          <a:xfrm>
+            <a:off x="4652323" y="3301844"/>
+            <a:ext cx="2887353" cy="2948397"/>
+          </a:xfrm>
+          <a:prstGeom prst="rect">
+            <a:avLst/>
+          </a:prstGeom>
+        </p:spPr>
+      </p:pic>
+      <p:sp>
+        <p:nvSpPr>
+          <p:cNvPr id="5" name="TextBox 4">
+            <a:extLst>
+              <a:ext uri="{FF2B5EF4-FFF2-40B4-BE49-F238E27FC236}">
+                <a16:creationId xmlns:a16="http://schemas.microsoft.com/office/drawing/2014/main" id="{7710B0EC-36A3-BB2B-40E7-AFCAF75A75FB}"/>
+              </a:ext>
+            </a:extLst>
+          </p:cNvPr>
+          <p:cNvSpPr txBox="1"/>
+          <p:nvPr/>
+        </p:nvSpPr>
+        <p:spPr>
+          <a:xfrm>
+            <a:off x="4835878" y="6492875"/>
+            <a:ext cx="2520242" cy="215444"/>
+          </a:xfrm>
+          <a:prstGeom prst="rect">
+            <a:avLst/>
+          </a:prstGeom>
+          <a:noFill/>
+        </p:spPr>
+        <p:txBody>
+          <a:bodyPr wrap="none" rtlCol="0">
+            <a:spAutoFit/>
+          </a:bodyPr>
+          <a:lstStyle/>
+          <a:p>
+            <a:r>
+              <a:rPr lang="en-US" sz="800" dirty="0"/>
+              <a:t>Image source: https://</a:t>
+            </a:r>
+            <a:r>
+              <a:rPr lang="en-US" sz="800" dirty="0" err="1"/>
+              <a:t>www.wikihow.com</a:t>
+            </a:r>
+            <a:r>
+              <a:rPr lang="en-US" sz="800" dirty="0"/>
+              <a:t>/Play-</a:t>
+            </a:r>
+            <a:r>
+              <a:rPr lang="en-US" sz="800" dirty="0" err="1"/>
+              <a:t>Gomoku</a:t>
+            </a:r>
+            <a:endParaRPr lang="en-US" sz="800" dirty="0"/>
+          </a:p>
+        </p:txBody>
+      </p:sp>
+      <p:sp>
+        <p:nvSpPr>
+          <p:cNvPr id="6" name="Slide Number Placeholder 5">
+            <a:extLst>
+              <a:ext uri="{FF2B5EF4-FFF2-40B4-BE49-F238E27FC236}">
+                <a16:creationId xmlns:a16="http://schemas.microsoft.com/office/drawing/2014/main" id="{1AA73B74-0F50-4E6F-6816-EAB185A781CC}"/>
               </a:ext>
             </a:extLst>
           </p:cNvPr>
@@ -7989,7 +8078,7 @@
     </p:spTree>
     <p:extLst>
       <p:ext uri="{BB962C8B-B14F-4D97-AF65-F5344CB8AC3E}">
-        <p14:creationId xmlns:p14="http://schemas.microsoft.com/office/powerpoint/2010/main" val="2591498733"/>
+        <p14:creationId xmlns:p14="http://schemas.microsoft.com/office/powerpoint/2010/main" val="1014093297"/>
       </p:ext>
     </p:extLst>
   </p:cSld>
@@ -8021,7 +8110,7 @@
           <p:cNvPr id="2" name="Title 1">
             <a:extLst>
               <a:ext uri="{FF2B5EF4-FFF2-40B4-BE49-F238E27FC236}">
-                <a16:creationId xmlns:a16="http://schemas.microsoft.com/office/drawing/2014/main" id="{D74F5CAB-CA8D-CDBB-6DF8-3128CFCECB1B}"/>
+                <a16:creationId xmlns:a16="http://schemas.microsoft.com/office/drawing/2014/main" id="{1874013F-EA8F-5440-7DDB-2D3E2F74CBF2}"/>
               </a:ext>
             </a:extLst>
           </p:cNvPr>
@@ -8039,7 +8128,7 @@
           <a:p>
             <a:r>
               <a:rPr lang="en-US" dirty="0"/>
-              <a:t>Or You Own Project</a:t>
+              <a:t>Project Goal</a:t>
             </a:r>
           </a:p>
         </p:txBody>
@@ -8049,7 +8138,7 @@
           <p:cNvPr id="3" name="Content Placeholder 2">
             <a:extLst>
               <a:ext uri="{FF2B5EF4-FFF2-40B4-BE49-F238E27FC236}">
-                <a16:creationId xmlns:a16="http://schemas.microsoft.com/office/drawing/2014/main" id="{70B7A3E9-C655-21C6-A713-DDA382EDAC89}"/>
+                <a16:creationId xmlns:a16="http://schemas.microsoft.com/office/drawing/2014/main" id="{B2DE82CF-2802-2662-6774-E0E0AF77332D}"/>
               </a:ext>
             </a:extLst>
           </p:cNvPr>
@@ -8067,7 +8156,19 @@
           <a:p>
             <a:r>
               <a:rPr lang="en-US" dirty="0"/>
-              <a:t>Send me a project proposal with specific product features, project milestones, teams members and demonstrate that it’s both manageable and related to class topics.</a:t>
+              <a:t>Build a web application where users can play Gomoku locally or online with a friend by sharing a link</a:t>
+            </a:r>
+          </a:p>
+          <a:p>
+            <a:r>
+              <a:rPr lang="en-US" dirty="0"/>
+              <a:t>Project specification specifies a list of mandatory features, while you can implement additional features you find fun</a:t>
+            </a:r>
+          </a:p>
+          <a:p>
+            <a:r>
+              <a:rPr lang="en-US" dirty="0"/>
+              <a:t>Work in teams of 3 people (form your team by Sep. xxx)</a:t>
             </a:r>
           </a:p>
         </p:txBody>
@@ -8077,7 +8178,7 @@
           <p:cNvPr id="4" name="Slide Number Placeholder 3">
             <a:extLst>
               <a:ext uri="{FF2B5EF4-FFF2-40B4-BE49-F238E27FC236}">
-                <a16:creationId xmlns:a16="http://schemas.microsoft.com/office/drawing/2014/main" id="{29F30F20-58CF-E894-E392-041FCA60228B}"/>
+                <a16:creationId xmlns:a16="http://schemas.microsoft.com/office/drawing/2014/main" id="{E82F27D3-7686-0834-390A-420E102B40C4}"/>
               </a:ext>
             </a:extLst>
           </p:cNvPr>
@@ -8104,7 +8205,7 @@
     </p:spTree>
     <p:extLst>
       <p:ext uri="{BB962C8B-B14F-4D97-AF65-F5344CB8AC3E}">
-        <p14:creationId xmlns:p14="http://schemas.microsoft.com/office/powerpoint/2010/main" val="2219086119"/>
+        <p14:creationId xmlns:p14="http://schemas.microsoft.com/office/powerpoint/2010/main" val="2591498733"/>
       </p:ext>
     </p:extLst>
   </p:cSld>
@@ -8136,7 +8237,7 @@
           <p:cNvPr id="2" name="Title 1">
             <a:extLst>
               <a:ext uri="{FF2B5EF4-FFF2-40B4-BE49-F238E27FC236}">
-                <a16:creationId xmlns:a16="http://schemas.microsoft.com/office/drawing/2014/main" id="{29C53B68-DFE3-BE98-3870-CA1A2D9CA95D}"/>
+                <a16:creationId xmlns:a16="http://schemas.microsoft.com/office/drawing/2014/main" id="{D74F5CAB-CA8D-CDBB-6DF8-3128CFCECB1B}"/>
               </a:ext>
             </a:extLst>
           </p:cNvPr>
@@ -8154,7 +8255,7 @@
           <a:p>
             <a:r>
               <a:rPr lang="en-US" dirty="0"/>
-              <a:t>A Brief History of Software Engineering</a:t>
+              <a:t>Or You Own Project</a:t>
             </a:r>
           </a:p>
         </p:txBody>
@@ -8164,7 +8265,7 @@
           <p:cNvPr id="3" name="Content Placeholder 2">
             <a:extLst>
               <a:ext uri="{FF2B5EF4-FFF2-40B4-BE49-F238E27FC236}">
-                <a16:creationId xmlns:a16="http://schemas.microsoft.com/office/drawing/2014/main" id="{875E1E56-03A5-8977-10DE-81DEC5AFE5E3}"/>
+                <a16:creationId xmlns:a16="http://schemas.microsoft.com/office/drawing/2014/main" id="{70B7A3E9-C655-21C6-A713-DDA382EDAC89}"/>
               </a:ext>
             </a:extLst>
           </p:cNvPr>
@@ -8181,61 +8282,9 @@
           <a:lstStyle/>
           <a:p>
             <a:r>
-              <a:rPr lang="en-US" b="1" dirty="0"/>
-              <a:t>1950s–60s: Early Days</a:t>
-            </a:r>
-            <a:endParaRPr lang="en-US" dirty="0"/>
-          </a:p>
-          <a:p>
-            <a:pPr lvl="1"/>
-            <a:r>
-              <a:rPr lang="en-US" dirty="0"/>
-              <a:t>Software was handcrafted by scientists &amp; engineers</a:t>
-            </a:r>
-          </a:p>
-          <a:p>
-            <a:pPr lvl="1"/>
-            <a:r>
-              <a:rPr lang="en-US" dirty="0"/>
-              <a:t>No standard processes; code was often treated as an accessory to hardware</a:t>
-            </a:r>
-          </a:p>
-          <a:p>
-            <a:r>
-              <a:rPr lang="en-US" b="1" dirty="0"/>
-              <a:t>1968: The "Software Crisis"</a:t>
-            </a:r>
-            <a:endParaRPr lang="en-US" dirty="0"/>
-          </a:p>
-          <a:p>
-            <a:pPr lvl="1"/>
-            <a:r>
-              <a:rPr lang="en-US" dirty="0"/>
-              <a:t>Coined at the NATO Conference on Software Engineering</a:t>
-            </a:r>
-          </a:p>
-          <a:p>
-            <a:pPr lvl="1"/>
-            <a:r>
-              <a:rPr lang="en-US" dirty="0"/>
-              <a:t>Large projects over budget, late, unmaintainable, or outright failures</a:t>
-            </a:r>
-          </a:p>
-          <a:p>
-            <a:pPr lvl="1"/>
-            <a:r>
-              <a:rPr lang="en-US" dirty="0"/>
-              <a:t>Highlighted lack of engineering discipline in software</a:t>
-            </a:r>
-          </a:p>
-          <a:p>
-            <a:endParaRPr lang="en-US" dirty="0"/>
-          </a:p>
-          <a:p>
-            <a:pPr marL="0" indent="0">
-              <a:buNone/>
-            </a:pPr>
-            <a:endParaRPr lang="en-US" sz="1800" dirty="0"/>
+              <a:rPr lang="en-US" dirty="0"/>
+              <a:t>Send me a project proposal with specific product features, project milestones, teams members and demonstrate that it’s both manageable and related to class topics.</a:t>
+            </a:r>
           </a:p>
         </p:txBody>
       </p:sp>
@@ -8244,7 +8293,7 @@
           <p:cNvPr id="4" name="Slide Number Placeholder 3">
             <a:extLst>
               <a:ext uri="{FF2B5EF4-FFF2-40B4-BE49-F238E27FC236}">
-                <a16:creationId xmlns:a16="http://schemas.microsoft.com/office/drawing/2014/main" id="{C8C67C56-0336-0DAC-C32B-9DC0243DE1D8}"/>
+                <a16:creationId xmlns:a16="http://schemas.microsoft.com/office/drawing/2014/main" id="{29F30F20-58CF-E894-E392-041FCA60228B}"/>
               </a:ext>
             </a:extLst>
           </p:cNvPr>
@@ -8271,7 +8320,7 @@
     </p:spTree>
     <p:extLst>
       <p:ext uri="{BB962C8B-B14F-4D97-AF65-F5344CB8AC3E}">
-        <p14:creationId xmlns:p14="http://schemas.microsoft.com/office/powerpoint/2010/main" val="3435083914"/>
+        <p14:creationId xmlns:p14="http://schemas.microsoft.com/office/powerpoint/2010/main" val="2219086119"/>
       </p:ext>
     </p:extLst>
   </p:cSld>
@@ -8286,13 +8335,7 @@
   <p:cSld>
     <p:spTree>
       <p:nvGrpSpPr>
-        <p:cNvPr id="1" name="">
-          <a:extLst>
-            <a:ext uri="{FF2B5EF4-FFF2-40B4-BE49-F238E27FC236}">
-              <a16:creationId xmlns:a16="http://schemas.microsoft.com/office/drawing/2014/main" id="{2038990F-10F2-ECA5-A372-3FA3F3884F45}"/>
-            </a:ext>
-          </a:extLst>
-        </p:cNvPr>
+        <p:cNvPr id="1" name=""/>
         <p:cNvGrpSpPr/>
         <p:nvPr/>
       </p:nvGrpSpPr>
@@ -8309,7 +8352,7 @@
           <p:cNvPr id="2" name="Title 1">
             <a:extLst>
               <a:ext uri="{FF2B5EF4-FFF2-40B4-BE49-F238E27FC236}">
-                <a16:creationId xmlns:a16="http://schemas.microsoft.com/office/drawing/2014/main" id="{473D8CDE-3225-1D98-A8A5-0815E39928B8}"/>
+                <a16:creationId xmlns:a16="http://schemas.microsoft.com/office/drawing/2014/main" id="{29C53B68-DFE3-BE98-3870-CA1A2D9CA95D}"/>
               </a:ext>
             </a:extLst>
           </p:cNvPr>
@@ -8337,7 +8380,7 @@
           <p:cNvPr id="3" name="Content Placeholder 2">
             <a:extLst>
               <a:ext uri="{FF2B5EF4-FFF2-40B4-BE49-F238E27FC236}">
-                <a16:creationId xmlns:a16="http://schemas.microsoft.com/office/drawing/2014/main" id="{423B6D85-4155-DF51-BAF8-E2DBE4723D13}"/>
+                <a16:creationId xmlns:a16="http://schemas.microsoft.com/office/drawing/2014/main" id="{875E1E56-03A5-8977-10DE-81DEC5AFE5E3}"/>
               </a:ext>
             </a:extLst>
           </p:cNvPr>
@@ -8355,7 +8398,7 @@
           <a:p>
             <a:r>
               <a:rPr lang="en-US" b="1" dirty="0"/>
-              <a:t>1970s–90s: Foundational Work</a:t>
+              <a:t>1950s–60s: Early Days</a:t>
             </a:r>
             <a:endParaRPr lang="en-US" dirty="0"/>
           </a:p>
@@ -8363,57 +8406,52 @@
             <a:pPr lvl="1"/>
             <a:r>
               <a:rPr lang="en-US" dirty="0"/>
-              <a:t>Structured programming (Dijkstra, Parnas)</a:t>
+              <a:t>Software was handcrafted by scientists &amp; engineers</a:t>
             </a:r>
           </a:p>
           <a:p>
             <a:pPr lvl="1"/>
             <a:r>
               <a:rPr lang="en-US" dirty="0"/>
-              <a:t>Object-Oriented programming (Simula -&gt; Smalltalk -&gt; C++)</a:t>
-            </a:r>
+              <a:t>No standard processes; code was often treated as an accessory to hardware</a:t>
+            </a:r>
+          </a:p>
+          <a:p>
+            <a:r>
+              <a:rPr lang="en-US" b="1" dirty="0"/>
+              <a:t>1968: The "Software Crisis"</a:t>
+            </a:r>
+            <a:endParaRPr lang="en-US" dirty="0"/>
           </a:p>
           <a:p>
             <a:pPr lvl="1"/>
             <a:r>
               <a:rPr lang="en-US" dirty="0"/>
-              <a:t>Waterfall model (Winston Royce)</a:t>
+              <a:t>Coined at the NATO Conference on Software Engineering</a:t>
             </a:r>
           </a:p>
           <a:p>
             <a:pPr lvl="1"/>
             <a:r>
               <a:rPr lang="en-US" dirty="0"/>
-              <a:t>SE education and textbooks emerge</a:t>
-            </a:r>
-          </a:p>
-          <a:p>
-            <a:r>
-              <a:rPr lang="en-US" b="1" dirty="0"/>
-              <a:t>2000s–Now: Agile &amp; Beyond</a:t>
-            </a:r>
+              <a:t>Large projects over budget, late, unmaintainable, or outright failures</a:t>
+            </a:r>
+          </a:p>
+          <a:p>
+            <a:pPr lvl="1"/>
+            <a:r>
+              <a:rPr lang="en-US" dirty="0"/>
+              <a:t>Highlighted lack of engineering discipline in software</a:t>
+            </a:r>
+          </a:p>
+          <a:p>
             <a:endParaRPr lang="en-US" dirty="0"/>
           </a:p>
           <a:p>
-            <a:pPr lvl="1"/>
-            <a:r>
-              <a:rPr lang="en-US" dirty="0"/>
-              <a:t>Agile Manifesto (2001) → shift toward adaptability and people</a:t>
-            </a:r>
-          </a:p>
-          <a:p>
-            <a:pPr lvl="1"/>
-            <a:r>
-              <a:rPr lang="en-US" dirty="0"/>
-              <a:t>Rise of DevOps, CI/CD, microservices</a:t>
-            </a:r>
-          </a:p>
-          <a:p>
-            <a:pPr lvl="1"/>
-            <a:r>
-              <a:rPr lang="en-US" dirty="0"/>
-              <a:t>Software as infrastructure (cloud, AI, ML systems)</a:t>
-            </a:r>
+            <a:pPr marL="0" indent="0">
+              <a:buNone/>
+            </a:pPr>
+            <a:endParaRPr lang="en-US" sz="1800" dirty="0"/>
           </a:p>
         </p:txBody>
       </p:sp>
@@ -8422,7 +8460,7 @@
           <p:cNvPr id="4" name="Slide Number Placeholder 3">
             <a:extLst>
               <a:ext uri="{FF2B5EF4-FFF2-40B4-BE49-F238E27FC236}">
-                <a16:creationId xmlns:a16="http://schemas.microsoft.com/office/drawing/2014/main" id="{D96A75AD-BB33-AD84-5366-26A21EE7D6D0}"/>
+                <a16:creationId xmlns:a16="http://schemas.microsoft.com/office/drawing/2014/main" id="{C8C67C56-0336-0DAC-C32B-9DC0243DE1D8}"/>
               </a:ext>
             </a:extLst>
           </p:cNvPr>
@@ -8449,7 +8487,7 @@
     </p:spTree>
     <p:extLst>
       <p:ext uri="{BB962C8B-B14F-4D97-AF65-F5344CB8AC3E}">
-        <p14:creationId xmlns:p14="http://schemas.microsoft.com/office/powerpoint/2010/main" val="1541740352"/>
+        <p14:creationId xmlns:p14="http://schemas.microsoft.com/office/powerpoint/2010/main" val="3435083914"/>
       </p:ext>
     </p:extLst>
   </p:cSld>
@@ -8654,7 +8692,13 @@
   <p:cSld>
     <p:spTree>
       <p:nvGrpSpPr>
-        <p:cNvPr id="1" name=""/>
+        <p:cNvPr id="1" name="">
+          <a:extLst>
+            <a:ext uri="{FF2B5EF4-FFF2-40B4-BE49-F238E27FC236}">
+              <a16:creationId xmlns:a16="http://schemas.microsoft.com/office/drawing/2014/main" id="{2038990F-10F2-ECA5-A372-3FA3F3884F45}"/>
+            </a:ext>
+          </a:extLst>
+        </p:cNvPr>
         <p:cNvGrpSpPr/>
         <p:nvPr/>
       </p:nvGrpSpPr>
@@ -8671,7 +8715,7 @@
           <p:cNvPr id="2" name="Title 1">
             <a:extLst>
               <a:ext uri="{FF2B5EF4-FFF2-40B4-BE49-F238E27FC236}">
-                <a16:creationId xmlns:a16="http://schemas.microsoft.com/office/drawing/2014/main" id="{14C38D71-44FE-058A-F860-DCFB08702132}"/>
+                <a16:creationId xmlns:a16="http://schemas.microsoft.com/office/drawing/2014/main" id="{473D8CDE-3225-1D98-A8A5-0815E39928B8}"/>
               </a:ext>
             </a:extLst>
           </p:cNvPr>
@@ -8689,7 +8733,7 @@
           <a:p>
             <a:r>
               <a:rPr lang="en-US" dirty="0"/>
-              <a:t>No Silver Bullet</a:t>
+              <a:t>A Brief History of Software Engineering</a:t>
             </a:r>
           </a:p>
         </p:txBody>
@@ -8699,7 +8743,7 @@
           <p:cNvPr id="3" name="Content Placeholder 2">
             <a:extLst>
               <a:ext uri="{FF2B5EF4-FFF2-40B4-BE49-F238E27FC236}">
-                <a16:creationId xmlns:a16="http://schemas.microsoft.com/office/drawing/2014/main" id="{DB9E00B0-01BA-3114-B3CD-7DE5C95442F8}"/>
+                <a16:creationId xmlns:a16="http://schemas.microsoft.com/office/drawing/2014/main" id="{423B6D85-4155-DF51-BAF8-E2DBE4723D13}"/>
               </a:ext>
             </a:extLst>
           </p:cNvPr>
@@ -8716,54 +8760,66 @@
           <a:lstStyle/>
           <a:p>
             <a:r>
-              <a:rPr lang="en-US" dirty="0"/>
-              <a:t>One of the most influential papers in the history of software engineering by Fred Brooks in 1986.</a:t>
-            </a:r>
-          </a:p>
-          <a:p>
+              <a:rPr lang="en-US" b="1" dirty="0"/>
+              <a:t>1970s–90s: Foundational Work</a:t>
+            </a:r>
             <a:endParaRPr lang="en-US" dirty="0"/>
           </a:p>
           <a:p>
+            <a:pPr lvl="1"/>
+            <a:r>
+              <a:rPr lang="en-US" dirty="0"/>
+              <a:t>Structured programming (Dijkstra, Parnas)</a:t>
+            </a:r>
+          </a:p>
+          <a:p>
+            <a:pPr lvl="1"/>
+            <a:r>
+              <a:rPr lang="en-US" dirty="0"/>
+              <a:t>Object-Oriented programming (Simula -&gt; Smalltalk -&gt; C++)</a:t>
+            </a:r>
+          </a:p>
+          <a:p>
+            <a:pPr lvl="1"/>
+            <a:r>
+              <a:rPr lang="en-US" dirty="0"/>
+              <a:t>Waterfall model (Winston Royce)</a:t>
+            </a:r>
+          </a:p>
+          <a:p>
+            <a:pPr lvl="1"/>
+            <a:r>
+              <a:rPr lang="en-US" dirty="0"/>
+              <a:t>SE education and textbooks emerge</a:t>
+            </a:r>
+          </a:p>
+          <a:p>
+            <a:r>
+              <a:rPr lang="en-US" b="1" dirty="0"/>
+              <a:t>2000s–Now: Agile &amp; Beyond</a:t>
+            </a:r>
             <a:endParaRPr lang="en-US" dirty="0"/>
           </a:p>
           <a:p>
-            <a:pPr marL="0" indent="0">
-              <a:buNone/>
-            </a:pPr>
-            <a:r>
-              <a:rPr lang="en-US" dirty="0"/>
-              <a:t>Acknowledgement: slides are inspired by Prof. Kenneth Anderson.</a:t>
-            </a:r>
-          </a:p>
-          <a:p>
-            <a:pPr marL="0" indent="0">
-              <a:buNone/>
-            </a:pPr>
-            <a:endParaRPr lang="en-US" dirty="0"/>
-          </a:p>
-          <a:p>
-            <a:pPr marL="0" indent="0">
-              <a:buNone/>
-            </a:pPr>
-            <a:endParaRPr lang="en-US" dirty="0"/>
-          </a:p>
-          <a:p>
-            <a:pPr marL="0" indent="0">
-              <a:buNone/>
-            </a:pPr>
-            <a:endParaRPr lang="en-US" dirty="0"/>
-          </a:p>
-          <a:p>
-            <a:pPr marL="0" indent="0">
-              <a:buNone/>
-            </a:pPr>
-            <a:endParaRPr lang="en-US" dirty="0"/>
-          </a:p>
-          <a:p>
-            <a:pPr marL="0" indent="0">
-              <a:buNone/>
-            </a:pPr>
-            <a:endParaRPr lang="en-US" dirty="0"/>
+            <a:pPr lvl="1"/>
+            <a:r>
+              <a:rPr lang="en-US" dirty="0"/>
+              <a:t>Agile Manifesto (2001) → shift toward adaptability and people</a:t>
+            </a:r>
+          </a:p>
+          <a:p>
+            <a:pPr lvl="1"/>
+            <a:r>
+              <a:rPr lang="en-US" dirty="0"/>
+              <a:t>Rise of DevOps, CI/CD, microservices</a:t>
+            </a:r>
+          </a:p>
+          <a:p>
+            <a:pPr lvl="1"/>
+            <a:r>
+              <a:rPr lang="en-US" dirty="0"/>
+              <a:t>Software as infrastructure (cloud, AI, ML systems)</a:t>
+            </a:r>
           </a:p>
         </p:txBody>
       </p:sp>
@@ -8772,7 +8828,7 @@
           <p:cNvPr id="4" name="Slide Number Placeholder 3">
             <a:extLst>
               <a:ext uri="{FF2B5EF4-FFF2-40B4-BE49-F238E27FC236}">
-                <a16:creationId xmlns:a16="http://schemas.microsoft.com/office/drawing/2014/main" id="{C3B26FA3-5ABF-0570-68EB-B418F6BC2C08}"/>
+                <a16:creationId xmlns:a16="http://schemas.microsoft.com/office/drawing/2014/main" id="{D96A75AD-BB33-AD84-5366-26A21EE7D6D0}"/>
               </a:ext>
             </a:extLst>
           </p:cNvPr>
@@ -8799,7 +8855,7 @@
     </p:spTree>
     <p:extLst>
       <p:ext uri="{BB962C8B-B14F-4D97-AF65-F5344CB8AC3E}">
-        <p14:creationId xmlns:p14="http://schemas.microsoft.com/office/powerpoint/2010/main" val="3785713702"/>
+        <p14:creationId xmlns:p14="http://schemas.microsoft.com/office/powerpoint/2010/main" val="1541740352"/>
       </p:ext>
     </p:extLst>
   </p:cSld>
@@ -8831,7 +8887,7 @@
           <p:cNvPr id="2" name="Title 1">
             <a:extLst>
               <a:ext uri="{FF2B5EF4-FFF2-40B4-BE49-F238E27FC236}">
-                <a16:creationId xmlns:a16="http://schemas.microsoft.com/office/drawing/2014/main" id="{E269875F-9BB7-898F-C153-42CD7A1DE9AA}"/>
+                <a16:creationId xmlns:a16="http://schemas.microsoft.com/office/drawing/2014/main" id="{14C38D71-44FE-058A-F860-DCFB08702132}"/>
               </a:ext>
             </a:extLst>
           </p:cNvPr>
@@ -8859,7 +8915,7 @@
           <p:cNvPr id="3" name="Content Placeholder 2">
             <a:extLst>
               <a:ext uri="{FF2B5EF4-FFF2-40B4-BE49-F238E27FC236}">
-                <a16:creationId xmlns:a16="http://schemas.microsoft.com/office/drawing/2014/main" id="{D00384A3-C10F-EDC9-5050-1CAC1879C5A8}"/>
+                <a16:creationId xmlns:a16="http://schemas.microsoft.com/office/drawing/2014/main" id="{DB9E00B0-01BA-3114-B3CD-7DE5C95442F8}"/>
               </a:ext>
             </a:extLst>
           </p:cNvPr>
@@ -8870,22 +8926,29 @@
             <p:ph idx="1"/>
           </p:nvPr>
         </p:nvSpPr>
-        <p:spPr>
-          <a:xfrm>
-            <a:off x="838200" y="1825625"/>
-            <a:ext cx="10586884" cy="4351338"/>
-          </a:xfrm>
-        </p:spPr>
-        <p:txBody>
-          <a:bodyPr/>
-          <a:lstStyle/>
+        <p:spPr/>
+        <p:txBody>
+          <a:bodyPr/>
+          <a:lstStyle/>
+          <a:p>
+            <a:r>
+              <a:rPr lang="en-US" dirty="0"/>
+              <a:t>One of the most influential papers in the history of software engineering by Fred Brooks in 1986.</a:t>
+            </a:r>
+          </a:p>
+          <a:p>
+            <a:endParaRPr lang="en-US" dirty="0"/>
+          </a:p>
+          <a:p>
+            <a:endParaRPr lang="en-US" dirty="0"/>
+          </a:p>
           <a:p>
             <a:pPr marL="0" indent="0">
               <a:buNone/>
             </a:pPr>
             <a:r>
               <a:rPr lang="en-US" dirty="0"/>
-              <a:t>“There is no single development, in either technology or management technique, which by itself promises even one order-of-magnitude improvement within a decade in productivity, in reliability, in simplicity.”</a:t>
+              <a:t>Acknowledgement: slides are inspired by Prof. Kenneth Anderson.</a:t>
             </a:r>
           </a:p>
           <a:p>
@@ -8898,26 +8961,25 @@
             <a:pPr marL="0" indent="0">
               <a:buNone/>
             </a:pPr>
-            <a:r>
-              <a:rPr lang="en-US" dirty="0"/>
-              <a:t>---- Fred Brooks, 1986</a:t>
-            </a:r>
-          </a:p>
-          <a:p>
-            <a:pPr>
-              <a:buFont typeface="Wingdings" pitchFamily="2" charset="2"/>
-              <a:buChar char="n"/>
-            </a:pPr>
             <a:endParaRPr lang="en-US" dirty="0"/>
           </a:p>
           <a:p>
             <a:pPr marL="0" indent="0">
               <a:buNone/>
             </a:pPr>
-            <a:r>
-              <a:rPr lang="en-US" dirty="0"/>
-              <a:t>i.e. There is no magical cure for the “software crisis”</a:t>
-            </a:r>
+            <a:endParaRPr lang="en-US" dirty="0"/>
+          </a:p>
+          <a:p>
+            <a:pPr marL="0" indent="0">
+              <a:buNone/>
+            </a:pPr>
+            <a:endParaRPr lang="en-US" dirty="0"/>
+          </a:p>
+          <a:p>
+            <a:pPr marL="0" indent="0">
+              <a:buNone/>
+            </a:pPr>
+            <a:endParaRPr lang="en-US" dirty="0"/>
           </a:p>
         </p:txBody>
       </p:sp>
@@ -8926,7 +8988,7 @@
           <p:cNvPr id="4" name="Slide Number Placeholder 3">
             <a:extLst>
               <a:ext uri="{FF2B5EF4-FFF2-40B4-BE49-F238E27FC236}">
-                <a16:creationId xmlns:a16="http://schemas.microsoft.com/office/drawing/2014/main" id="{F97FAC74-EE87-48F1-E4E5-1B9D123B62A2}"/>
+                <a16:creationId xmlns:a16="http://schemas.microsoft.com/office/drawing/2014/main" id="{C3B26FA3-5ABF-0570-68EB-B418F6BC2C08}"/>
               </a:ext>
             </a:extLst>
           </p:cNvPr>
@@ -8953,7 +9015,7 @@
     </p:spTree>
     <p:extLst>
       <p:ext uri="{BB962C8B-B14F-4D97-AF65-F5344CB8AC3E}">
-        <p14:creationId xmlns:p14="http://schemas.microsoft.com/office/powerpoint/2010/main" val="3321343231"/>
+        <p14:creationId xmlns:p14="http://schemas.microsoft.com/office/powerpoint/2010/main" val="3785713702"/>
       </p:ext>
     </p:extLst>
   </p:cSld>
@@ -8985,7 +9047,7 @@
           <p:cNvPr id="2" name="Title 1">
             <a:extLst>
               <a:ext uri="{FF2B5EF4-FFF2-40B4-BE49-F238E27FC236}">
-                <a16:creationId xmlns:a16="http://schemas.microsoft.com/office/drawing/2014/main" id="{591E2F4F-3E0C-6C26-CD1D-26690D7B382A}"/>
+                <a16:creationId xmlns:a16="http://schemas.microsoft.com/office/drawing/2014/main" id="{E269875F-9BB7-898F-C153-42CD7A1DE9AA}"/>
               </a:ext>
             </a:extLst>
           </p:cNvPr>
@@ -9003,7 +9065,7 @@
           <a:p>
             <a:r>
               <a:rPr lang="en-US" dirty="0"/>
-              <a:t>Why? Essence and Accidents</a:t>
+              <a:t>No Silver Bullet</a:t>
             </a:r>
           </a:p>
         </p:txBody>
@@ -9013,7 +9075,7 @@
           <p:cNvPr id="3" name="Content Placeholder 2">
             <a:extLst>
               <a:ext uri="{FF2B5EF4-FFF2-40B4-BE49-F238E27FC236}">
-                <a16:creationId xmlns:a16="http://schemas.microsoft.com/office/drawing/2014/main" id="{D9364D6B-A862-B5D6-6509-E2320CECE7FE}"/>
+                <a16:creationId xmlns:a16="http://schemas.microsoft.com/office/drawing/2014/main" id="{D00384A3-C10F-EDC9-5050-1CAC1879C5A8}"/>
               </a:ext>
             </a:extLst>
           </p:cNvPr>
@@ -9024,42 +9086,53 @@
             <p:ph idx="1"/>
           </p:nvPr>
         </p:nvSpPr>
-        <p:spPr/>
-        <p:txBody>
-          <a:bodyPr/>
-          <a:lstStyle/>
-          <a:p>
-            <a:r>
-              <a:rPr lang="en-US" dirty="0"/>
-              <a:t>Brooks divides the problems facing software engineering into two categories</a:t>
-            </a:r>
-          </a:p>
-          <a:p>
-            <a:pPr lvl="1"/>
-            <a:r>
-              <a:rPr lang="en-US" b="1" dirty="0"/>
-              <a:t>Essence</a:t>
-            </a:r>
-            <a:r>
-              <a:rPr lang="en-US" dirty="0"/>
-              <a:t>: difficulties inherent in the nature of software</a:t>
-            </a:r>
-          </a:p>
-          <a:p>
-            <a:pPr lvl="1"/>
-            <a:r>
-              <a:rPr lang="en-US" b="1" dirty="0"/>
-              <a:t>Accidents</a:t>
-            </a:r>
-            <a:r>
-              <a:rPr lang="en-US" dirty="0"/>
-              <a:t>: difficulties related to the production of software</a:t>
-            </a:r>
-          </a:p>
-          <a:p>
-            <a:r>
-              <a:rPr lang="en-US" dirty="0"/>
-              <a:t>Brooks argues that most techniques attack the accidents of software engineering</a:t>
+        <p:spPr>
+          <a:xfrm>
+            <a:off x="838200" y="1825625"/>
+            <a:ext cx="10586884" cy="4351338"/>
+          </a:xfrm>
+        </p:spPr>
+        <p:txBody>
+          <a:bodyPr/>
+          <a:lstStyle/>
+          <a:p>
+            <a:pPr marL="0" indent="0">
+              <a:buNone/>
+            </a:pPr>
+            <a:r>
+              <a:rPr lang="en-US" dirty="0"/>
+              <a:t>“There is no single development, in either technology or management technique, which by itself promises even one order-of-magnitude improvement within a decade in productivity, in reliability, in simplicity.”</a:t>
+            </a:r>
+          </a:p>
+          <a:p>
+            <a:pPr marL="0" indent="0">
+              <a:buNone/>
+            </a:pPr>
+            <a:endParaRPr lang="en-US" dirty="0"/>
+          </a:p>
+          <a:p>
+            <a:pPr marL="0" indent="0">
+              <a:buNone/>
+            </a:pPr>
+            <a:r>
+              <a:rPr lang="en-US" dirty="0"/>
+              <a:t>---- Fred Brooks, 1986</a:t>
+            </a:r>
+          </a:p>
+          <a:p>
+            <a:pPr>
+              <a:buFont typeface="Wingdings" pitchFamily="2" charset="2"/>
+              <a:buChar char="n"/>
+            </a:pPr>
+            <a:endParaRPr lang="en-US" dirty="0"/>
+          </a:p>
+          <a:p>
+            <a:pPr marL="0" indent="0">
+              <a:buNone/>
+            </a:pPr>
+            <a:r>
+              <a:rPr lang="en-US" dirty="0"/>
+              <a:t>i.e. There is no magical cure for the “software crisis”</a:t>
             </a:r>
           </a:p>
         </p:txBody>
@@ -9069,7 +9142,7 @@
           <p:cNvPr id="4" name="Slide Number Placeholder 3">
             <a:extLst>
               <a:ext uri="{FF2B5EF4-FFF2-40B4-BE49-F238E27FC236}">
-                <a16:creationId xmlns:a16="http://schemas.microsoft.com/office/drawing/2014/main" id="{45BFFC80-0C92-A779-0DDD-973AD920686A}"/>
+                <a16:creationId xmlns:a16="http://schemas.microsoft.com/office/drawing/2014/main" id="{F97FAC74-EE87-48F1-E4E5-1B9D123B62A2}"/>
               </a:ext>
             </a:extLst>
           </p:cNvPr>
@@ -9096,7 +9169,7 @@
     </p:spTree>
     <p:extLst>
       <p:ext uri="{BB962C8B-B14F-4D97-AF65-F5344CB8AC3E}">
-        <p14:creationId xmlns:p14="http://schemas.microsoft.com/office/powerpoint/2010/main" val="136927100"/>
+        <p14:creationId xmlns:p14="http://schemas.microsoft.com/office/powerpoint/2010/main" val="3321343231"/>
       </p:ext>
     </p:extLst>
   </p:cSld>
@@ -9128,7 +9201,7 @@
           <p:cNvPr id="2" name="Title 1">
             <a:extLst>
               <a:ext uri="{FF2B5EF4-FFF2-40B4-BE49-F238E27FC236}">
-                <a16:creationId xmlns:a16="http://schemas.microsoft.com/office/drawing/2014/main" id="{DF0D2778-54F1-7A29-5481-F6A1A67120A7}"/>
+                <a16:creationId xmlns:a16="http://schemas.microsoft.com/office/drawing/2014/main" id="{591E2F4F-3E0C-6C26-CD1D-26690D7B382A}"/>
               </a:ext>
             </a:extLst>
           </p:cNvPr>
@@ -9146,7 +9219,7 @@
           <a:p>
             <a:r>
               <a:rPr lang="en-US" dirty="0"/>
-              <a:t>The Four Essential Difficulties</a:t>
+              <a:t>Why? Essence and Accidents</a:t>
             </a:r>
           </a:p>
         </p:txBody>
@@ -9156,7 +9229,7 @@
           <p:cNvPr id="3" name="Content Placeholder 2">
             <a:extLst>
               <a:ext uri="{FF2B5EF4-FFF2-40B4-BE49-F238E27FC236}">
-                <a16:creationId xmlns:a16="http://schemas.microsoft.com/office/drawing/2014/main" id="{9E62E67D-9522-3EBE-B45D-18639062B65F}"/>
+                <a16:creationId xmlns:a16="http://schemas.microsoft.com/office/drawing/2014/main" id="{D9364D6B-A862-B5D6-6509-E2320CECE7FE}"/>
               </a:ext>
             </a:extLst>
           </p:cNvPr>
@@ -9172,58 +9245,37 @@
           <a:bodyPr/>
           <a:lstStyle/>
           <a:p>
-            <a:pPr marL="0" indent="0">
-              <a:buNone/>
-            </a:pPr>
-            <a:r>
-              <a:rPr lang="en-US" dirty="0"/>
-              <a:t>Why Software is Inherently Hard?</a:t>
-            </a:r>
-          </a:p>
-          <a:p>
-            <a:pPr marL="0" indent="0">
-              <a:buNone/>
-            </a:pPr>
-            <a:endParaRPr lang="en-US" dirty="0"/>
-          </a:p>
-          <a:p>
+            <a:r>
+              <a:rPr lang="en-US" dirty="0"/>
+              <a:t>Brooks divides the problems facing software engineering into two categories</a:t>
+            </a:r>
+          </a:p>
+          <a:p>
+            <a:pPr lvl="1"/>
             <a:r>
               <a:rPr lang="en-US" b="1" dirty="0"/>
-              <a:t>Complexity</a:t>
-            </a:r>
-            <a:r>
-              <a:rPr lang="en-US" dirty="0"/>
-              <a:t>: Software systems are more complex than other human constructs; no two parts are alike.</a:t>
-            </a:r>
-          </a:p>
-          <a:p>
+              <a:t>Essence</a:t>
+            </a:r>
+            <a:r>
+              <a:rPr lang="en-US" dirty="0"/>
+              <a:t>: difficulties inherent in the nature of software</a:t>
+            </a:r>
+          </a:p>
+          <a:p>
+            <a:pPr lvl="1"/>
             <a:r>
               <a:rPr lang="en-US" b="1" dirty="0"/>
-              <a:t>Conformity</a:t>
-            </a:r>
-            <a:r>
-              <a:rPr lang="en-US" dirty="0"/>
-              <a:t>: Software must conform to a variety of human institutions and systems.</a:t>
-            </a:r>
-          </a:p>
-          <a:p>
-            <a:r>
-              <a:rPr lang="en-US" b="1" dirty="0"/>
-              <a:t>Changeability</a:t>
-            </a:r>
-            <a:r>
-              <a:rPr lang="en-US" dirty="0"/>
-              <a:t>: Software is constantly under pressure to change to meet new demands.</a:t>
-            </a:r>
-          </a:p>
-          <a:p>
-            <a:r>
-              <a:rPr lang="en-US" b="1" dirty="0"/>
-              <a:t>Invisibility</a:t>
-            </a:r>
-            <a:r>
-              <a:rPr lang="en-US" dirty="0"/>
-              <a:t>: Software is an abstract construct; it's hard to visualize.</a:t>
+              <a:t>Accidents</a:t>
+            </a:r>
+            <a:r>
+              <a:rPr lang="en-US" dirty="0"/>
+              <a:t>: difficulties related to the production of software</a:t>
+            </a:r>
+          </a:p>
+          <a:p>
+            <a:r>
+              <a:rPr lang="en-US" dirty="0"/>
+              <a:t>Brooks argues that most techniques attack the accidents of software engineering</a:t>
             </a:r>
           </a:p>
         </p:txBody>
@@ -9233,7 +9285,7 @@
           <p:cNvPr id="4" name="Slide Number Placeholder 3">
             <a:extLst>
               <a:ext uri="{FF2B5EF4-FFF2-40B4-BE49-F238E27FC236}">
-                <a16:creationId xmlns:a16="http://schemas.microsoft.com/office/drawing/2014/main" id="{728633FF-6B7D-76EB-B7F2-146E0F752330}"/>
+                <a16:creationId xmlns:a16="http://schemas.microsoft.com/office/drawing/2014/main" id="{45BFFC80-0C92-A779-0DDD-973AD920686A}"/>
               </a:ext>
             </a:extLst>
           </p:cNvPr>
@@ -9260,7 +9312,7 @@
     </p:spTree>
     <p:extLst>
       <p:ext uri="{BB962C8B-B14F-4D97-AF65-F5344CB8AC3E}">
-        <p14:creationId xmlns:p14="http://schemas.microsoft.com/office/powerpoint/2010/main" val="1885371618"/>
+        <p14:creationId xmlns:p14="http://schemas.microsoft.com/office/powerpoint/2010/main" val="136927100"/>
       </p:ext>
     </p:extLst>
   </p:cSld>
@@ -9292,7 +9344,7 @@
           <p:cNvPr id="2" name="Title 1">
             <a:extLst>
               <a:ext uri="{FF2B5EF4-FFF2-40B4-BE49-F238E27FC236}">
-                <a16:creationId xmlns:a16="http://schemas.microsoft.com/office/drawing/2014/main" id="{9B261BE8-3893-B023-55F5-A424A12572B7}"/>
+                <a16:creationId xmlns:a16="http://schemas.microsoft.com/office/drawing/2014/main" id="{DF0D2778-54F1-7A29-5481-F6A1A67120A7}"/>
               </a:ext>
             </a:extLst>
           </p:cNvPr>
@@ -9310,7 +9362,7 @@
           <a:p>
             <a:r>
               <a:rPr lang="en-US" dirty="0"/>
-              <a:t>Past Solutions (The "Accidental" Gains)</a:t>
+              <a:t>The Four Essential Difficulties</a:t>
             </a:r>
           </a:p>
         </p:txBody>
@@ -9320,7 +9372,7 @@
           <p:cNvPr id="3" name="Content Placeholder 2">
             <a:extLst>
               <a:ext uri="{FF2B5EF4-FFF2-40B4-BE49-F238E27FC236}">
-                <a16:creationId xmlns:a16="http://schemas.microsoft.com/office/drawing/2014/main" id="{E101E67F-7F3D-9681-331A-C4991789295D}"/>
+                <a16:creationId xmlns:a16="http://schemas.microsoft.com/office/drawing/2014/main" id="{9E62E67D-9522-3EBE-B45D-18639062B65F}"/>
               </a:ext>
             </a:extLst>
           </p:cNvPr>
@@ -9341,7 +9393,7 @@
             </a:pPr>
             <a:r>
               <a:rPr lang="en-US" dirty="0"/>
-              <a:t>Most of the big productivity gains in the past solved accidental problems.</a:t>
+              <a:t>Why Software is Inherently Hard?</a:t>
             </a:r>
           </a:p>
           <a:p>
@@ -9351,52 +9403,44 @@
             <a:endParaRPr lang="en-US" dirty="0"/>
           </a:p>
           <a:p>
-            <a:pPr>
-              <a:buFont typeface="Arial" panose="020B0604020202020204" pitchFamily="34" charset="0"/>
-              <a:buChar char="•"/>
-            </a:pPr>
             <a:r>
               <a:rPr lang="en-US" b="1" dirty="0"/>
-              <a:t>High-level languages:</a:t>
-            </a:r>
-            <a:r>
-              <a:rPr lang="en-US" dirty="0"/>
-              <a:t> Eliminated the complexity of writing machine-level code.</a:t>
-            </a:r>
-          </a:p>
-          <a:p>
-            <a:pPr>
-              <a:buFont typeface="Arial" panose="020B0604020202020204" pitchFamily="34" charset="0"/>
-              <a:buChar char="•"/>
-            </a:pPr>
+              <a:t>Complexity</a:t>
+            </a:r>
+            <a:r>
+              <a:rPr lang="en-US" dirty="0"/>
+              <a:t>: Software systems are more complex than other human constructs; no two parts are alike.</a:t>
+            </a:r>
+          </a:p>
+          <a:p>
             <a:r>
               <a:rPr lang="en-US" b="1" dirty="0"/>
-              <a:t>Time-sharing:</a:t>
-            </a:r>
-            <a:r>
-              <a:rPr lang="en-US" dirty="0"/>
-              <a:t> Reduced slow turnaround times.</a:t>
-            </a:r>
-          </a:p>
-          <a:p>
-            <a:pPr>
-              <a:buFont typeface="Arial" panose="020B0604020202020204" pitchFamily="34" charset="0"/>
-              <a:buChar char="•"/>
-            </a:pPr>
+              <a:t>Conformity</a:t>
+            </a:r>
+            <a:r>
+              <a:rPr lang="en-US" dirty="0"/>
+              <a:t>: Software must conform to a variety of human institutions and systems.</a:t>
+            </a:r>
+          </a:p>
+          <a:p>
             <a:r>
               <a:rPr lang="en-US" b="1" dirty="0"/>
-              <a:t>Unified programming environments:</a:t>
-            </a:r>
-            <a:r>
-              <a:rPr lang="en-US" dirty="0"/>
-              <a:t> Improved the way programs work together.</a:t>
-            </a:r>
-          </a:p>
-          <a:p>
-            <a:pPr marL="0" indent="0">
-              <a:buNone/>
-            </a:pPr>
-            <a:endParaRPr lang="en-US" dirty="0"/>
+              <a:t>Changeability</a:t>
+            </a:r>
+            <a:r>
+              <a:rPr lang="en-US" dirty="0"/>
+              <a:t>: Software is constantly under pressure to change to meet new demands.</a:t>
+            </a:r>
+          </a:p>
+          <a:p>
+            <a:r>
+              <a:rPr lang="en-US" b="1" dirty="0"/>
+              <a:t>Invisibility</a:t>
+            </a:r>
+            <a:r>
+              <a:rPr lang="en-US" dirty="0"/>
+              <a:t>: Software is an abstract construct; it's hard to visualize.</a:t>
+            </a:r>
           </a:p>
         </p:txBody>
       </p:sp>
@@ -9405,7 +9449,7 @@
           <p:cNvPr id="4" name="Slide Number Placeholder 3">
             <a:extLst>
               <a:ext uri="{FF2B5EF4-FFF2-40B4-BE49-F238E27FC236}">
-                <a16:creationId xmlns:a16="http://schemas.microsoft.com/office/drawing/2014/main" id="{B41DAB98-3AAE-42E5-3150-DD60A12180B0}"/>
+                <a16:creationId xmlns:a16="http://schemas.microsoft.com/office/drawing/2014/main" id="{728633FF-6B7D-76EB-B7F2-146E0F752330}"/>
               </a:ext>
             </a:extLst>
           </p:cNvPr>
@@ -9432,7 +9476,7 @@
     </p:spTree>
     <p:extLst>
       <p:ext uri="{BB962C8B-B14F-4D97-AF65-F5344CB8AC3E}">
-        <p14:creationId xmlns:p14="http://schemas.microsoft.com/office/powerpoint/2010/main" val="579760326"/>
+        <p14:creationId xmlns:p14="http://schemas.microsoft.com/office/powerpoint/2010/main" val="1885371618"/>
       </p:ext>
     </p:extLst>
   </p:cSld>
@@ -9464,7 +9508,7 @@
           <p:cNvPr id="2" name="Title 1">
             <a:extLst>
               <a:ext uri="{FF2B5EF4-FFF2-40B4-BE49-F238E27FC236}">
-                <a16:creationId xmlns:a16="http://schemas.microsoft.com/office/drawing/2014/main" id="{1CBF31AE-A851-A9F1-84C9-7C598CD7DAAC}"/>
+                <a16:creationId xmlns:a16="http://schemas.microsoft.com/office/drawing/2014/main" id="{9B261BE8-3893-B023-55F5-A424A12572B7}"/>
               </a:ext>
             </a:extLst>
           </p:cNvPr>
@@ -9482,7 +9526,7 @@
           <a:p>
             <a:r>
               <a:rPr lang="en-US" dirty="0"/>
-              <a:t>New Hopes</a:t>
+              <a:t>Past Solutions (The "Accidental" Gains)</a:t>
             </a:r>
           </a:p>
         </p:txBody>
@@ -9492,7 +9536,7 @@
           <p:cNvPr id="3" name="Content Placeholder 2">
             <a:extLst>
               <a:ext uri="{FF2B5EF4-FFF2-40B4-BE49-F238E27FC236}">
-                <a16:creationId xmlns:a16="http://schemas.microsoft.com/office/drawing/2014/main" id="{52BC44A8-27EC-6F7D-AE00-B1D2AC1A423D}"/>
+                <a16:creationId xmlns:a16="http://schemas.microsoft.com/office/drawing/2014/main" id="{E101E67F-7F3D-9681-331A-C4991789295D}"/>
               </a:ext>
             </a:extLst>
           </p:cNvPr>
@@ -9508,52 +9552,68 @@
           <a:bodyPr/>
           <a:lstStyle/>
           <a:p>
-            <a:r>
-              <a:rPr lang="en-US" dirty="0"/>
-              <a:t>Ada</a:t>
-            </a:r>
-          </a:p>
-          <a:p>
-            <a:pPr lvl="1"/>
-            <a:r>
-              <a:rPr lang="en-US" dirty="0"/>
-              <a:t>Main contribution is its philosophy, instead of language features</a:t>
-            </a:r>
-          </a:p>
-          <a:p>
-            <a:r>
-              <a:rPr lang="en-US" dirty="0"/>
-              <a:t>Object-Oriented programming</a:t>
-            </a:r>
-          </a:p>
-          <a:p>
-            <a:pPr lvl="1"/>
+            <a:pPr marL="0" indent="0">
+              <a:buNone/>
+            </a:pPr>
+            <a:r>
+              <a:rPr lang="en-US" dirty="0"/>
+              <a:t>Most of the big productivity gains in the past solved accidental problems.</a:t>
+            </a:r>
+          </a:p>
+          <a:p>
+            <a:pPr marL="0" indent="0">
+              <a:buNone/>
+            </a:pPr>
             <a:endParaRPr lang="en-US" dirty="0"/>
           </a:p>
           <a:p>
-            <a:r>
-              <a:rPr lang="en-US" dirty="0"/>
-              <a:t>AI</a:t>
-            </a:r>
-          </a:p>
-          <a:p>
+            <a:pPr>
+              <a:buFont typeface="Arial" panose="020B0604020202020204" pitchFamily="34" charset="0"/>
+              <a:buChar char="•"/>
+            </a:pPr>
+            <a:r>
+              <a:rPr lang="en-US" b="1" dirty="0"/>
+              <a:t>High-level languages:</a:t>
+            </a:r>
+            <a:r>
+              <a:rPr lang="en-US" dirty="0"/>
+              <a:t> Eliminated the complexity of writing machine-level code.</a:t>
+            </a:r>
+          </a:p>
+          <a:p>
+            <a:pPr>
+              <a:buFont typeface="Arial" panose="020B0604020202020204" pitchFamily="34" charset="0"/>
+              <a:buChar char="•"/>
+            </a:pPr>
+            <a:r>
+              <a:rPr lang="en-US" b="1" dirty="0"/>
+              <a:t>Time-sharing:</a:t>
+            </a:r>
+            <a:r>
+              <a:rPr lang="en-US" dirty="0"/>
+              <a:t> Reduced slow turnaround times.</a:t>
+            </a:r>
+          </a:p>
+          <a:p>
+            <a:pPr>
+              <a:buFont typeface="Arial" panose="020B0604020202020204" pitchFamily="34" charset="0"/>
+              <a:buChar char="•"/>
+            </a:pPr>
+            <a:r>
+              <a:rPr lang="en-US" b="1" dirty="0"/>
+              <a:t>Unified programming environments:</a:t>
+            </a:r>
+            <a:r>
+              <a:rPr lang="en-US" dirty="0"/>
+              <a:t> Improved the way programs work together.</a:t>
+            </a:r>
+          </a:p>
+          <a:p>
+            <a:pPr marL="0" indent="0">
+              <a:buNone/>
+            </a:pPr>
             <a:endParaRPr lang="en-US" dirty="0"/>
           </a:p>
-          <a:p>
-            <a:r>
-              <a:rPr lang="en-US" dirty="0"/>
-              <a:t>Automated programming</a:t>
-            </a:r>
-          </a:p>
-          <a:p>
-            <a:endParaRPr lang="en-US" dirty="0"/>
-          </a:p>
-          <a:p>
-            <a:r>
-              <a:rPr lang="en-US" dirty="0"/>
-              <a:t>Program verification</a:t>
-            </a:r>
-          </a:p>
         </p:txBody>
       </p:sp>
       <p:sp>
@@ -9561,7 +9621,7 @@
           <p:cNvPr id="4" name="Slide Number Placeholder 3">
             <a:extLst>
               <a:ext uri="{FF2B5EF4-FFF2-40B4-BE49-F238E27FC236}">
-                <a16:creationId xmlns:a16="http://schemas.microsoft.com/office/drawing/2014/main" id="{3F9E9420-96E9-A534-F63F-5FBAD2B88600}"/>
+                <a16:creationId xmlns:a16="http://schemas.microsoft.com/office/drawing/2014/main" id="{B41DAB98-3AAE-42E5-3150-DD60A12180B0}"/>
               </a:ext>
             </a:extLst>
           </p:cNvPr>
@@ -9588,7 +9648,7 @@
     </p:spTree>
     <p:extLst>
       <p:ext uri="{BB962C8B-B14F-4D97-AF65-F5344CB8AC3E}">
-        <p14:creationId xmlns:p14="http://schemas.microsoft.com/office/powerpoint/2010/main" val="2596271236"/>
+        <p14:creationId xmlns:p14="http://schemas.microsoft.com/office/powerpoint/2010/main" val="579760326"/>
       </p:ext>
     </p:extLst>
   </p:cSld>
@@ -9620,7 +9680,7 @@
           <p:cNvPr id="2" name="Title 1">
             <a:extLst>
               <a:ext uri="{FF2B5EF4-FFF2-40B4-BE49-F238E27FC236}">
-                <a16:creationId xmlns:a16="http://schemas.microsoft.com/office/drawing/2014/main" id="{D57D02C6-FC30-283D-C19E-5B6D236792D3}"/>
+                <a16:creationId xmlns:a16="http://schemas.microsoft.com/office/drawing/2014/main" id="{1CBF31AE-A851-A9F1-84C9-7C598CD7DAAC}"/>
               </a:ext>
             </a:extLst>
           </p:cNvPr>
@@ -9637,12 +9697,8 @@
           <a:lstStyle/>
           <a:p>
             <a:r>
-              <a:rPr lang="en-US" dirty="0" err="1"/>
-              <a:t>Brooks's</a:t>
-            </a:r>
-            <a:r>
-              <a:rPr lang="en-US" dirty="0"/>
-              <a:t> Core Recommendations</a:t>
+              <a:rPr lang="en-US" dirty="0"/>
+              <a:t>New Hopes</a:t>
             </a:r>
           </a:p>
         </p:txBody>
@@ -9652,7 +9708,7 @@
           <p:cNvPr id="3" name="Content Placeholder 2">
             <a:extLst>
               <a:ext uri="{FF2B5EF4-FFF2-40B4-BE49-F238E27FC236}">
-                <a16:creationId xmlns:a16="http://schemas.microsoft.com/office/drawing/2014/main" id="{C0EFF6ED-1133-3903-235E-64214D771464}"/>
+                <a16:creationId xmlns:a16="http://schemas.microsoft.com/office/drawing/2014/main" id="{52BC44A8-27EC-6F7D-AE00-B1D2AC1A423D}"/>
               </a:ext>
             </a:extLst>
           </p:cNvPr>
@@ -9669,42 +9725,49 @@
           <a:lstStyle/>
           <a:p>
             <a:r>
-              <a:rPr lang="en-US" b="1" dirty="0"/>
-              <a:t>Buy vs. Build:</a:t>
-            </a:r>
-            <a:r>
-              <a:rPr lang="en-US" dirty="0"/>
-              <a:t> Exploit the mass market and avoid creating what you can buy.</a:t>
-            </a:r>
-          </a:p>
-          <a:p>
-            <a:r>
-              <a:rPr lang="en-US" b="1" dirty="0"/>
-              <a:t>Rapid Prototyping:</a:t>
-            </a:r>
-            <a:r>
-              <a:rPr lang="en-US" dirty="0"/>
-              <a:t> Use prototypes to refine requirements iteratively.</a:t>
-            </a:r>
-          </a:p>
-          <a:p>
-            <a:r>
-              <a:rPr lang="en-US" b="1" dirty="0"/>
-              <a:t>Incremental Development:</a:t>
-            </a:r>
-            <a:r>
-              <a:rPr lang="en-US" dirty="0"/>
-              <a:t> "Grow" software piece by piece, rather than trying to build it all at once.</a:t>
-            </a:r>
-          </a:p>
-          <a:p>
-            <a:r>
-              <a:rPr lang="en-US" b="1" dirty="0"/>
-              <a:t>Great Designers:</a:t>
-            </a:r>
-            <a:r>
-              <a:rPr lang="en-US" dirty="0"/>
-              <a:t> Acknowledge and nurture the exceptional people who produce great designs.</a:t>
+              <a:rPr lang="en-US" dirty="0"/>
+              <a:t>Ada</a:t>
+            </a:r>
+          </a:p>
+          <a:p>
+            <a:pPr lvl="1"/>
+            <a:r>
+              <a:rPr lang="en-US" dirty="0"/>
+              <a:t>Main contribution is its philosophy, instead of language features</a:t>
+            </a:r>
+          </a:p>
+          <a:p>
+            <a:r>
+              <a:rPr lang="en-US" dirty="0"/>
+              <a:t>Object-Oriented programming</a:t>
+            </a:r>
+          </a:p>
+          <a:p>
+            <a:pPr lvl="1"/>
+            <a:endParaRPr lang="en-US" dirty="0"/>
+          </a:p>
+          <a:p>
+            <a:r>
+              <a:rPr lang="en-US" dirty="0"/>
+              <a:t>AI</a:t>
+            </a:r>
+          </a:p>
+          <a:p>
+            <a:endParaRPr lang="en-US" dirty="0"/>
+          </a:p>
+          <a:p>
+            <a:r>
+              <a:rPr lang="en-US" dirty="0"/>
+              <a:t>Automated programming</a:t>
+            </a:r>
+          </a:p>
+          <a:p>
+            <a:endParaRPr lang="en-US" dirty="0"/>
+          </a:p>
+          <a:p>
+            <a:r>
+              <a:rPr lang="en-US" dirty="0"/>
+              <a:t>Program verification</a:t>
             </a:r>
           </a:p>
         </p:txBody>
@@ -9714,7 +9777,7 @@
           <p:cNvPr id="4" name="Slide Number Placeholder 3">
             <a:extLst>
               <a:ext uri="{FF2B5EF4-FFF2-40B4-BE49-F238E27FC236}">
-                <a16:creationId xmlns:a16="http://schemas.microsoft.com/office/drawing/2014/main" id="{CD163FCC-57BF-6DCB-3F71-2DC6A9C256AD}"/>
+                <a16:creationId xmlns:a16="http://schemas.microsoft.com/office/drawing/2014/main" id="{3F9E9420-96E9-A534-F63F-5FBAD2B88600}"/>
               </a:ext>
             </a:extLst>
           </p:cNvPr>
@@ -9741,7 +9804,7 @@
     </p:spTree>
     <p:extLst>
       <p:ext uri="{BB962C8B-B14F-4D97-AF65-F5344CB8AC3E}">
-        <p14:creationId xmlns:p14="http://schemas.microsoft.com/office/powerpoint/2010/main" val="1098065064"/>
+        <p14:creationId xmlns:p14="http://schemas.microsoft.com/office/powerpoint/2010/main" val="2596271236"/>
       </p:ext>
     </p:extLst>
   </p:cSld>
@@ -9773,7 +9836,7 @@
           <p:cNvPr id="2" name="Title 1">
             <a:extLst>
               <a:ext uri="{FF2B5EF4-FFF2-40B4-BE49-F238E27FC236}">
-                <a16:creationId xmlns:a16="http://schemas.microsoft.com/office/drawing/2014/main" id="{606A405C-F76A-61F4-8E8C-58C843DDD736}"/>
+                <a16:creationId xmlns:a16="http://schemas.microsoft.com/office/drawing/2014/main" id="{D57D02C6-FC30-283D-C19E-5B6D236792D3}"/>
               </a:ext>
             </a:extLst>
           </p:cNvPr>
@@ -9790,8 +9853,12 @@
           <a:lstStyle/>
           <a:p>
             <a:r>
-              <a:rPr lang="en-US" dirty="0"/>
-              <a:t>Final Takeaway</a:t>
+              <a:rPr lang="en-US" dirty="0" err="1"/>
+              <a:t>Brooks's</a:t>
+            </a:r>
+            <a:r>
+              <a:rPr lang="en-US" dirty="0"/>
+              <a:t> Core Recommendations</a:t>
             </a:r>
           </a:p>
         </p:txBody>
@@ -9801,7 +9868,7 @@
           <p:cNvPr id="3" name="Content Placeholder 2">
             <a:extLst>
               <a:ext uri="{FF2B5EF4-FFF2-40B4-BE49-F238E27FC236}">
-                <a16:creationId xmlns:a16="http://schemas.microsoft.com/office/drawing/2014/main" id="{5F590423-0721-6397-9F35-EBA20CEC9704}"/>
+                <a16:creationId xmlns:a16="http://schemas.microsoft.com/office/drawing/2014/main" id="{C0EFF6ED-1133-3903-235E-64214D771464}"/>
               </a:ext>
             </a:extLst>
           </p:cNvPr>
@@ -9818,24 +9885,43 @@
           <a:lstStyle/>
           <a:p>
             <a:r>
-              <a:rPr lang="en-US" dirty="0"/>
-              <a:t>There's no magic solution to the software crisis.</a:t>
-            </a:r>
-          </a:p>
-          <a:p>
-            <a:r>
-              <a:rPr lang="en-US" dirty="0"/>
-              <a:t>Instead of seeking a single fix, we must address the fundamental nature of software.</a:t>
-            </a:r>
-          </a:p>
-          <a:p>
-            <a:r>
-              <a:rPr lang="en-US" dirty="0"/>
-              <a:t>The road to better software is paved with small, disciplined steps and the cultivation of great talent.</a:t>
-            </a:r>
-          </a:p>
-          <a:p>
-            <a:endParaRPr lang="en-US" dirty="0"/>
+              <a:rPr lang="en-US" b="1" dirty="0"/>
+              <a:t>Buy vs. Build:</a:t>
+            </a:r>
+            <a:r>
+              <a:rPr lang="en-US" dirty="0"/>
+              <a:t> Exploit the mass market and avoid creating what you can buy.</a:t>
+            </a:r>
+          </a:p>
+          <a:p>
+            <a:r>
+              <a:rPr lang="en-US" b="1" dirty="0"/>
+              <a:t>Rapid Prototyping:</a:t>
+            </a:r>
+            <a:r>
+              <a:rPr lang="en-US" dirty="0"/>
+              <a:t> Use prototypes to refine requirements iteratively.</a:t>
+            </a:r>
+          </a:p>
+          <a:p>
+            <a:r>
+              <a:rPr lang="en-US" b="1" dirty="0"/>
+              <a:t>Incremental Development:</a:t>
+            </a:r>
+            <a:r>
+              <a:rPr lang="en-US" dirty="0"/>
+              <a:t> "Grow" software piece by piece, rather than trying to build it all at once.</a:t>
+            </a:r>
+          </a:p>
+          <a:p>
+            <a:r>
+              <a:rPr lang="en-US" b="1" dirty="0"/>
+              <a:t>Great Designers:</a:t>
+            </a:r>
+            <a:r>
+              <a:rPr lang="en-US" dirty="0"/>
+              <a:t> Acknowledge and nurture the exceptional people who produce great designs.</a:t>
+            </a:r>
           </a:p>
         </p:txBody>
       </p:sp>
@@ -9844,7 +9930,7 @@
           <p:cNvPr id="4" name="Slide Number Placeholder 3">
             <a:extLst>
               <a:ext uri="{FF2B5EF4-FFF2-40B4-BE49-F238E27FC236}">
-                <a16:creationId xmlns:a16="http://schemas.microsoft.com/office/drawing/2014/main" id="{5FDA1BA6-F94F-7A9B-42CD-9AE64BF0E3E1}"/>
+                <a16:creationId xmlns:a16="http://schemas.microsoft.com/office/drawing/2014/main" id="{CD163FCC-57BF-6DCB-3F71-2DC6A9C256AD}"/>
               </a:ext>
             </a:extLst>
           </p:cNvPr>
@@ -9871,7 +9957,7 @@
     </p:spTree>
     <p:extLst>
       <p:ext uri="{BB962C8B-B14F-4D97-AF65-F5344CB8AC3E}">
-        <p14:creationId xmlns:p14="http://schemas.microsoft.com/office/powerpoint/2010/main" val="3132436037"/>
+        <p14:creationId xmlns:p14="http://schemas.microsoft.com/office/powerpoint/2010/main" val="1098065064"/>
       </p:ext>
     </p:extLst>
   </p:cSld>
@@ -9903,7 +9989,7 @@
           <p:cNvPr id="2" name="Title 1">
             <a:extLst>
               <a:ext uri="{FF2B5EF4-FFF2-40B4-BE49-F238E27FC236}">
-                <a16:creationId xmlns:a16="http://schemas.microsoft.com/office/drawing/2014/main" id="{1351CCE4-A17A-54C7-791C-5EC433B09661}"/>
+                <a16:creationId xmlns:a16="http://schemas.microsoft.com/office/drawing/2014/main" id="{606A405C-F76A-61F4-8E8C-58C843DDD736}"/>
               </a:ext>
             </a:extLst>
           </p:cNvPr>
@@ -9921,7 +10007,7 @@
           <a:p>
             <a:r>
               <a:rPr lang="en-US" dirty="0"/>
-              <a:t>Backup slides</a:t>
+              <a:t>Final Takeaway</a:t>
             </a:r>
           </a:p>
         </p:txBody>
@@ -9931,7 +10017,7 @@
           <p:cNvPr id="3" name="Content Placeholder 2">
             <a:extLst>
               <a:ext uri="{FF2B5EF4-FFF2-40B4-BE49-F238E27FC236}">
-                <a16:creationId xmlns:a16="http://schemas.microsoft.com/office/drawing/2014/main" id="{DE136F43-A2D1-0ED3-CA49-35D8DE89FC44}"/>
+                <a16:creationId xmlns:a16="http://schemas.microsoft.com/office/drawing/2014/main" id="{5F590423-0721-6397-9F35-EBA20CEC9704}"/>
               </a:ext>
             </a:extLst>
           </p:cNvPr>
@@ -9947,7 +10033,25 @@
           <a:bodyPr/>
           <a:lstStyle/>
           <a:p>
-            <a:endParaRPr lang="en-US"/>
+            <a:r>
+              <a:rPr lang="en-US" dirty="0"/>
+              <a:t>There's no magic solution to the software crisis.</a:t>
+            </a:r>
+          </a:p>
+          <a:p>
+            <a:r>
+              <a:rPr lang="en-US" dirty="0"/>
+              <a:t>Instead of seeking a single fix, we must address the fundamental nature of software.</a:t>
+            </a:r>
+          </a:p>
+          <a:p>
+            <a:r>
+              <a:rPr lang="en-US" dirty="0"/>
+              <a:t>The road to better software is paved with small, disciplined steps and the cultivation of great talent.</a:t>
+            </a:r>
+          </a:p>
+          <a:p>
+            <a:endParaRPr lang="en-US" dirty="0"/>
           </a:p>
         </p:txBody>
       </p:sp>
@@ -9956,7 +10060,7 @@
           <p:cNvPr id="4" name="Slide Number Placeholder 3">
             <a:extLst>
               <a:ext uri="{FF2B5EF4-FFF2-40B4-BE49-F238E27FC236}">
-                <a16:creationId xmlns:a16="http://schemas.microsoft.com/office/drawing/2014/main" id="{EA9A51AD-DAB4-490B-61FD-4BAD314648C2}"/>
+                <a16:creationId xmlns:a16="http://schemas.microsoft.com/office/drawing/2014/main" id="{5FDA1BA6-F94F-7A9B-42CD-9AE64BF0E3E1}"/>
               </a:ext>
             </a:extLst>
           </p:cNvPr>
@@ -9975,6 +10079,118 @@
             <a:fld id="{3AB30462-0FD5-604F-8C98-DCC91BE84583}" type="slidenum">
               <a:rPr lang="en-US" smtClean="0"/>
               <a:t>38</a:t>
+            </a:fld>
+            <a:endParaRPr lang="en-US"/>
+          </a:p>
+        </p:txBody>
+      </p:sp>
+    </p:spTree>
+    <p:extLst>
+      <p:ext uri="{BB962C8B-B14F-4D97-AF65-F5344CB8AC3E}">
+        <p14:creationId xmlns:p14="http://schemas.microsoft.com/office/powerpoint/2010/main" val="3132436037"/>
+      </p:ext>
+    </p:extLst>
+  </p:cSld>
+  <p:clrMapOvr>
+    <a:masterClrMapping/>
+  </p:clrMapOvr>
+</p:sld>
+</file>
+
+<file path=ppt/slides/slide39.xml><?xml version="1.0" encoding="utf-8"?>
+<p:sld xmlns:a="http://schemas.openxmlformats.org/drawingml/2006/main" xmlns:r="http://schemas.openxmlformats.org/officeDocument/2006/relationships" xmlns:p="http://schemas.openxmlformats.org/presentationml/2006/main">
+  <p:cSld>
+    <p:spTree>
+      <p:nvGrpSpPr>
+        <p:cNvPr id="1" name=""/>
+        <p:cNvGrpSpPr/>
+        <p:nvPr/>
+      </p:nvGrpSpPr>
+      <p:grpSpPr>
+        <a:xfrm>
+          <a:off x="0" y="0"/>
+          <a:ext cx="0" cy="0"/>
+          <a:chOff x="0" y="0"/>
+          <a:chExt cx="0" cy="0"/>
+        </a:xfrm>
+      </p:grpSpPr>
+      <p:sp>
+        <p:nvSpPr>
+          <p:cNvPr id="2" name="Title 1">
+            <a:extLst>
+              <a:ext uri="{FF2B5EF4-FFF2-40B4-BE49-F238E27FC236}">
+                <a16:creationId xmlns:a16="http://schemas.microsoft.com/office/drawing/2014/main" id="{1351CCE4-A17A-54C7-791C-5EC433B09661}"/>
+              </a:ext>
+            </a:extLst>
+          </p:cNvPr>
+          <p:cNvSpPr>
+            <a:spLocks noGrp="1"/>
+          </p:cNvSpPr>
+          <p:nvPr>
+            <p:ph type="title"/>
+          </p:nvPr>
+        </p:nvSpPr>
+        <p:spPr/>
+        <p:txBody>
+          <a:bodyPr/>
+          <a:lstStyle/>
+          <a:p>
+            <a:r>
+              <a:rPr lang="en-US" dirty="0"/>
+              <a:t>Backup slides</a:t>
+            </a:r>
+          </a:p>
+        </p:txBody>
+      </p:sp>
+      <p:sp>
+        <p:nvSpPr>
+          <p:cNvPr id="3" name="Content Placeholder 2">
+            <a:extLst>
+              <a:ext uri="{FF2B5EF4-FFF2-40B4-BE49-F238E27FC236}">
+                <a16:creationId xmlns:a16="http://schemas.microsoft.com/office/drawing/2014/main" id="{DE136F43-A2D1-0ED3-CA49-35D8DE89FC44}"/>
+              </a:ext>
+            </a:extLst>
+          </p:cNvPr>
+          <p:cNvSpPr>
+            <a:spLocks noGrp="1"/>
+          </p:cNvSpPr>
+          <p:nvPr>
+            <p:ph idx="1"/>
+          </p:nvPr>
+        </p:nvSpPr>
+        <p:spPr/>
+        <p:txBody>
+          <a:bodyPr/>
+          <a:lstStyle/>
+          <a:p>
+            <a:endParaRPr lang="en-US"/>
+          </a:p>
+        </p:txBody>
+      </p:sp>
+      <p:sp>
+        <p:nvSpPr>
+          <p:cNvPr id="4" name="Slide Number Placeholder 3">
+            <a:extLst>
+              <a:ext uri="{FF2B5EF4-FFF2-40B4-BE49-F238E27FC236}">
+                <a16:creationId xmlns:a16="http://schemas.microsoft.com/office/drawing/2014/main" id="{EA9A51AD-DAB4-490B-61FD-4BAD314648C2}"/>
+              </a:ext>
+            </a:extLst>
+          </p:cNvPr>
+          <p:cNvSpPr>
+            <a:spLocks noGrp="1"/>
+          </p:cNvSpPr>
+          <p:nvPr>
+            <p:ph type="sldNum" sz="quarter" idx="12"/>
+          </p:nvPr>
+        </p:nvSpPr>
+        <p:spPr/>
+        <p:txBody>
+          <a:bodyPr/>
+          <a:lstStyle/>
+          <a:p>
+            <a:fld id="{3AB30462-0FD5-604F-8C98-DCC91BE84583}" type="slidenum">
+              <a:rPr lang="en-US" smtClean="0"/>
+              <a:t>39</a:t>
             </a:fld>
             <a:endParaRPr lang="en-US"/>
           </a:p>

</xml_diff>